<commit_message>
docs(concurso): revisión final contra TDR — nivel avanzado explícito + keywords del pliego
- README y planteamiento: tabla/sección 'Por qué Nivel Avanzado' mapeando
  la letra del TDR (agentes de IA para servicios públicos, IA generativa y
  sistemas conversacionales, modelos de lenguaje, arquitectura híbrida,
  Big Data, datos estructurados y no estructurados, automatización y
  despliegue funcional) con evidencia: 25.192 datasets ≫ 3-10 del
  intermedio; 29 variables curadas ≫ 10-20 del intermedio.
- Pitch (19 diapositivas): tarjeta '29 variables curadas por dataset',
  slide de IA re-titulada 'Un agente de IA para servicios públicos' con
  vocabulario del pliego, y slide nueva 'Nivel Avanzado, con la letra del
  pliego'. PDF re-exportado.
- Rezagos corregidos: cita del reto en glossary/BRAND/ADR-021, referencias
  a CHANGELOG.md (privado) y docs/accessibility.md (inexistente) en
  BRAND/ADR-012.

Co-Authored-By: Claude Fable 5 <noreply@anthropic.com>
</commit_message>
<xml_diff>
--- a/recursos/presentacion.pptx
+++ b/recursos/presentacion.pptx
@@ -23,6 +23,7 @@
     <p:sldId id="271" r:id="rId22"/>
     <p:sldId id="272" r:id="rId23"/>
     <p:sldId id="273" r:id="rId24"/>
+    <p:sldId id="274" r:id="rId25"/>
   </p:sldIdLst>
   <p:sldSz cx="12191695" cy="6858000" type="screen4x3"/>
   <p:notesSz cx="6858000" cy="9144000"/>
@@ -3340,7 +3341,7 @@
                 </a:solidFill>
                 <a:latin typeface="IBM Plex Mono"/>
               </a:rPr>
-              <a:t>POR QUÉ DATOSVIVOS</a:t>
+              <a:t>CUMPLIMIENTO DEL TDR</a:t>
             </a:r>
           </a:p>
           <a:p/>
@@ -3357,7 +3358,7 @@
                 </a:solidFill>
                 <a:latin typeface="Nunito Sans"/>
               </a:rPr>
-              <a:t>Lo que nadie más hace</a:t>
+              <a:t>Nivel Avanzado, con la letra del pliego</a:t>
             </a:r>
           </a:p>
         </p:txBody>
@@ -3370,8 +3371,8 @@
         </p:nvSpPr>
         <p:spPr>
           <a:xfrm>
-            <a:off x="594360" y="1828800"/>
-            <a:ext cx="10972800" cy="4297680"/>
+            <a:off x="594360" y="1783080"/>
+            <a:ext cx="10972800" cy="4389120"/>
           </a:xfrm>
           <a:prstGeom prst="rect">
             <a:avLst/>
@@ -3386,162 +3387,194 @@
           <a:p>
             <a:pPr algn="l">
               <a:spcAft>
-                <a:spcPts val="200"/>
-              </a:spcAft>
-            </a:pPr>
-            <a:r>
-              <a:rPr sz="1700" b="1">
+                <a:spcPts val="100"/>
+              </a:spcAft>
+            </a:pPr>
+            <a:r>
+              <a:rPr sz="1500" b="1">
                 <a:solidFill>
                   <a:srgbClr val="004884"/>
                 </a:solidFill>
                 <a:latin typeface="Nunito Sans"/>
               </a:rPr>
-              <a:t>Integra los portales federados</a:t>
+              <a:t>Agentes de IA para servicios públicos</a:t>
             </a:r>
           </a:p>
           <a:p/>
           <a:p>
             <a:pPr algn="l">
               <a:spcAft>
-                <a:spcPts val="1000"/>
-              </a:spcAft>
-            </a:pPr>
-            <a:r>
-              <a:rPr sz="1500" b="0">
-                <a:solidFill>
-                  <a:srgbClr val="202124"/>
-                </a:solidFill>
-                <a:latin typeface="Nunito Sans"/>
-              </a:rPr>
-              <a:t>datos.gov.co + IGAC + Bogotá + Cali + Medellín + Valle en un catálogo comparable. Hoy, eso exige revisar sitio por sitio.</a:t>
-            </a:r>
-          </a:p>
-          <a:p>
-            <a:pPr algn="l">
-              <a:spcAft>
-                <a:spcPts val="200"/>
-              </a:spcAft>
-            </a:pPr>
-            <a:r>
-              <a:rPr sz="1700" b="1">
+                <a:spcPts val="800"/>
+              </a:spcAft>
+            </a:pPr>
+            <a:r>
+              <a:rPr sz="1300" b="0">
+                <a:solidFill>
+                  <a:srgbClr val="202124"/>
+                </a:solidFill>
+                <a:latin typeface="Nunito Sans"/>
+              </a:rPr>
+              <a:t>el agente consulta y procesa datos abiertos de manera automática para responder solicitudes ciudadanas.</a:t>
+            </a:r>
+          </a:p>
+          <a:p>
+            <a:pPr algn="l">
+              <a:spcAft>
+                <a:spcPts val="100"/>
+              </a:spcAft>
+            </a:pPr>
+            <a:r>
+              <a:rPr sz="1500" b="1">
                 <a:solidFill>
                   <a:srgbClr val="004884"/>
                 </a:solidFill>
                 <a:latin typeface="Nunito Sans"/>
               </a:rPr>
-              <a:t>Se actualiza solo</a:t>
-            </a:r>
-          </a:p>
-          <a:p>
-            <a:pPr algn="l">
-              <a:spcAft>
-                <a:spcPts val="1000"/>
-              </a:spcAft>
-            </a:pPr>
-            <a:r>
-              <a:rPr sz="1500" b="0">
-                <a:solidFill>
-                  <a:srgbClr val="202124"/>
-                </a:solidFill>
-                <a:latin typeface="Nunito Sans"/>
-              </a:rPr>
-              <a:t>panorama diario automático — no es un informe: es infraestructura viva.</a:t>
-            </a:r>
-          </a:p>
-          <a:p>
-            <a:pPr algn="l">
-              <a:spcAft>
-                <a:spcPts val="200"/>
-              </a:spcAft>
-            </a:pPr>
-            <a:r>
-              <a:rPr sz="1700" b="1">
+              <a:t>IA generativa y sistemas conversacionales</a:t>
+            </a:r>
+          </a:p>
+          <a:p>
+            <a:pPr algn="l">
+              <a:spcAft>
+                <a:spcPts val="800"/>
+              </a:spcAft>
+            </a:pPr>
+            <a:r>
+              <a:rPr sz="1300" b="0">
+                <a:solidFill>
+                  <a:srgbClr val="202124"/>
+                </a:solidFill>
+                <a:latin typeface="Nunito Sans"/>
+              </a:rPr>
+              <a:t>buscador conversacional basado en datos abiertos: NL2SQL / Text-to-SQL generativo verificado.</a:t>
+            </a:r>
+          </a:p>
+          <a:p>
+            <a:pPr algn="l">
+              <a:spcAft>
+                <a:spcPts val="100"/>
+              </a:spcAft>
+            </a:pPr>
+            <a:r>
+              <a:rPr sz="1500" b="1">
                 <a:solidFill>
                   <a:srgbClr val="004884"/>
                 </a:solidFill>
                 <a:latin typeface="Nunito Sans"/>
               </a:rPr>
-              <a:t>Verificable de punta a punta</a:t>
-            </a:r>
-          </a:p>
-          <a:p>
-            <a:pPr algn="l">
-              <a:spcAft>
-                <a:spcPts val="1000"/>
-              </a:spcAft>
-            </a:pPr>
-            <a:r>
-              <a:rPr sz="1500" b="0">
-                <a:solidFill>
-                  <a:srgbClr val="202124"/>
-                </a:solidFill>
-                <a:latin typeface="Nunito Sans"/>
-              </a:rPr>
-              <a:t>cada cifra con fuente citada; API pública para auditar los números del sitio; repo abierto y replicable.</a:t>
-            </a:r>
-          </a:p>
-          <a:p>
-            <a:pPr algn="l">
-              <a:spcAft>
-                <a:spcPts val="200"/>
-              </a:spcAft>
-            </a:pPr>
-            <a:r>
-              <a:rPr sz="1700" b="1">
+              <a:t>Modelos de lenguaje + arquitectura híbrida</a:t>
+            </a:r>
+          </a:p>
+          <a:p>
+            <a:pPr algn="l">
+              <a:spcAft>
+                <a:spcPts val="800"/>
+              </a:spcAft>
+            </a:pPr>
+            <a:r>
+              <a:rPr sz="1300" b="0">
+                <a:solidFill>
+                  <a:srgbClr val="202124"/>
+                </a:solidFill>
+                <a:latin typeface="Nunito Sans"/>
+              </a:rPr>
+              <a:t>el LLM razona, el motor determinista verifica (3 capas) — con embeddings neuronales de retrieval.</a:t>
+            </a:r>
+          </a:p>
+          <a:p>
+            <a:pPr algn="l">
+              <a:spcAft>
+                <a:spcPts val="100"/>
+              </a:spcAft>
+            </a:pPr>
+            <a:r>
+              <a:rPr sz="1500" b="1">
                 <a:solidFill>
                   <a:srgbClr val="004884"/>
                 </a:solidFill>
                 <a:latin typeface="Nunito Sans"/>
               </a:rPr>
-              <a:t>Interoperable por estándar</a:t>
-            </a:r>
-          </a:p>
-          <a:p>
-            <a:pPr algn="l">
-              <a:spcAft>
-                <a:spcPts val="1000"/>
-              </a:spcAft>
-            </a:pPr>
-            <a:r>
-              <a:rPr sz="1500" b="0">
-                <a:solidFill>
-                  <a:srgbClr val="202124"/>
-                </a:solidFill>
-                <a:latin typeface="Nunito Sans"/>
-              </a:rPr>
-              <a:t>MCP server: cualquier agente de IA puede consultar el catálogo colombiano.</a:t>
-            </a:r>
-          </a:p>
-          <a:p>
-            <a:pPr algn="l">
-              <a:spcAft>
-                <a:spcPts val="200"/>
-              </a:spcAft>
-            </a:pPr>
-            <a:r>
-              <a:rPr sz="1700" b="1">
+              <a:t>Integración de grandes volúmenes</a:t>
+            </a:r>
+          </a:p>
+          <a:p>
+            <a:pPr algn="l">
+              <a:spcAft>
+                <a:spcPts val="800"/>
+              </a:spcAft>
+            </a:pPr>
+            <a:r>
+              <a:rPr sz="1300" b="0">
+                <a:solidFill>
+                  <a:srgbClr val="202124"/>
+                </a:solidFill>
+                <a:latin typeface="Nunito Sans"/>
+              </a:rPr>
+              <a:t>25.192 datasets de 6 fuentes y 3 protocolos — muy por encima de los 3-10 conjuntos del nivel intermedio.</a:t>
+            </a:r>
+          </a:p>
+          <a:p>
+            <a:pPr algn="l">
+              <a:spcAft>
+                <a:spcPts val="100"/>
+              </a:spcAft>
+            </a:pPr>
+            <a:r>
+              <a:rPr sz="1500" b="1">
                 <a:solidFill>
                   <a:srgbClr val="004884"/>
                 </a:solidFill>
                 <a:latin typeface="Nunito Sans"/>
               </a:rPr>
-              <a:t>Accesible e institucional</a:t>
-            </a:r>
-          </a:p>
-          <a:p>
-            <a:pPr algn="l">
-              <a:spcAft>
-                <a:spcPts val="1000"/>
-              </a:spcAft>
-            </a:pPr>
-            <a:r>
-              <a:rPr sz="1500" b="0">
-                <a:solidFill>
-                  <a:srgbClr val="202124"/>
-                </a:solidFill>
-                <a:latin typeface="Nunito Sans"/>
-              </a:rPr>
-              <a:t>identidad gov.co, voz y narración (Ley 1618), sin registro y sin rastreadores.</a:t>
+              <a:t>Datos estructurados y no estructurados</a:t>
+            </a:r>
+          </a:p>
+          <a:p>
+            <a:pPr algn="l">
+              <a:spcAft>
+                <a:spcPts val="800"/>
+              </a:spcAft>
+            </a:pPr>
+            <a:r>
+              <a:rPr sz="1300" b="0">
+                <a:solidFill>
+                  <a:srgbClr val="202124"/>
+                </a:solidFill>
+                <a:latin typeface="Nunito Sans"/>
+              </a:rPr>
+              <a:t>metadata estructurada + texto libre procesado con embeddings; 29 variables curadas por dataset (el intermedio pide 10-20).</a:t>
+            </a:r>
+          </a:p>
+          <a:p>
+            <a:pPr algn="l">
+              <a:spcAft>
+                <a:spcPts val="100"/>
+              </a:spcAft>
+            </a:pPr>
+            <a:r>
+              <a:rPr sz="1500" b="1">
+                <a:solidFill>
+                  <a:srgbClr val="004884"/>
+                </a:solidFill>
+                <a:latin typeface="Nunito Sans"/>
+              </a:rPr>
+              <a:t>Automatización, escalabilidad y despliegue funcional</a:t>
+            </a:r>
+          </a:p>
+          <a:p>
+            <a:pPr algn="l">
+              <a:spcAft>
+                <a:spcPts val="800"/>
+              </a:spcAft>
+            </a:pPr>
+            <a:r>
+              <a:rPr sz="1300" b="0">
+                <a:solidFill>
+                  <a:srgbClr val="202124"/>
+                </a:solidFill>
+                <a:latin typeface="Nunito Sans"/>
+              </a:rPr>
+              <a:t>actualización diaria automática y solución EN PRODUCCIÓN: datosvivos.co.</a:t>
             </a:r>
           </a:p>
         </p:txBody>
@@ -3645,6 +3678,311 @@
                 </a:solidFill>
                 <a:latin typeface="IBM Plex Mono"/>
               </a:rPr>
+              <a:t>POR QUÉ DATOSVIVOS</a:t>
+            </a:r>
+          </a:p>
+          <a:p/>
+          <a:p>
+            <a:pPr algn="l">
+              <a:spcAft>
+                <a:spcPts val="0"/>
+              </a:spcAft>
+            </a:pPr>
+            <a:r>
+              <a:rPr sz="3200" b="1">
+                <a:solidFill>
+                  <a:srgbClr val="202124"/>
+                </a:solidFill>
+                <a:latin typeface="Nunito Sans"/>
+              </a:rPr>
+              <a:t>Lo que nadie más hace</a:t>
+            </a:r>
+          </a:p>
+        </p:txBody>
+      </p:sp>
+      <p:sp>
+        <p:nvSpPr>
+          <p:cNvPr id="3" name="TextBox 2"/>
+          <p:cNvSpPr txBox="1"/>
+          <p:nvPr/>
+        </p:nvSpPr>
+        <p:spPr>
+          <a:xfrm>
+            <a:off x="594360" y="1828800"/>
+            <a:ext cx="10972800" cy="4297680"/>
+          </a:xfrm>
+          <a:prstGeom prst="rect">
+            <a:avLst/>
+          </a:prstGeom>
+          <a:noFill/>
+        </p:spPr>
+        <p:txBody>
+          <a:bodyPr wrap="square">
+            <a:spAutoFit/>
+          </a:bodyPr>
+          <a:lstStyle/>
+          <a:p>
+            <a:pPr algn="l">
+              <a:spcAft>
+                <a:spcPts val="200"/>
+              </a:spcAft>
+            </a:pPr>
+            <a:r>
+              <a:rPr sz="1700" b="1">
+                <a:solidFill>
+                  <a:srgbClr val="004884"/>
+                </a:solidFill>
+                <a:latin typeface="Nunito Sans"/>
+              </a:rPr>
+              <a:t>Integra los portales federados</a:t>
+            </a:r>
+          </a:p>
+          <a:p/>
+          <a:p>
+            <a:pPr algn="l">
+              <a:spcAft>
+                <a:spcPts val="1000"/>
+              </a:spcAft>
+            </a:pPr>
+            <a:r>
+              <a:rPr sz="1500" b="0">
+                <a:solidFill>
+                  <a:srgbClr val="202124"/>
+                </a:solidFill>
+                <a:latin typeface="Nunito Sans"/>
+              </a:rPr>
+              <a:t>datos.gov.co + IGAC + Bogotá + Cali + Medellín + Valle en un catálogo comparable. Hoy, eso exige revisar sitio por sitio.</a:t>
+            </a:r>
+          </a:p>
+          <a:p>
+            <a:pPr algn="l">
+              <a:spcAft>
+                <a:spcPts val="200"/>
+              </a:spcAft>
+            </a:pPr>
+            <a:r>
+              <a:rPr sz="1700" b="1">
+                <a:solidFill>
+                  <a:srgbClr val="004884"/>
+                </a:solidFill>
+                <a:latin typeface="Nunito Sans"/>
+              </a:rPr>
+              <a:t>Se actualiza solo</a:t>
+            </a:r>
+          </a:p>
+          <a:p>
+            <a:pPr algn="l">
+              <a:spcAft>
+                <a:spcPts val="1000"/>
+              </a:spcAft>
+            </a:pPr>
+            <a:r>
+              <a:rPr sz="1500" b="0">
+                <a:solidFill>
+                  <a:srgbClr val="202124"/>
+                </a:solidFill>
+                <a:latin typeface="Nunito Sans"/>
+              </a:rPr>
+              <a:t>panorama diario automático — no es un informe: es infraestructura viva.</a:t>
+            </a:r>
+          </a:p>
+          <a:p>
+            <a:pPr algn="l">
+              <a:spcAft>
+                <a:spcPts val="200"/>
+              </a:spcAft>
+            </a:pPr>
+            <a:r>
+              <a:rPr sz="1700" b="1">
+                <a:solidFill>
+                  <a:srgbClr val="004884"/>
+                </a:solidFill>
+                <a:latin typeface="Nunito Sans"/>
+              </a:rPr>
+              <a:t>Verificable de punta a punta</a:t>
+            </a:r>
+          </a:p>
+          <a:p>
+            <a:pPr algn="l">
+              <a:spcAft>
+                <a:spcPts val="1000"/>
+              </a:spcAft>
+            </a:pPr>
+            <a:r>
+              <a:rPr sz="1500" b="0">
+                <a:solidFill>
+                  <a:srgbClr val="202124"/>
+                </a:solidFill>
+                <a:latin typeface="Nunito Sans"/>
+              </a:rPr>
+              <a:t>cada cifra con fuente citada; API pública para auditar los números del sitio; repo abierto y replicable.</a:t>
+            </a:r>
+          </a:p>
+          <a:p>
+            <a:pPr algn="l">
+              <a:spcAft>
+                <a:spcPts val="200"/>
+              </a:spcAft>
+            </a:pPr>
+            <a:r>
+              <a:rPr sz="1700" b="1">
+                <a:solidFill>
+                  <a:srgbClr val="004884"/>
+                </a:solidFill>
+                <a:latin typeface="Nunito Sans"/>
+              </a:rPr>
+              <a:t>Interoperable por estándar</a:t>
+            </a:r>
+          </a:p>
+          <a:p>
+            <a:pPr algn="l">
+              <a:spcAft>
+                <a:spcPts val="1000"/>
+              </a:spcAft>
+            </a:pPr>
+            <a:r>
+              <a:rPr sz="1500" b="0">
+                <a:solidFill>
+                  <a:srgbClr val="202124"/>
+                </a:solidFill>
+                <a:latin typeface="Nunito Sans"/>
+              </a:rPr>
+              <a:t>MCP server: cualquier agente de IA puede consultar el catálogo colombiano.</a:t>
+            </a:r>
+          </a:p>
+          <a:p>
+            <a:pPr algn="l">
+              <a:spcAft>
+                <a:spcPts val="200"/>
+              </a:spcAft>
+            </a:pPr>
+            <a:r>
+              <a:rPr sz="1700" b="1">
+                <a:solidFill>
+                  <a:srgbClr val="004884"/>
+                </a:solidFill>
+                <a:latin typeface="Nunito Sans"/>
+              </a:rPr>
+              <a:t>Accesible e institucional</a:t>
+            </a:r>
+          </a:p>
+          <a:p>
+            <a:pPr algn="l">
+              <a:spcAft>
+                <a:spcPts val="1000"/>
+              </a:spcAft>
+            </a:pPr>
+            <a:r>
+              <a:rPr sz="1500" b="0">
+                <a:solidFill>
+                  <a:srgbClr val="202124"/>
+                </a:solidFill>
+                <a:latin typeface="Nunito Sans"/>
+              </a:rPr>
+              <a:t>identidad gov.co, voz y narración (Ley 1618), sin registro y sin rastreadores.</a:t>
+            </a:r>
+          </a:p>
+        </p:txBody>
+      </p:sp>
+      <p:sp>
+        <p:nvSpPr>
+          <p:cNvPr id="4" name="TextBox 3"/>
+          <p:cNvSpPr txBox="1"/>
+          <p:nvPr/>
+        </p:nvSpPr>
+        <p:spPr>
+          <a:xfrm>
+            <a:off x="457200" y="6446520"/>
+            <a:ext cx="11247120" cy="320040"/>
+          </a:xfrm>
+          <a:prstGeom prst="rect">
+            <a:avLst/>
+          </a:prstGeom>
+          <a:noFill/>
+        </p:spPr>
+        <p:txBody>
+          <a:bodyPr wrap="square">
+            <a:spAutoFit/>
+          </a:bodyPr>
+          <a:lstStyle/>
+          <a:p>
+            <a:pPr algn="l">
+              <a:spcAft>
+                <a:spcPts val="600"/>
+              </a:spcAft>
+            </a:pPr>
+            <a:r>
+              <a:rPr sz="900" b="0">
+                <a:solidFill>
+                  <a:srgbClr val="5F6368"/>
+                </a:solidFill>
+                <a:latin typeface="IBM Plex Mono"/>
+              </a:rPr>
+              <a:t>DatosVivos · datosvivos.co  —  Datos al Ecosistema 2026 · Equipo 93 · Reto 7 (id 102) · Nivel Avanzado        11</a:t>
+            </a:r>
+          </a:p>
+        </p:txBody>
+      </p:sp>
+    </p:spTree>
+  </p:cSld>
+  <p:clrMapOvr>
+    <a:masterClrMapping/>
+  </p:clrMapOvr>
+</p:sld>
+</file>
+
+<file path=ppt/slides/slide12.xml><?xml version="1.0" encoding="utf-8"?>
+<p:sld xmlns:a="http://schemas.openxmlformats.org/drawingml/2006/main" xmlns:p="http://schemas.openxmlformats.org/presentationml/2006/main" xmlns:r="http://schemas.openxmlformats.org/officeDocument/2006/relationships">
+  <p:cSld>
+    <p:bg>
+      <p:bgPr>
+        <a:solidFill>
+          <a:srgbClr val="FFFFFF"/>
+        </a:solidFill>
+        <a:effectLst/>
+      </p:bgPr>
+    </p:bg>
+    <p:spTree>
+      <p:nvGrpSpPr>
+        <p:cNvPr id="1" name=""/>
+        <p:cNvGrpSpPr/>
+        <p:nvPr/>
+      </p:nvGrpSpPr>
+      <p:grpSpPr/>
+      <p:sp>
+        <p:nvSpPr>
+          <p:cNvPr id="2" name="TextBox 1"/>
+          <p:cNvSpPr txBox="1"/>
+          <p:nvPr/>
+        </p:nvSpPr>
+        <p:spPr>
+          <a:xfrm>
+            <a:off x="548640" y="411480"/>
+            <a:ext cx="11064240" cy="1554480"/>
+          </a:xfrm>
+          <a:prstGeom prst="rect">
+            <a:avLst/>
+          </a:prstGeom>
+          <a:noFill/>
+        </p:spPr>
+        <p:txBody>
+          <a:bodyPr wrap="square">
+            <a:spAutoFit/>
+          </a:bodyPr>
+          <a:lstStyle/>
+          <a:p>
+            <a:pPr algn="l">
+              <a:spcAft>
+                <a:spcPts val="600"/>
+              </a:spcAft>
+            </a:pPr>
+            <a:r>
+              <a:rPr sz="1200" b="1">
+                <a:solidFill>
+                  <a:srgbClr val="3366CC"/>
+                </a:solidFill>
+                <a:latin typeface="IBM Plex Mono"/>
+              </a:rPr>
               <a:t>IMPACTO Y ESCALABILIDAD</a:t>
             </a:r>
           </a:p>
@@ -3941,7 +4279,7 @@
                 </a:solidFill>
                 <a:latin typeface="IBM Plex Mono"/>
               </a:rPr>
-              <a:t>DatosVivos · datosvivos.co  —  Datos al Ecosistema 2026 · Equipo 93 · Reto 7 (id 102) · Nivel Avanzado        11</a:t>
+              <a:t>DatosVivos · datosvivos.co  —  Datos al Ecosistema 2026 · Equipo 93 · Reto 7 (id 102) · Nivel Avanzado        12</a:t>
             </a:r>
           </a:p>
         </p:txBody>
@@ -3954,7 +4292,7 @@
 </p:sld>
 </file>
 
-<file path=ppt/slides/slide12.xml><?xml version="1.0" encoding="utf-8"?>
+<file path=ppt/slides/slide13.xml><?xml version="1.0" encoding="utf-8"?>
 <p:sld xmlns:a="http://schemas.openxmlformats.org/drawingml/2006/main" xmlns:p="http://schemas.openxmlformats.org/presentationml/2006/main" xmlns:r="http://schemas.openxmlformats.org/officeDocument/2006/relationships">
   <p:cSld>
     <p:bg>
@@ -4107,279 +4445,6 @@
               <a:rPr sz="900" b="0">
                 <a:solidFill>
                   <a:srgbClr val="FFFFFF"/>
-                </a:solidFill>
-                <a:latin typeface="IBM Plex Mono"/>
-              </a:rPr>
-              <a:t>DatosVivos · datosvivos.co  —  Datos al Ecosistema 2026 · Equipo 93 · Reto 7 (id 102) · Nivel Avanzado        12</a:t>
-            </a:r>
-          </a:p>
-        </p:txBody>
-      </p:sp>
-    </p:spTree>
-  </p:cSld>
-  <p:clrMapOvr>
-    <a:masterClrMapping/>
-  </p:clrMapOvr>
-</p:sld>
-</file>
-
-<file path=ppt/slides/slide13.xml><?xml version="1.0" encoding="utf-8"?>
-<p:sld xmlns:a="http://schemas.openxmlformats.org/drawingml/2006/main" xmlns:p="http://schemas.openxmlformats.org/presentationml/2006/main" xmlns:r="http://schemas.openxmlformats.org/officeDocument/2006/relationships">
-  <p:cSld>
-    <p:bg>
-      <p:bgPr>
-        <a:solidFill>
-          <a:srgbClr val="FFFFFF"/>
-        </a:solidFill>
-        <a:effectLst/>
-      </p:bgPr>
-    </p:bg>
-    <p:spTree>
-      <p:nvGrpSpPr>
-        <p:cNvPr id="1" name=""/>
-        <p:cNvGrpSpPr/>
-        <p:nvPr/>
-      </p:nvGrpSpPr>
-      <p:grpSpPr/>
-      <p:sp>
-        <p:nvSpPr>
-          <p:cNvPr id="2" name="TextBox 1"/>
-          <p:cNvSpPr txBox="1"/>
-          <p:nvPr/>
-        </p:nvSpPr>
-        <p:spPr>
-          <a:xfrm>
-            <a:off x="548640" y="411480"/>
-            <a:ext cx="11064240" cy="1554480"/>
-          </a:xfrm>
-          <a:prstGeom prst="rect">
-            <a:avLst/>
-          </a:prstGeom>
-          <a:noFill/>
-        </p:spPr>
-        <p:txBody>
-          <a:bodyPr wrap="square">
-            <a:spAutoFit/>
-          </a:bodyPr>
-          <a:lstStyle/>
-          <a:p>
-            <a:pPr algn="l">
-              <a:spcAft>
-                <a:spcPts val="600"/>
-              </a:spcAft>
-            </a:pPr>
-            <a:r>
-              <a:rPr sz="1200" b="1">
-                <a:solidFill>
-                  <a:srgbClr val="3366CC"/>
-                </a:solidFill>
-                <a:latin typeface="IBM Plex Mono"/>
-              </a:rPr>
-              <a:t>RESPALDO TÉCNICO · B1</a:t>
-            </a:r>
-          </a:p>
-          <a:p/>
-          <a:p>
-            <a:pPr algn="l">
-              <a:spcAft>
-                <a:spcPts val="0"/>
-              </a:spcAft>
-            </a:pPr>
-            <a:r>
-              <a:rPr sz="2800" b="1">
-                <a:solidFill>
-                  <a:srgbClr val="202124"/>
-                </a:solidFill>
-                <a:latin typeface="Nunito Sans"/>
-              </a:rPr>
-              <a:t>Arquitectura de 3 capas (fiel al plan inicial de inscripción)</a:t>
-            </a:r>
-          </a:p>
-        </p:txBody>
-      </p:sp>
-      <p:sp>
-        <p:nvSpPr>
-          <p:cNvPr id="3" name="TextBox 2"/>
-          <p:cNvSpPr txBox="1"/>
-          <p:nvPr/>
-        </p:nvSpPr>
-        <p:spPr>
-          <a:xfrm>
-            <a:off x="594360" y="1828800"/>
-            <a:ext cx="10972800" cy="4297680"/>
-          </a:xfrm>
-          <a:prstGeom prst="rect">
-            <a:avLst/>
-          </a:prstGeom>
-          <a:noFill/>
-        </p:spPr>
-        <p:txBody>
-          <a:bodyPr wrap="square">
-            <a:spAutoFit/>
-          </a:bodyPr>
-          <a:lstStyle/>
-          <a:p>
-            <a:pPr algn="l">
-              <a:spcAft>
-                <a:spcPts val="200"/>
-              </a:spcAft>
-            </a:pPr>
-            <a:r>
-              <a:rPr sz="1700" b="1">
-                <a:solidFill>
-                  <a:srgbClr val="004884"/>
-                </a:solidFill>
-                <a:latin typeface="Nunito Sans"/>
-              </a:rPr>
-              <a:t>Capa MCP</a:t>
-            </a:r>
-          </a:p>
-          <a:p/>
-          <a:p>
-            <a:pPr algn="l">
-              <a:spcAft>
-                <a:spcPts val="1000"/>
-              </a:spcAft>
-            </a:pPr>
-            <a:r>
-              <a:rPr sz="1500" b="0">
-                <a:solidFill>
-                  <a:srgbClr val="202124"/>
-                </a:solidFill>
-                <a:latin typeface="Nunito Sans"/>
-              </a:rPr>
-              <a:t>servidor MCP sobre las APIs Socrata de datos.gov.co (Discovery, SODA, Metadata) — search_datasets · get_metadata · query_data · cross_datasets.</a:t>
-            </a:r>
-          </a:p>
-          <a:p>
-            <a:pPr algn="l">
-              <a:spcAft>
-                <a:spcPts val="200"/>
-              </a:spcAft>
-            </a:pPr>
-            <a:r>
-              <a:rPr sz="1700" b="1">
-                <a:solidFill>
-                  <a:srgbClr val="004884"/>
-                </a:solidFill>
-                <a:latin typeface="Nunito Sans"/>
-              </a:rPr>
-              <a:t>Capa motor</a:t>
-            </a:r>
-          </a:p>
-          <a:p>
-            <a:pPr algn="l">
-              <a:spcAft>
-                <a:spcPts val="1000"/>
-              </a:spcAft>
-            </a:pPr>
-            <a:r>
-              <a:rPr sz="1500" b="0">
-                <a:solidFill>
-                  <a:srgbClr val="202124"/>
-                </a:solidFill>
-                <a:latin typeface="Nunito Sans"/>
-              </a:rPr>
-              <a:t>FastAPI + PostgreSQL (catálogo curado, vistas _decisor) + ChromaDB (retrieval) + DuckDB (federados con CSV externo) + backend LLM intercambiable (LLM_BACKEND = ollama | anthropic).</a:t>
-            </a:r>
-          </a:p>
-          <a:p>
-            <a:pPr algn="l">
-              <a:spcAft>
-                <a:spcPts val="200"/>
-              </a:spcAft>
-            </a:pPr>
-            <a:r>
-              <a:rPr sz="1700" b="1">
-                <a:solidFill>
-                  <a:srgbClr val="004884"/>
-                </a:solidFill>
-                <a:latin typeface="Nunito Sans"/>
-              </a:rPr>
-              <a:t>Capa presentación</a:t>
-            </a:r>
-          </a:p>
-          <a:p>
-            <a:pPr algn="l">
-              <a:spcAft>
-                <a:spcPts val="1000"/>
-              </a:spcAft>
-            </a:pPr>
-            <a:r>
-              <a:rPr sz="1500" b="0">
-                <a:solidFill>
-                  <a:srgbClr val="202124"/>
-                </a:solidFill>
-                <a:latin typeface="Nunito Sans"/>
-              </a:rPr>
-              <a:t>Next.js (panorama + buscador SSE) y Power BI (tablero publish-to-web sobre CSVs públicos de la API). Evolución documentada: Streamlit → Next.js (ADR-011).</a:t>
-            </a:r>
-          </a:p>
-          <a:p>
-            <a:pPr algn="l">
-              <a:spcAft>
-                <a:spcPts val="200"/>
-              </a:spcAft>
-            </a:pPr>
-            <a:r>
-              <a:rPr sz="1700" b="1">
-                <a:solidFill>
-                  <a:srgbClr val="004884"/>
-                </a:solidFill>
-                <a:latin typeface="Nunito Sans"/>
-              </a:rPr>
-              <a:t>Despliegue</a:t>
-            </a:r>
-          </a:p>
-          <a:p>
-            <a:pPr algn="l">
-              <a:spcAft>
-                <a:spcPts val="1000"/>
-              </a:spcAft>
-            </a:pPr>
-            <a:r>
-              <a:rPr sz="1500" b="0">
-                <a:solidFill>
-                  <a:srgbClr val="202124"/>
-                </a:solidFill>
-                <a:latin typeface="Nunito Sans"/>
-              </a:rPr>
-              <a:t>Docker Compose con imagen reproducible, túnel seguro de salida, cron de actualización diaria.</a:t>
-            </a:r>
-          </a:p>
-        </p:txBody>
-      </p:sp>
-      <p:sp>
-        <p:nvSpPr>
-          <p:cNvPr id="4" name="TextBox 3"/>
-          <p:cNvSpPr txBox="1"/>
-          <p:nvPr/>
-        </p:nvSpPr>
-        <p:spPr>
-          <a:xfrm>
-            <a:off x="457200" y="6446520"/>
-            <a:ext cx="11247120" cy="320040"/>
-          </a:xfrm>
-          <a:prstGeom prst="rect">
-            <a:avLst/>
-          </a:prstGeom>
-          <a:noFill/>
-        </p:spPr>
-        <p:txBody>
-          <a:bodyPr wrap="square">
-            <a:spAutoFit/>
-          </a:bodyPr>
-          <a:lstStyle/>
-          <a:p>
-            <a:pPr algn="l">
-              <a:spcAft>
-                <a:spcPts val="600"/>
-              </a:spcAft>
-            </a:pPr>
-            <a:r>
-              <a:rPr sz="900" b="0">
-                <a:solidFill>
-                  <a:srgbClr val="5F6368"/>
                 </a:solidFill>
                 <a:latin typeface="IBM Plex Mono"/>
               </a:rPr>
@@ -4448,7 +4513,7 @@
                 </a:solidFill>
                 <a:latin typeface="IBM Plex Mono"/>
               </a:rPr>
-              <a:t>RESPALDO TÉCNICO · B2</a:t>
+              <a:t>RESPALDO TÉCNICO · B1</a:t>
             </a:r>
           </a:p>
           <a:p/>
@@ -4465,7 +4530,7 @@
                 </a:solidFill>
                 <a:latin typeface="Nunito Sans"/>
               </a:rPr>
-              <a:t>Motor NL2SQL: generar no basta — hay que verificar</a:t>
+              <a:t>Arquitectura de 3 capas (fiel al plan inicial de inscripción)</a:t>
             </a:r>
           </a:p>
         </p:txBody>
@@ -4504,7 +4569,7 @@
                 </a:solidFill>
                 <a:latin typeface="Nunito Sans"/>
               </a:rPr>
-              <a:t>Capa 1 · Esquema real</a:t>
+              <a:t>Capa MCP</a:t>
             </a:r>
           </a:p>
           <a:p/>
@@ -4521,7 +4586,7 @@
                 </a:solidFill>
                 <a:latin typeface="Nunito Sans"/>
               </a:rPr>
-              <a:t>el LLM genera viendo SOLO columnas curadas reales del dataset (tipos semánticos: dimensión/métrica/fecha/geo). No puede alucinar columnas.</a:t>
+              <a:t>servidor MCP sobre las APIs Socrata de datos.gov.co (Discovery, SODA, Metadata) — search_datasets · get_metadata · query_data · cross_datasets.</a:t>
             </a:r>
           </a:p>
           <a:p>
@@ -4537,7 +4602,7 @@
                 </a:solidFill>
                 <a:latin typeface="Nunito Sans"/>
               </a:rPr>
-              <a:t>Capa 2 · Verificación estática</a:t>
+              <a:t>Capa motor</a:t>
             </a:r>
           </a:p>
           <a:p>
@@ -4553,7 +4618,7 @@
                 </a:solidFill>
                 <a:latin typeface="Nunito Sans"/>
               </a:rPr>
-              <a:t>código (no otro LLM) valida columnas, funciones permitidas, filtro territorial y solo-lectura ANTES de ejecutar.</a:t>
+              <a:t>FastAPI + PostgreSQL (catálogo curado, vistas _decisor) + ChromaDB (retrieval) + DuckDB (federados con CSV externo) + backend LLM intercambiable (LLM_BACKEND = ollama | anthropic).</a:t>
             </a:r>
           </a:p>
           <a:p>
@@ -4569,7 +4634,7 @@
                 </a:solidFill>
                 <a:latin typeface="Nunito Sans"/>
               </a:rPr>
-              <a:t>Capa 3 · Validación del resultado</a:t>
+              <a:t>Capa presentación</a:t>
             </a:r>
           </a:p>
           <a:p>
@@ -4585,7 +4650,7 @@
                 </a:solidFill>
                 <a:latin typeface="Nunito Sans"/>
               </a:rPr>
-              <a:t>toda cifra de la narrativa se contrasta contra la lista calculada de las filas; un número ajeno censura la oración.</a:t>
+              <a:t>Next.js (panorama + buscador SSE) y Power BI (tablero publish-to-web sobre CSVs públicos de la API). Evolución documentada: Streamlit → Next.js (ADR-011).</a:t>
             </a:r>
           </a:p>
           <a:p>
@@ -4601,7 +4666,7 @@
                 </a:solidFill>
                 <a:latin typeface="Nunito Sans"/>
               </a:rPr>
-              <a:t>Reparación y refusal</a:t>
+              <a:t>Despliegue</a:t>
             </a:r>
           </a:p>
           <a:p>
@@ -4617,39 +4682,7 @@
                 </a:solidFill>
                 <a:latin typeface="Nunito Sans"/>
               </a:rPr>
-              <a:t>si la verificación falla: ciclo de reparación acotado; si persiste, la respuesta se niega. Preferimos no responder a responder mal.</a:t>
-            </a:r>
-          </a:p>
-          <a:p>
-            <a:pPr algn="l">
-              <a:spcAft>
-                <a:spcPts val="200"/>
-              </a:spcAft>
-            </a:pPr>
-            <a:r>
-              <a:rPr sz="1700" b="1">
-                <a:solidFill>
-                  <a:srgbClr val="004884"/>
-                </a:solidFill>
-                <a:latin typeface="Nunito Sans"/>
-              </a:rPr>
-              <a:t>Respaldo determinista</a:t>
-            </a:r>
-          </a:p>
-          <a:p>
-            <a:pPr algn="l">
-              <a:spcAft>
-                <a:spcPts val="1000"/>
-              </a:spcAft>
-            </a:pPr>
-            <a:r>
-              <a:rPr sz="1500" b="0">
-                <a:solidFill>
-                  <a:srgbClr val="202124"/>
-                </a:solidFill>
-                <a:latin typeface="Nunito Sans"/>
-              </a:rPr>
-              <a:t>plantillas SoQL por tipo de pregunta (conteo/comparación/ranking/tendencia/mapa) como camino estructurado con chips.</a:t>
+              <a:t>Docker Compose con imagen reproducible, túnel seguro de salida, cron de actualización diaria.</a:t>
             </a:r>
           </a:p>
         </p:txBody>
@@ -4753,7 +4786,7 @@
                 </a:solidFill>
                 <a:latin typeface="IBM Plex Mono"/>
               </a:rPr>
-              <a:t>RESPALDO TÉCNICO · B3</a:t>
+              <a:t>RESPALDO TÉCNICO · B2</a:t>
             </a:r>
           </a:p>
           <a:p/>
@@ -4770,7 +4803,7 @@
                 </a:solidFill>
                 <a:latin typeface="Nunito Sans"/>
               </a:rPr>
-              <a:t>Modelo de datos: una vista curada como fuente única</a:t>
+              <a:t>Motor NL2SQL: generar no basta — hay que verificar</a:t>
             </a:r>
           </a:p>
         </p:txBody>
@@ -4809,7 +4842,7 @@
                 </a:solidFill>
                 <a:latin typeface="Nunito Sans"/>
               </a:rPr>
-              <a:t>datasets (42 columnas)</a:t>
+              <a:t>Capa 1 · Esquema real</a:t>
             </a:r>
           </a:p>
           <a:p/>
@@ -4826,7 +4859,7 @@
                 </a:solidFill>
                 <a:latin typeface="Nunito Sans"/>
               </a:rPr>
-              <a:t>una fila por dataset del catálogo integrado; upsert idempotente por dataset_id (auditado: 0 duplicados de clave).</a:t>
+              <a:t>el LLM genera viendo SOLO columnas curadas reales del dataset (tipos semánticos: dimensión/métrica/fecha/geo). No puede alucinar columnas.</a:t>
             </a:r>
           </a:p>
           <a:p>
@@ -4842,7 +4875,7 @@
                 </a:solidFill>
                 <a:latin typeface="Nunito Sans"/>
               </a:rPr>
-              <a:t>v_dataset_status_decisor (29 variables)</a:t>
+              <a:t>Capa 2 · Verificación estática</a:t>
             </a:r>
           </a:p>
           <a:p>
@@ -4858,7 +4891,7 @@
                 </a:solidFill>
                 <a:latin typeface="Nunito Sans"/>
               </a:rPr>
-              <a:t>la vista del decisor: identidad, semáforo de frescura, uso, acceso (directo/archivo/solo metadatos), territorio DIVIPOLA, calidad.</a:t>
+              <a:t>código (no otro LLM) valida columnas, funciones permitidas, filtro territorial y solo-lectura ANTES de ejecutar.</a:t>
             </a:r>
           </a:p>
           <a:p>
@@ -4874,7 +4907,7 @@
                 </a:solidFill>
                 <a:latin typeface="Nunito Sans"/>
               </a:rPr>
-              <a:t>v_entity_summary_decisor</a:t>
+              <a:t>Capa 3 · Validación del resultado</a:t>
             </a:r>
           </a:p>
           <a:p>
@@ -4890,7 +4923,7 @@
                 </a:solidFill>
                 <a:latin typeface="Nunito Sans"/>
               </a:rPr>
-              <a:t>agregado por entidad con pct_verdes: el indicador de cumplimiento listo para gestión.</a:t>
+              <a:t>toda cifra de la narrativa se contrasta contra la lista calculada de las filas; un número ajeno censura la oración.</a:t>
             </a:r>
           </a:p>
           <a:p>
@@ -4906,7 +4939,7 @@
                 </a:solidFill>
                 <a:latin typeface="Nunito Sans"/>
               </a:rPr>
-              <a:t>Una sola fuente de verdad</a:t>
+              <a:t>Reparación y refusal</a:t>
             </a:r>
           </a:p>
           <a:p>
@@ -4922,7 +4955,39 @@
                 </a:solidFill>
                 <a:latin typeface="Nunito Sans"/>
               </a:rPr>
-              <a:t>panorama web, tablero Power BI y CSVs públicos leen LA MISMA vista — imposible que se desalineen.</a:t>
+              <a:t>si la verificación falla: ciclo de reparación acotado; si persiste, la respuesta se niega. Preferimos no responder a responder mal.</a:t>
+            </a:r>
+          </a:p>
+          <a:p>
+            <a:pPr algn="l">
+              <a:spcAft>
+                <a:spcPts val="200"/>
+              </a:spcAft>
+            </a:pPr>
+            <a:r>
+              <a:rPr sz="1700" b="1">
+                <a:solidFill>
+                  <a:srgbClr val="004884"/>
+                </a:solidFill>
+                <a:latin typeface="Nunito Sans"/>
+              </a:rPr>
+              <a:t>Respaldo determinista</a:t>
+            </a:r>
+          </a:p>
+          <a:p>
+            <a:pPr algn="l">
+              <a:spcAft>
+                <a:spcPts val="1000"/>
+              </a:spcAft>
+            </a:pPr>
+            <a:r>
+              <a:rPr sz="1500" b="0">
+                <a:solidFill>
+                  <a:srgbClr val="202124"/>
+                </a:solidFill>
+                <a:latin typeface="Nunito Sans"/>
+              </a:rPr>
+              <a:t>plantillas SoQL por tipo de pregunta (conteo/comparación/ranking/tendencia/mapa) como camino estructurado con chips.</a:t>
             </a:r>
           </a:p>
         </p:txBody>
@@ -5026,7 +5091,7 @@
                 </a:solidFill>
                 <a:latin typeface="IBM Plex Mono"/>
               </a:rPr>
-              <a:t>RESPALDO TÉCNICO · B4</a:t>
+              <a:t>RESPALDO TÉCNICO · B3</a:t>
             </a:r>
           </a:p>
           <a:p/>
@@ -5043,7 +5108,7 @@
                 </a:solidFill>
                 <a:latin typeface="Nunito Sans"/>
               </a:rPr>
-              <a:t>Calidad de datos: medida, no declarada</a:t>
+              <a:t>Modelo de datos: una vista curada como fuente única</a:t>
             </a:r>
           </a:p>
         </p:txBody>
@@ -5082,7 +5147,7 @@
                 </a:solidFill>
                 <a:latin typeface="Nunito Sans"/>
               </a:rPr>
-              <a:t>Auditoría columna a columna</a:t>
+              <a:t>datasets (42 columnas)</a:t>
             </a:r>
           </a:p>
           <a:p/>
@@ -5099,7 +5164,7 @@
                 </a:solidFill>
                 <a:latin typeface="Nunito Sans"/>
               </a:rPr>
-              <a:t>17/18 columnas al 100 % de fidelidad contra la fuente Socrata (reportes versionados en eval/reports/).</a:t>
+              <a:t>una fila por dataset del catálogo integrado; upsert idempotente por dataset_id (auditado: 0 duplicados de clave).</a:t>
             </a:r>
           </a:p>
           <a:p>
@@ -5115,7 +5180,7 @@
                 </a:solidFill>
                 <a:latin typeface="Nunito Sans"/>
               </a:rPr>
-              <a:t>Clasificación continua</a:t>
+              <a:t>v_dataset_status_decisor (29 variables)</a:t>
             </a:r>
           </a:p>
           <a:p>
@@ -5131,7 +5196,7 @@
                 </a:solidFill>
                 <a:latin typeface="Nunito Sans"/>
               </a:rPr>
-              <a:t>los 2.996 reportes administrativos (Ley 1712) se separan de los datos temáticos automáticamente, en cada corrida del ETL.</a:t>
+              <a:t>la vista del decisor: identidad, semáforo de frescura, uso, acceso (directo/archivo/solo metadatos), territorio DIVIPOLA, calidad.</a:t>
             </a:r>
           </a:p>
           <a:p>
@@ -5147,7 +5212,7 @@
                 </a:solidFill>
                 <a:latin typeface="Nunito Sans"/>
               </a:rPr>
-              <a:t>Inferencia territorial</a:t>
+              <a:t>v_entity_summary_decisor</a:t>
             </a:r>
           </a:p>
           <a:p>
@@ -5163,7 +5228,7 @@
                 </a:solidFill>
                 <a:latin typeface="Nunito Sans"/>
               </a:rPr>
-              <a:t>códigos DIVIPOLA asignados por IA con confianza registrada (~89 % de cobertura del catálogo).</a:t>
+              <a:t>agregado por entidad con pct_verdes: el indicador de cumplimiento listo para gestión.</a:t>
             </a:r>
           </a:p>
           <a:p>
@@ -5179,7 +5244,7 @@
                 </a:solidFill>
                 <a:latin typeface="Nunito Sans"/>
               </a:rPr>
-              <a:t>Guardas anti-basura</a:t>
+              <a:t>Una sola fuente de verdad</a:t>
             </a:r>
           </a:p>
           <a:p>
@@ -5195,39 +5260,7 @@
                 </a:solidFill>
                 <a:latin typeface="Nunito Sans"/>
               </a:rPr>
-              <a:t>metadata placeholder sin diligenciar ({{name}}) se descarta en la ingesta; el catálogo no acumula ruido.</a:t>
-            </a:r>
-          </a:p>
-          <a:p>
-            <a:pPr algn="l">
-              <a:spcAft>
-                <a:spcPts val="200"/>
-              </a:spcAft>
-            </a:pPr>
-            <a:r>
-              <a:rPr sz="1700" b="1">
-                <a:solidFill>
-                  <a:srgbClr val="004884"/>
-                </a:solidFill>
-                <a:latin typeface="Nunito Sans"/>
-              </a:rPr>
-              <a:t>Atribución por origen</a:t>
-            </a:r>
-          </a:p>
-          <a:p>
-            <a:pPr algn="l">
-              <a:spcAft>
-                <a:spcPts val="1000"/>
-              </a:spcAft>
-            </a:pPr>
-            <a:r>
-              <a:rPr sz="1500" b="0">
-                <a:solidFill>
-                  <a:srgbClr val="202124"/>
-                </a:solidFill>
-                <a:latin typeface="Nunito Sans"/>
-              </a:rPr>
-              <a:t>cada dataset se atribuye al portal donde su entidad publica originalmente — incluso las copias federadas del solapamiento cross-portal.</a:t>
+              <a:t>panorama web, tablero Power BI y CSVs públicos leen LA MISMA vista — imposible que se desalineen.</a:t>
             </a:r>
           </a:p>
         </p:txBody>
@@ -5331,7 +5364,7 @@
                 </a:solidFill>
                 <a:latin typeface="IBM Plex Mono"/>
               </a:rPr>
-              <a:t>RESPALDO TÉCNICO · B5</a:t>
+              <a:t>RESPALDO TÉCNICO · B4</a:t>
             </a:r>
           </a:p>
           <a:p/>
@@ -5348,7 +5381,7 @@
                 </a:solidFill>
                 <a:latin typeface="Nunito Sans"/>
               </a:rPr>
-              <a:t>Evaluación y trazabilidad</a:t>
+              <a:t>Calidad de datos: medida, no declarada</a:t>
             </a:r>
           </a:p>
         </p:txBody>
@@ -5387,7 +5420,7 @@
                 </a:solidFill>
                 <a:latin typeface="Nunito Sans"/>
               </a:rPr>
-              <a:t>Golden sets versionados</a:t>
+              <a:t>Auditoría columna a columna</a:t>
             </a:r>
           </a:p>
           <a:p/>
@@ -5404,7 +5437,7 @@
                 </a:solidFill>
                 <a:latin typeface="Nunito Sans"/>
               </a:rPr>
-              <a:t>eval/golden_queries.yaml y golden_chips.yaml — corridas reproducibles con reportes históricos (16 en eval/reports/).</a:t>
+              <a:t>17/18 columnas al 100 % de fidelidad contra la fuente Socrata (reportes versionados en eval/reports/).</a:t>
             </a:r>
           </a:p>
           <a:p>
@@ -5420,7 +5453,7 @@
                 </a:solidFill>
                 <a:latin typeface="Nunito Sans"/>
               </a:rPr>
-              <a:t>35 archivos de pruebas</a:t>
+              <a:t>Clasificación continua</a:t>
             </a:r>
           </a:p>
           <a:p>
@@ -5436,7 +5469,7 @@
                 </a:solidFill>
                 <a:latin typeface="Nunito Sans"/>
               </a:rPr>
-              <a:t>verificador SoQL, validador anti-alucinación, reparación, geo/DIVIPOLA, cosecha, MCP (stdio/SSE), rutas de API.</a:t>
+              <a:t>los 2.996 reportes administrativos (Ley 1712) se separan de los datos temáticos automáticamente, en cada corrida del ETL.</a:t>
             </a:r>
           </a:p>
           <a:p>
@@ -5452,7 +5485,7 @@
                 </a:solidFill>
                 <a:latin typeface="Nunito Sans"/>
               </a:rPr>
-              <a:t>Evaluación embebida</a:t>
+              <a:t>Inferencia territorial</a:t>
             </a:r>
           </a:p>
           <a:p>
@@ -5468,7 +5501,7 @@
                 </a:solidFill>
                 <a:latin typeface="Nunito Sans"/>
               </a:rPr>
-              <a:t>el verificador corre en producción en cada consulta — la garantía no es una métrica de laboratorio.</a:t>
+              <a:t>códigos DIVIPOLA asignados por IA con confianza registrada (~89 % de cobertura del catálogo).</a:t>
             </a:r>
           </a:p>
           <a:p>
@@ -5484,7 +5517,7 @@
                 </a:solidFill>
                 <a:latin typeface="Nunito Sans"/>
               </a:rPr>
-              <a:t>Decisiones documentadas</a:t>
+              <a:t>Guardas anti-basura</a:t>
             </a:r>
           </a:p>
           <a:p>
@@ -5500,7 +5533,7 @@
                 </a:solidFill>
                 <a:latin typeface="Nunito Sans"/>
               </a:rPr>
-              <a:t>ADRs públicos (017-023): del principio 'la IA razona, el motor verifica' al pivote panorama-decisor.</a:t>
+              <a:t>metadata placeholder sin diligenciar ({{name}}) se descarta en la ingesta; el catálogo no acumula ruido.</a:t>
             </a:r>
           </a:p>
           <a:p>
@@ -5516,7 +5549,7 @@
                 </a:solidFill>
                 <a:latin typeface="Nunito Sans"/>
               </a:rPr>
-              <a:t>Telemetría anónima</a:t>
+              <a:t>Atribución por origen</a:t>
             </a:r>
           </a:p>
           <a:p>
@@ -5532,7 +5565,7 @@
                 </a:solidFill>
                 <a:latin typeface="Nunito Sans"/>
               </a:rPr>
-              <a:t>lo más consultado alimenta la mejora sin datos personales.</a:t>
+              <a:t>cada dataset se atribuye al portal donde su entidad publica originalmente — incluso las copias federadas del solapamiento cross-portal.</a:t>
             </a:r>
           </a:p>
         </p:txBody>
@@ -5636,7 +5669,7 @@
                 </a:solidFill>
                 <a:latin typeface="IBM Plex Mono"/>
               </a:rPr>
-              <a:t>RESPALDO TÉCNICO · B6</a:t>
+              <a:t>RESPALDO TÉCNICO · B5</a:t>
             </a:r>
           </a:p>
           <a:p/>
@@ -5653,7 +5686,7 @@
                 </a:solidFill>
                 <a:latin typeface="Nunito Sans"/>
               </a:rPr>
-              <a:t>Soberanía, seguridad y cumplimiento</a:t>
+              <a:t>Evaluación y trazabilidad</a:t>
             </a:r>
           </a:p>
         </p:txBody>
@@ -5692,7 +5725,7 @@
                 </a:solidFill>
                 <a:latin typeface="Nunito Sans"/>
               </a:rPr>
-              <a:t>Infraestructura del Estado</a:t>
+              <a:t>Golden sets versionados</a:t>
             </a:r>
           </a:p>
           <a:p/>
@@ -5709,7 +5742,7 @@
                 </a:solidFill>
                 <a:latin typeface="Nunito Sans"/>
               </a:rPr>
-              <a:t>el servicio corre en infraestructura pública; los datos consultados son públicos por definición.</a:t>
+              <a:t>eval/golden_queries.yaml y golden_chips.yaml — corridas reproducibles con reportes históricos (16 en eval/reports/).</a:t>
             </a:r>
           </a:p>
           <a:p>
@@ -5725,7 +5758,7 @@
                 </a:solidFill>
                 <a:latin typeface="Nunito Sans"/>
               </a:rPr>
-              <a:t>Sin datos personales</a:t>
+              <a:t>35 archivos de pruebas</a:t>
             </a:r>
           </a:p>
           <a:p>
@@ -5741,7 +5774,7 @@
                 </a:solidFill>
                 <a:latin typeface="Nunito Sans"/>
               </a:rPr>
-              <a:t>cero registro, cero rastreadores; telemetría agregada y anónima.</a:t>
+              <a:t>verificador SoQL, validador anti-alucinación, reparación, geo/DIVIPOLA, cosecha, MCP (stdio/SSE), rutas de API.</a:t>
             </a:r>
           </a:p>
           <a:p>
@@ -5757,7 +5790,7 @@
                 </a:solidFill>
                 <a:latin typeface="Nunito Sans"/>
               </a:rPr>
-              <a:t>Solo lectura</a:t>
+              <a:t>Evaluación embebida</a:t>
             </a:r>
           </a:p>
           <a:p>
@@ -5773,7 +5806,7 @@
                 </a:solidFill>
                 <a:latin typeface="Nunito Sans"/>
               </a:rPr>
-              <a:t>el motor no puede escribir en ninguna fuente; verificación de solo-lectura en la capa 2.</a:t>
+              <a:t>el verificador corre en producción en cada consulta — la garantía no es una métrica de laboratorio.</a:t>
             </a:r>
           </a:p>
           <a:p>
@@ -5789,7 +5822,7 @@
                 </a:solidFill>
                 <a:latin typeface="Nunito Sans"/>
               </a:rPr>
-              <a:t>Repo abierto y auditable</a:t>
+              <a:t>Decisiones documentadas</a:t>
             </a:r>
           </a:p>
           <a:p>
@@ -5805,7 +5838,7 @@
                 </a:solidFill>
                 <a:latin typeface="Nunito Sans"/>
               </a:rPr>
-              <a:t>código, documentación, pruebas y evaluación públicos — replicable con Docker en cualquier máquina (guía de validación para el jurado).</a:t>
+              <a:t>ADRs públicos (017-023): del principio 'la IA razona, el motor verifica' al pivote panorama-decisor.</a:t>
             </a:r>
           </a:p>
           <a:p>
@@ -5821,7 +5854,7 @@
                 </a:solidFill>
                 <a:latin typeface="Nunito Sans"/>
               </a:rPr>
-              <a:t>Accesibilidad</a:t>
+              <a:t>Telemetría anónima</a:t>
             </a:r>
           </a:p>
           <a:p>
@@ -5837,7 +5870,7 @@
                 </a:solidFill>
                 <a:latin typeface="Nunito Sans"/>
               </a:rPr>
-              <a:t>Ley 1618 de 2013 y WCAG 2.1 AA: voz, narración, contraste, escala tipográfica.</a:t>
+              <a:t>lo más consultado alimenta la mejora sin datos personales.</a:t>
             </a:r>
           </a:p>
         </p:txBody>
@@ -5877,6 +5910,311 @@
                 <a:latin typeface="IBM Plex Mono"/>
               </a:rPr>
               <a:t>DatosVivos · datosvivos.co  —  Datos al Ecosistema 2026 · Equipo 93 · Reto 7 (id 102) · Nivel Avanzado        18</a:t>
+            </a:r>
+          </a:p>
+        </p:txBody>
+      </p:sp>
+    </p:spTree>
+  </p:cSld>
+  <p:clrMapOvr>
+    <a:masterClrMapping/>
+  </p:clrMapOvr>
+</p:sld>
+</file>
+
+<file path=ppt/slides/slide19.xml><?xml version="1.0" encoding="utf-8"?>
+<p:sld xmlns:a="http://schemas.openxmlformats.org/drawingml/2006/main" xmlns:p="http://schemas.openxmlformats.org/presentationml/2006/main" xmlns:r="http://schemas.openxmlformats.org/officeDocument/2006/relationships">
+  <p:cSld>
+    <p:bg>
+      <p:bgPr>
+        <a:solidFill>
+          <a:srgbClr val="FFFFFF"/>
+        </a:solidFill>
+        <a:effectLst/>
+      </p:bgPr>
+    </p:bg>
+    <p:spTree>
+      <p:nvGrpSpPr>
+        <p:cNvPr id="1" name=""/>
+        <p:cNvGrpSpPr/>
+        <p:nvPr/>
+      </p:nvGrpSpPr>
+      <p:grpSpPr/>
+      <p:sp>
+        <p:nvSpPr>
+          <p:cNvPr id="2" name="TextBox 1"/>
+          <p:cNvSpPr txBox="1"/>
+          <p:nvPr/>
+        </p:nvSpPr>
+        <p:spPr>
+          <a:xfrm>
+            <a:off x="548640" y="411480"/>
+            <a:ext cx="11064240" cy="1554480"/>
+          </a:xfrm>
+          <a:prstGeom prst="rect">
+            <a:avLst/>
+          </a:prstGeom>
+          <a:noFill/>
+        </p:spPr>
+        <p:txBody>
+          <a:bodyPr wrap="square">
+            <a:spAutoFit/>
+          </a:bodyPr>
+          <a:lstStyle/>
+          <a:p>
+            <a:pPr algn="l">
+              <a:spcAft>
+                <a:spcPts val="600"/>
+              </a:spcAft>
+            </a:pPr>
+            <a:r>
+              <a:rPr sz="1200" b="1">
+                <a:solidFill>
+                  <a:srgbClr val="3366CC"/>
+                </a:solidFill>
+                <a:latin typeface="IBM Plex Mono"/>
+              </a:rPr>
+              <a:t>RESPALDO TÉCNICO · B6</a:t>
+            </a:r>
+          </a:p>
+          <a:p/>
+          <a:p>
+            <a:pPr algn="l">
+              <a:spcAft>
+                <a:spcPts val="0"/>
+              </a:spcAft>
+            </a:pPr>
+            <a:r>
+              <a:rPr sz="2800" b="1">
+                <a:solidFill>
+                  <a:srgbClr val="202124"/>
+                </a:solidFill>
+                <a:latin typeface="Nunito Sans"/>
+              </a:rPr>
+              <a:t>Soberanía, seguridad y cumplimiento</a:t>
+            </a:r>
+          </a:p>
+        </p:txBody>
+      </p:sp>
+      <p:sp>
+        <p:nvSpPr>
+          <p:cNvPr id="3" name="TextBox 2"/>
+          <p:cNvSpPr txBox="1"/>
+          <p:nvPr/>
+        </p:nvSpPr>
+        <p:spPr>
+          <a:xfrm>
+            <a:off x="594360" y="1828800"/>
+            <a:ext cx="10972800" cy="4297680"/>
+          </a:xfrm>
+          <a:prstGeom prst="rect">
+            <a:avLst/>
+          </a:prstGeom>
+          <a:noFill/>
+        </p:spPr>
+        <p:txBody>
+          <a:bodyPr wrap="square">
+            <a:spAutoFit/>
+          </a:bodyPr>
+          <a:lstStyle/>
+          <a:p>
+            <a:pPr algn="l">
+              <a:spcAft>
+                <a:spcPts val="200"/>
+              </a:spcAft>
+            </a:pPr>
+            <a:r>
+              <a:rPr sz="1700" b="1">
+                <a:solidFill>
+                  <a:srgbClr val="004884"/>
+                </a:solidFill>
+                <a:latin typeface="Nunito Sans"/>
+              </a:rPr>
+              <a:t>Infraestructura del Estado</a:t>
+            </a:r>
+          </a:p>
+          <a:p/>
+          <a:p>
+            <a:pPr algn="l">
+              <a:spcAft>
+                <a:spcPts val="1000"/>
+              </a:spcAft>
+            </a:pPr>
+            <a:r>
+              <a:rPr sz="1500" b="0">
+                <a:solidFill>
+                  <a:srgbClr val="202124"/>
+                </a:solidFill>
+                <a:latin typeface="Nunito Sans"/>
+              </a:rPr>
+              <a:t>el servicio corre en infraestructura pública; los datos consultados son públicos por definición.</a:t>
+            </a:r>
+          </a:p>
+          <a:p>
+            <a:pPr algn="l">
+              <a:spcAft>
+                <a:spcPts val="200"/>
+              </a:spcAft>
+            </a:pPr>
+            <a:r>
+              <a:rPr sz="1700" b="1">
+                <a:solidFill>
+                  <a:srgbClr val="004884"/>
+                </a:solidFill>
+                <a:latin typeface="Nunito Sans"/>
+              </a:rPr>
+              <a:t>Sin datos personales</a:t>
+            </a:r>
+          </a:p>
+          <a:p>
+            <a:pPr algn="l">
+              <a:spcAft>
+                <a:spcPts val="1000"/>
+              </a:spcAft>
+            </a:pPr>
+            <a:r>
+              <a:rPr sz="1500" b="0">
+                <a:solidFill>
+                  <a:srgbClr val="202124"/>
+                </a:solidFill>
+                <a:latin typeface="Nunito Sans"/>
+              </a:rPr>
+              <a:t>cero registro, cero rastreadores; telemetría agregada y anónima.</a:t>
+            </a:r>
+          </a:p>
+          <a:p>
+            <a:pPr algn="l">
+              <a:spcAft>
+                <a:spcPts val="200"/>
+              </a:spcAft>
+            </a:pPr>
+            <a:r>
+              <a:rPr sz="1700" b="1">
+                <a:solidFill>
+                  <a:srgbClr val="004884"/>
+                </a:solidFill>
+                <a:latin typeface="Nunito Sans"/>
+              </a:rPr>
+              <a:t>Solo lectura</a:t>
+            </a:r>
+          </a:p>
+          <a:p>
+            <a:pPr algn="l">
+              <a:spcAft>
+                <a:spcPts val="1000"/>
+              </a:spcAft>
+            </a:pPr>
+            <a:r>
+              <a:rPr sz="1500" b="0">
+                <a:solidFill>
+                  <a:srgbClr val="202124"/>
+                </a:solidFill>
+                <a:latin typeface="Nunito Sans"/>
+              </a:rPr>
+              <a:t>el motor no puede escribir en ninguna fuente; verificación de solo-lectura en la capa 2.</a:t>
+            </a:r>
+          </a:p>
+          <a:p>
+            <a:pPr algn="l">
+              <a:spcAft>
+                <a:spcPts val="200"/>
+              </a:spcAft>
+            </a:pPr>
+            <a:r>
+              <a:rPr sz="1700" b="1">
+                <a:solidFill>
+                  <a:srgbClr val="004884"/>
+                </a:solidFill>
+                <a:latin typeface="Nunito Sans"/>
+              </a:rPr>
+              <a:t>Repo abierto y auditable</a:t>
+            </a:r>
+          </a:p>
+          <a:p>
+            <a:pPr algn="l">
+              <a:spcAft>
+                <a:spcPts val="1000"/>
+              </a:spcAft>
+            </a:pPr>
+            <a:r>
+              <a:rPr sz="1500" b="0">
+                <a:solidFill>
+                  <a:srgbClr val="202124"/>
+                </a:solidFill>
+                <a:latin typeface="Nunito Sans"/>
+              </a:rPr>
+              <a:t>código, documentación, pruebas y evaluación públicos — replicable con Docker en cualquier máquina (guía de validación para el jurado).</a:t>
+            </a:r>
+          </a:p>
+          <a:p>
+            <a:pPr algn="l">
+              <a:spcAft>
+                <a:spcPts val="200"/>
+              </a:spcAft>
+            </a:pPr>
+            <a:r>
+              <a:rPr sz="1700" b="1">
+                <a:solidFill>
+                  <a:srgbClr val="004884"/>
+                </a:solidFill>
+                <a:latin typeface="Nunito Sans"/>
+              </a:rPr>
+              <a:t>Accesibilidad</a:t>
+            </a:r>
+          </a:p>
+          <a:p>
+            <a:pPr algn="l">
+              <a:spcAft>
+                <a:spcPts val="1000"/>
+              </a:spcAft>
+            </a:pPr>
+            <a:r>
+              <a:rPr sz="1500" b="0">
+                <a:solidFill>
+                  <a:srgbClr val="202124"/>
+                </a:solidFill>
+                <a:latin typeface="Nunito Sans"/>
+              </a:rPr>
+              <a:t>Ley 1618 de 2013 y WCAG 2.1 AA: voz, narración, contraste, escala tipográfica.</a:t>
+            </a:r>
+          </a:p>
+        </p:txBody>
+      </p:sp>
+      <p:sp>
+        <p:nvSpPr>
+          <p:cNvPr id="4" name="TextBox 3"/>
+          <p:cNvSpPr txBox="1"/>
+          <p:nvPr/>
+        </p:nvSpPr>
+        <p:spPr>
+          <a:xfrm>
+            <a:off x="457200" y="6446520"/>
+            <a:ext cx="11247120" cy="320040"/>
+          </a:xfrm>
+          <a:prstGeom prst="rect">
+            <a:avLst/>
+          </a:prstGeom>
+          <a:noFill/>
+        </p:spPr>
+        <p:txBody>
+          <a:bodyPr wrap="square">
+            <a:spAutoFit/>
+          </a:bodyPr>
+          <a:lstStyle/>
+          <a:p>
+            <a:pPr algn="l">
+              <a:spcAft>
+                <a:spcPts val="600"/>
+              </a:spcAft>
+            </a:pPr>
+            <a:r>
+              <a:rPr sz="900" b="0">
+                <a:solidFill>
+                  <a:srgbClr val="5F6368"/>
+                </a:solidFill>
+                <a:latin typeface="IBM Plex Mono"/>
+              </a:rPr>
+              <a:t>DatosVivos · datosvivos.co  —  Datos al Ecosistema 2026 · Equipo 93 · Reto 7 (id 102) · Nivel Avanzado        19</a:t>
             </a:r>
           </a:p>
         </p:txBody>
@@ -6813,7 +7151,7 @@
         <p:spPr>
           <a:xfrm>
             <a:off x="548640" y="1920240"/>
-            <a:ext cx="2602153" cy="1737360"/>
+            <a:ext cx="2036003" cy="1737360"/>
           </a:xfrm>
           <a:prstGeom prst="rect">
             <a:avLst/>
@@ -6886,8 +7224,8 @@
         </p:nvSpPr>
         <p:spPr>
           <a:xfrm>
-            <a:off x="3379393" y="1920240"/>
-            <a:ext cx="2602153" cy="1737360"/>
+            <a:off x="2813243" y="1920240"/>
+            <a:ext cx="2036003" cy="1737360"/>
           </a:xfrm>
           <a:prstGeom prst="rect">
             <a:avLst/>
@@ -6960,8 +7298,8 @@
         </p:nvSpPr>
         <p:spPr>
           <a:xfrm>
-            <a:off x="6210146" y="1920240"/>
-            <a:ext cx="2602153" cy="1737360"/>
+            <a:off x="5077846" y="1920240"/>
+            <a:ext cx="2036003" cy="1737360"/>
           </a:xfrm>
           <a:prstGeom prst="rect">
             <a:avLst/>
@@ -7034,8 +7372,8 @@
         </p:nvSpPr>
         <p:spPr>
           <a:xfrm>
-            <a:off x="9040899" y="1920240"/>
-            <a:ext cx="2602153" cy="1737360"/>
+            <a:off x="7342449" y="1920240"/>
+            <a:ext cx="2036003" cy="1737360"/>
           </a:xfrm>
           <a:prstGeom prst="rect">
             <a:avLst/>
@@ -7074,6 +7412,80 @@
             <a:r>
               <a:rPr sz="3000" b="1">
                 <a:solidFill>
+                  <a:srgbClr val="004884"/>
+                </a:solidFill>
+                <a:latin typeface="IBM Plex Mono"/>
+              </a:rPr>
+              <a:t>29</a:t>
+            </a:r>
+          </a:p>
+          <a:p/>
+          <a:p>
+            <a:pPr algn="ctr">
+              <a:spcAft>
+                <a:spcPts val="0"/>
+              </a:spcAft>
+            </a:pPr>
+            <a:r>
+              <a:rPr sz="1200" b="0">
+                <a:solidFill>
+                  <a:srgbClr val="5F6368"/>
+                </a:solidFill>
+                <a:latin typeface="Nunito Sans"/>
+              </a:rPr>
+              <a:t>variables curadas por dataset</a:t>
+            </a:r>
+          </a:p>
+        </p:txBody>
+      </p:sp>
+      <p:sp>
+        <p:nvSpPr>
+          <p:cNvPr id="7" name="Rectangle 6"/>
+          <p:cNvSpPr/>
+          <p:nvPr/>
+        </p:nvSpPr>
+        <p:spPr>
+          <a:xfrm>
+            <a:off x="9607052" y="1920240"/>
+            <a:ext cx="2036003" cy="1737360"/>
+          </a:xfrm>
+          <a:prstGeom prst="rect">
+            <a:avLst/>
+          </a:prstGeom>
+          <a:solidFill>
+            <a:srgbClr val="F4F6F9"/>
+          </a:solidFill>
+          <a:ln>
+            <a:noFill/>
+          </a:ln>
+          <a:effectLst/>
+        </p:spPr>
+        <p:style>
+          <a:lnRef idx="1">
+            <a:schemeClr val="accent1"/>
+          </a:lnRef>
+          <a:fillRef idx="3">
+            <a:schemeClr val="accent1"/>
+          </a:fillRef>
+          <a:effectRef idx="2">
+            <a:schemeClr val="accent1"/>
+          </a:effectRef>
+          <a:fontRef idx="minor">
+            <a:schemeClr val="lt1"/>
+          </a:fontRef>
+        </p:style>
+        <p:txBody>
+          <a:bodyPr rtlCol="0" anchor="ctr" wrap="square"/>
+          <a:lstStyle/>
+          <a:p>
+            <a:pPr algn="ctr">
+              <a:spcAft>
+                <a:spcPts val="200"/>
+              </a:spcAft>
+            </a:pPr>
+            <a:r>
+              <a:rPr sz="3000" b="1">
+                <a:solidFill>
                   <a:srgbClr val="C32D4B"/>
                 </a:solidFill>
                 <a:latin typeface="IBM Plex Mono"/>
@@ -7102,7 +7514,7 @@
       </p:sp>
       <p:sp>
         <p:nvSpPr>
-          <p:cNvPr id="7" name="TextBox 6"/>
+          <p:cNvPr id="8" name="TextBox 7"/>
           <p:cNvSpPr txBox="1"/>
           <p:nvPr/>
         </p:nvSpPr>
@@ -7222,7 +7634,7 @@
       </p:sp>
       <p:sp>
         <p:nvSpPr>
-          <p:cNvPr id="8" name="TextBox 7"/>
+          <p:cNvPr id="9" name="TextBox 8"/>
           <p:cNvSpPr txBox="1"/>
           <p:nvPr/>
         </p:nvSpPr>
@@ -7897,7 +8309,7 @@
                 </a:solidFill>
                 <a:latin typeface="IBM Plex Mono"/>
               </a:rPr>
-              <a:t>TECNOLOGÍAS EMERGENTES</a:t>
+              <a:t>TECNOLOGÍAS EMERGENTES · IA</a:t>
             </a:r>
           </a:p>
           <a:p/>
@@ -7914,21 +8326,61 @@
                 </a:solidFill>
                 <a:latin typeface="Nunito Sans"/>
               </a:rPr>
-              <a:t>Dónde vive la IA en DatosVivos</a:t>
-            </a:r>
-          </a:p>
-        </p:txBody>
-      </p:sp>
-      <p:sp>
-        <p:nvSpPr>
-          <p:cNvPr id="3" name="Rectangle 2"/>
+              <a:t>Un agente de IA para servicios públicos</a:t>
+            </a:r>
+          </a:p>
+        </p:txBody>
+      </p:sp>
+      <p:sp>
+        <p:nvSpPr>
+          <p:cNvPr id="3" name="TextBox 2"/>
+          <p:cNvSpPr txBox="1"/>
+          <p:nvPr/>
+        </p:nvSpPr>
+        <p:spPr>
+          <a:xfrm>
+            <a:off x="594360" y="1417320"/>
+            <a:ext cx="10972800" cy="457200"/>
+          </a:xfrm>
+          <a:prstGeom prst="rect">
+            <a:avLst/>
+          </a:prstGeom>
+          <a:noFill/>
+        </p:spPr>
+        <p:txBody>
+          <a:bodyPr wrap="square">
+            <a:spAutoFit/>
+          </a:bodyPr>
+          <a:lstStyle/>
+          <a:p>
+            <a:pPr algn="l">
+              <a:spcAft>
+                <a:spcPts val="600"/>
+              </a:spcAft>
+            </a:pPr>
+            <a:r>
+              <a:rPr sz="1300" b="0">
+                <a:solidFill>
+                  <a:srgbClr val="5F6368"/>
+                </a:solidFill>
+                <a:latin typeface="Nunito Sans"/>
+              </a:rPr>
+              <a:t>IA generativa + arquitectura híbrida: modelos de lenguaje que razonan, motor determinista que verifica. Pertinente, aplicable e interpretable — nunca superficial.</a:t>
+            </a:r>
+          </a:p>
+          <a:p/>
+        </p:txBody>
+      </p:sp>
+      <p:sp>
+        <p:nvSpPr>
+          <p:cNvPr id="4" name="Rectangle 3"/>
           <p:cNvSpPr/>
           <p:nvPr/>
         </p:nvSpPr>
         <p:spPr>
           <a:xfrm>
-            <a:off x="548640" y="1828800"/>
-            <a:ext cx="5486400" cy="4023360"/>
+            <a:off x="548640" y="2057400"/>
+            <a:ext cx="5486400" cy="3794760"/>
           </a:xfrm>
           <a:prstGeom prst="rect">
             <a:avLst/>
@@ -8059,14 +8511,14 @@
       </p:sp>
       <p:sp>
         <p:nvSpPr>
-          <p:cNvPr id="4" name="Rectangle 3"/>
+          <p:cNvPr id="5" name="Rectangle 4"/>
           <p:cNvSpPr/>
           <p:nvPr/>
         </p:nvSpPr>
         <p:spPr>
           <a:xfrm>
-            <a:off x="6263640" y="1828800"/>
-            <a:ext cx="5486400" cy="4023360"/>
+            <a:off x="6263640" y="2057400"/>
+            <a:ext cx="5486400" cy="3794760"/>
           </a:xfrm>
           <a:prstGeom prst="rect">
             <a:avLst/>
@@ -8197,7 +8649,7 @@
       </p:sp>
       <p:sp>
         <p:nvSpPr>
-          <p:cNvPr id="5" name="TextBox 4"/>
+          <p:cNvPr id="6" name="TextBox 5"/>
           <p:cNvSpPr txBox="1"/>
           <p:nvPr/>
         </p:nvSpPr>

</xml_diff>

<commit_message>
feat(web+pitch): nav con Inicio y 'Detalle por entidad'; demo del pitch amarrada a las 3 secciones
- Header y Footer: se agrega 'Inicio' (faltaba; la home solo era accesible
  por el wordmark) y 'Tablero' pasa a 'Detalle por entidad' (más diciente
  para el decisor).
- Pitch: la sección demo queda explícita como Demo 1/3 Inicio · Demo 2/3
  Detalle por entidad · Demo 3/3 Buscar, y la diapositiva de los 3 niveles
  usa los mismos nombres de la navegación real. PDF re-exportado.

Co-Authored-By: Claude Fable 5 <noreply@anthropic.com>
</commit_message>
<xml_diff>
--- a/recursos/presentacion.pptx
+++ b/recursos/presentacion.pptx
@@ -6763,7 +6763,7 @@
                 </a:solidFill>
                 <a:latin typeface="IBM Plex Mono"/>
               </a:rPr>
-              <a:t>1 · PANORAMA</a:t>
+              <a:t>1 · INICIO</a:t>
             </a:r>
           </a:p>
           <a:p/>
@@ -6780,7 +6780,7 @@
                 </a:solidFill>
                 <a:latin typeface="Nunito Sans"/>
               </a:rPr>
-              <a:t>datosvivos.co</a:t>
+              <a:t>Panorama nacional — datosvivos.co</a:t>
             </a:r>
           </a:p>
           <a:p>
@@ -6853,7 +6853,7 @@
                 </a:solidFill>
                 <a:latin typeface="IBM Plex Mono"/>
               </a:rPr>
-              <a:t>2 · TABLERO</a:t>
+              <a:t>2 · DETALLE POR ENTIDAD</a:t>
             </a:r>
           </a:p>
           <a:p/>
@@ -6943,7 +6943,7 @@
                 </a:solidFill>
                 <a:latin typeface="IBM Plex Mono"/>
               </a:rPr>
-              <a:t>3 · BUSCADOR</a:t>
+              <a:t>3 · BUSCAR</a:t>
             </a:r>
           </a:p>
           <a:p/>
@@ -7120,7 +7120,7 @@
                 </a:solidFill>
                 <a:latin typeface="IBM Plex Mono"/>
               </a:rPr>
-              <a:t>EN PRODUCCIÓN · CORTE 2026-07-10</a:t>
+              <a:t>DEMO 1/3 · INICIO · CORTE 2026-07-10</a:t>
             </a:r>
           </a:p>
           <a:p/>
@@ -7731,7 +7731,7 @@
                 </a:solidFill>
                 <a:latin typeface="IBM Plex Mono"/>
               </a:rPr>
-              <a:t>NIVEL 2 · POWER BI</a:t>
+              <a:t>DEMO 2/3 · DETALLE POR ENTIDAD (POWER BI)</a:t>
             </a:r>
           </a:p>
           <a:p/>
@@ -8036,7 +8036,7 @@
                 </a:solidFill>
                 <a:latin typeface="IBM Plex Mono"/>
               </a:rPr>
-              <a:t>NIVEL 3 · BUSCADOR</a:t>
+              <a:t>DEMO 3/3 · BUSCAR (LENGUAJE NATURAL)</a:t>
             </a:r>
           </a:p>
           <a:p/>

</xml_diff>

<commit_message>
docs(pitch): estado real a julio 2026 — bodega Parquet en producción y roadmap con un solo pendiente
Regenerado (19 diapositivas): 'Lo que sigue' refleja lo ejecutado
(migración a la API de Claude ~1.5 s, bodega local con regla diaria,
catalogación 100 %) y deja como único pendiente los casos de consulta
verificados sobre la bodega. B1 describe el cron diario ETL + cola de
la bodega. Se versiona scripts/gen_pitch.py para reproducibilidad.

Co-Authored-By: Claude Fable 5 <noreply@anthropic.com>
</commit_message>
<xml_diff>
--- a/recursos/presentacion.pptx
+++ b/recursos/presentacion.pptx
@@ -4355,13 +4355,13 @@
               </a:spcAft>
             </a:pPr>
             <a:r>
-              <a:rPr sz="1700" b="0">
+              <a:rPr sz="1500" b="0">
                 <a:solidFill>
                   <a:srgbClr val="FFFFFF"/>
                 </a:solidFill>
                 <a:latin typeface="Nunito Sans"/>
               </a:rPr>
-              <a:t>1 · Cosecha y catalogación previa de datasets — casos de consulta verificados para una búsqueda aún más precisa (6.2 GB ya liberados para la bodega).</a:t>
+              <a:t>Ya ejecutado (julio 2026): motor de lenguaje migrado a la API de Claude (interpretación en ~1.5 s) · bodega local Parquet en producción con regla diaria de cola (el buscador responde en milisegundos desde la copia local) · catalogación temática al 100 % del catálogo.</a:t>
             </a:r>
           </a:p>
           <a:p>
@@ -4371,13 +4371,13 @@
               </a:spcAft>
             </a:pPr>
             <a:r>
-              <a:rPr sz="1700" b="0">
+              <a:rPr sz="1500" b="0">
                 <a:solidFill>
                   <a:srgbClr val="FFFFFF"/>
                 </a:solidFill>
                 <a:latin typeface="Nunito Sans"/>
               </a:rPr>
-              <a:t>2 · Motor de lenguaje ya migrado a la API de Claude: interpretación en ~1.5 s (antes 31-45 s) con verificación determinista intacta.</a:t>
+              <a:t>Lo que falta: casos de consulta generados y verificados por el motor sobre la bodega — retrieval aún más preciso.</a:t>
             </a:r>
           </a:p>
           <a:p>
@@ -4618,7 +4618,7 @@
                 </a:solidFill>
                 <a:latin typeface="Nunito Sans"/>
               </a:rPr>
-              <a:t>FastAPI + PostgreSQL (catálogo curado, vistas _decisor) + ChromaDB (retrieval) + DuckDB (federados con CSV externo) + backend LLM conectable — producción: API de Claude (Haiku); opción local: Ollama.</a:t>
+              <a:t>FastAPI + PostgreSQL (catálogo curado, vistas _decisor) + ChromaDB (retrieval) + DuckDB (federados con CSV externo) + backend LLM intercambiable (producción: API de Claude · réplicas sin key: Ollama).</a:t>
             </a:r>
           </a:p>
           <a:p>
@@ -4682,7 +4682,7 @@
                 </a:solidFill>
                 <a:latin typeface="Nunito Sans"/>
               </a:rPr>
-              <a:t>Docker Compose con imagen reproducible, túnel seguro de salida, cron de actualización diaria.</a:t>
+              <a:t>Docker Compose con imagen reproducible, túnel seguro de salida, cron diario: ETL + regla de cola de la bodega Parquet (snapshot fresco → respuesta local en milisegundos; fuente cambió → dato vivo).</a:t>
             </a:r>
           </a:p>
         </p:txBody>
@@ -6853,7 +6853,7 @@
                 </a:solidFill>
                 <a:latin typeface="IBM Plex Mono"/>
               </a:rPr>
-              <a:t>2 · DETALLE POR ENTIDAD</a:t>
+              <a:t>2 · DETALLE ENTIDAD</a:t>
             </a:r>
           </a:p>
           <a:p/>
@@ -7731,7 +7731,7 @@
                 </a:solidFill>
                 <a:latin typeface="IBM Plex Mono"/>
               </a:rPr>
-              <a:t>DEMO 2/3 · DETALLE POR ENTIDAD (POWER BI)</a:t>
+              <a:t>DEMO 2/3 · DETALLE ENTIDAD (POWER BI)</a:t>
             </a:r>
           </a:p>
           <a:p/>

</xml_diff>

<commit_message>
docs+fix(buscar): documentación al estado real (bodega completa 10.279, ciclo ciudadano, TIPO Total) + orígenes muertos penalizan el ranking
README/metodología/arquitectura/conclusiones/pitch con las cifras de
hoy: bodega COMPLETA (10.279 datasets · 6,4 GB), re-ranking semántico
en el camino estructurado, 6 TIPOs (Total para montos), ciclo ciudadano
como metodología de evaluación centrada en el usuario, y roadmap nuevo
(filtros año/municipio + respuestas compuestas). En el score de
candidatos: LEFT JOIN a dataset_snapshots — un dataset cuyo origen
respondió 403/404 al farmeo pierde 0.6 (sin columnas nuevas: la marca
ya vivía en el manifest).

Co-Authored-By: Claude Fable 5 <noreply@anthropic.com>
</commit_message>
<xml_diff>
--- a/recursos/presentacion.pptx
+++ b/recursos/presentacion.pptx
@@ -4355,13 +4355,13 @@
               </a:spcAft>
             </a:pPr>
             <a:r>
-              <a:rPr sz="1500" b="0">
+              <a:rPr sz="1400" b="0">
                 <a:solidFill>
                   <a:srgbClr val="FFFFFF"/>
                 </a:solidFill>
                 <a:latin typeface="Nunito Sans"/>
               </a:rPr>
-              <a:t>Ya ejecutado (julio 2026): motor de lenguaje migrado a la API de Claude (interpretación en ~1.5 s) · bodega local Parquet en producción con regla diaria de cola (el buscador responde en milisegundos desde la copia local) · catalogación temática al 100 % del catálogo.</a:t>
+              <a:t>Ya ejecutado (julio 2026): motor de lenguaje en la API de Claude (~1.5 s) · bodega local Parquet COMPLETA (10.279 datasets, el buscador responde en milisegundos desde la copia local) · catalogación temática al 100 % · evaluación ciudadana de 50 preguntas convertida en mejoras estructurales del buscador.</a:t>
             </a:r>
           </a:p>
           <a:p>
@@ -4371,13 +4371,13 @@
               </a:spcAft>
             </a:pPr>
             <a:r>
-              <a:rPr sz="1500" b="0">
+              <a:rPr sz="1400" b="0">
                 <a:solidFill>
                   <a:srgbClr val="FFFFFF"/>
                 </a:solidFill>
                 <a:latin typeface="Nunito Sans"/>
               </a:rPr>
-              <a:t>Lo que falta: casos de consulta generados y verificados por el motor sobre la bodega — retrieval aún más preciso.</a:t>
+              <a:t>Lo que sigue: filtros de año/municipio dentro del dataset elegido y respuestas compuestas (KPI + tendencia + per cápita).</a:t>
             </a:r>
           </a:p>
           <a:p>
@@ -4618,7 +4618,7 @@
                 </a:solidFill>
                 <a:latin typeface="Nunito Sans"/>
               </a:rPr>
-              <a:t>FastAPI + PostgreSQL (catálogo curado, vistas _decisor) + ChromaDB (retrieval) + DuckDB (federados con CSV externo) + backend LLM intercambiable (producción: API de Claude · réplicas sin key: Ollama).</a:t>
+              <a:t>FastAPI + PostgreSQL (catálogo curado, vistas _decisor) + ChromaDB (retrieval semántico en ambos caminos) + DuckDB (bodega Parquet local de 10.279 datasets + CSVs federados) + backend LLM intercambiable (producción: API de Claude).</a:t>
             </a:r>
           </a:p>
           <a:p>

</xml_diff>

<commit_message>
docs(pitch): versión final del equipo — pptx actualizado + PDF exportado
Co-Authored-By: Claude Fable 5 <noreply@anthropic.com>
</commit_message>
<xml_diff>
--- a/recursos/presentacion.pptx
+++ b/recursos/presentacion.pptx
@@ -2447,7 +2447,40 @@
                 <a:ea typeface="Calibri" pitchFamily="34" charset="-122"/>
                 <a:cs typeface="Calibri" pitchFamily="34" charset="-120"/>
               </a:rPr>
-              <a:t>El panorama de los datos abiertos de Colombia</a:t>
+              <a:t>El panorama de los </a:t>
+            </a:r>
+            <a:r>
+              <a:rPr lang="en-US" sz="1900" dirty="0" err="1">
+                <a:solidFill>
+                  <a:srgbClr val="AEC6D8"/>
+                </a:solidFill>
+                <a:latin typeface="Calibri" pitchFamily="34" charset="0"/>
+                <a:ea typeface="Calibri" pitchFamily="34" charset="-122"/>
+                <a:cs typeface="Calibri" pitchFamily="34" charset="-120"/>
+              </a:rPr>
+              <a:t>datos</a:t>
+            </a:r>
+            <a:r>
+              <a:rPr lang="en-US" sz="1900" dirty="0">
+                <a:solidFill>
+                  <a:srgbClr val="AEC6D8"/>
+                </a:solidFill>
+                <a:latin typeface="Calibri" pitchFamily="34" charset="0"/>
+                <a:ea typeface="Calibri" pitchFamily="34" charset="-122"/>
+                <a:cs typeface="Calibri" pitchFamily="34" charset="-120"/>
+              </a:rPr>
+              <a:t> </a:t>
+            </a:r>
+            <a:r>
+              <a:rPr lang="en-US" sz="1900" dirty="0" err="1">
+                <a:solidFill>
+                  <a:srgbClr val="AEC6D8"/>
+                </a:solidFill>
+                <a:latin typeface="Calibri" pitchFamily="34" charset="0"/>
+                <a:ea typeface="Calibri" pitchFamily="34" charset="-122"/>
+                <a:cs typeface="Calibri" pitchFamily="34" charset="-120"/>
+              </a:rPr>
+              <a:t>abiertos</a:t>
             </a:r>
             <a:endParaRPr lang="en-US" sz="1900" dirty="0"/>
           </a:p>
@@ -2478,7 +2511,7 @@
               <a:buNone/>
             </a:pPr>
             <a:r>
-              <a:rPr lang="en-US" sz="2100" b="1" dirty="0">
+              <a:rPr lang="en-US" sz="2100" b="1" dirty="0" err="1">
                 <a:solidFill>
                   <a:srgbClr val="1ABC9C"/>
                 </a:solidFill>
@@ -2486,7 +2519,18 @@
                 <a:ea typeface="Trebuchet MS" pitchFamily="34" charset="-122"/>
                 <a:cs typeface="Trebuchet MS" pitchFamily="34" charset="-120"/>
               </a:rPr>
-              <a:t>Datos del Estado, en tus palabras.</a:t>
+              <a:t>en</a:t>
+            </a:r>
+            <a:r>
+              <a:rPr lang="en-US" sz="2100" b="1" dirty="0">
+                <a:solidFill>
+                  <a:srgbClr val="1ABC9C"/>
+                </a:solidFill>
+                <a:latin typeface="Trebuchet MS" pitchFamily="34" charset="0"/>
+                <a:ea typeface="Trebuchet MS" pitchFamily="34" charset="-122"/>
+                <a:cs typeface="Trebuchet MS" pitchFamily="34" charset="-120"/>
+              </a:rPr>
+              <a:t> Colombia</a:t>
             </a:r>
             <a:endParaRPr lang="en-US" sz="2100" dirty="0"/>
           </a:p>
@@ -6146,7 +6190,7 @@
                 <a:ea typeface="Trebuchet MS" pitchFamily="34" charset="-122"/>
                 <a:cs typeface="Trebuchet MS" pitchFamily="34" charset="-120"/>
               </a:rPr>
-              <a:t>~1.5 s</a:t>
+              <a:t>~1 - 4 s</a:t>
             </a:r>
             <a:endParaRPr lang="en-US" sz="3000" dirty="0"/>
           </a:p>
@@ -6177,15 +6221,174 @@
               <a:buNone/>
             </a:pPr>
             <a:r>
+              <a:rPr lang="en-US" sz="1050" dirty="0" err="1">
+                <a:solidFill>
+                  <a:srgbClr val="2C3E50"/>
+                </a:solidFill>
+                <a:latin typeface="Calibri" pitchFamily="34" charset="0"/>
+                <a:cs typeface="Calibri" pitchFamily="34" charset="-120"/>
+              </a:rPr>
+              <a:t>en</a:t>
+            </a:r>
+            <a:r>
               <a:rPr lang="en-US" sz="1050" dirty="0">
                 <a:solidFill>
                   <a:srgbClr val="2C3E50"/>
                 </a:solidFill>
                 <a:latin typeface="Calibri" pitchFamily="34" charset="0"/>
-                <a:ea typeface="Calibri" pitchFamily="34" charset="-122"/>
-                <a:cs typeface="Calibri" pitchFamily="34" charset="-120"/>
-              </a:rPr>
-              <a:t>interpreta la pregunta el motor de lenguaje (API de Claude); antes tomaba 31-45 s</a:t>
+                <a:cs typeface="Calibri" pitchFamily="34" charset="-120"/>
+              </a:rPr>
+              <a:t> </a:t>
+            </a:r>
+            <a:r>
+              <a:rPr lang="en-US" sz="1050" dirty="0" err="1">
+                <a:solidFill>
+                  <a:srgbClr val="2C3E50"/>
+                </a:solidFill>
+                <a:latin typeface="Calibri" pitchFamily="34" charset="0"/>
+                <a:cs typeface="Calibri" pitchFamily="34" charset="-120"/>
+              </a:rPr>
+              <a:t>tiempo</a:t>
+            </a:r>
+            <a:r>
+              <a:rPr lang="en-US" sz="1050" dirty="0">
+                <a:solidFill>
+                  <a:srgbClr val="2C3E50"/>
+                </a:solidFill>
+                <a:latin typeface="Calibri" pitchFamily="34" charset="0"/>
+                <a:cs typeface="Calibri" pitchFamily="34" charset="-120"/>
+              </a:rPr>
+              <a:t> de </a:t>
+            </a:r>
+            <a:r>
+              <a:rPr lang="en-US" sz="1050" dirty="0" err="1">
+                <a:solidFill>
+                  <a:srgbClr val="2C3E50"/>
+                </a:solidFill>
+                <a:latin typeface="Calibri" pitchFamily="34" charset="0"/>
+                <a:cs typeface="Calibri" pitchFamily="34" charset="-120"/>
+              </a:rPr>
+              <a:t>procesamiento</a:t>
+            </a:r>
+            <a:r>
+              <a:rPr lang="en-US" sz="1050" dirty="0">
+                <a:solidFill>
+                  <a:srgbClr val="2C3E50"/>
+                </a:solidFill>
+                <a:latin typeface="Calibri" pitchFamily="34" charset="0"/>
+                <a:cs typeface="Calibri" pitchFamily="34" charset="-120"/>
+              </a:rPr>
+              <a:t> de </a:t>
+            </a:r>
+            <a:r>
+              <a:rPr lang="en-US" sz="1050" dirty="0" err="1">
+                <a:solidFill>
+                  <a:srgbClr val="2C3E50"/>
+                </a:solidFill>
+                <a:latin typeface="Calibri" pitchFamily="34" charset="0"/>
+                <a:cs typeface="Calibri" pitchFamily="34" charset="-120"/>
+              </a:rPr>
+              <a:t>información</a:t>
+            </a:r>
+            <a:r>
+              <a:rPr lang="en-US" sz="1050" dirty="0">
+                <a:solidFill>
+                  <a:srgbClr val="2C3E50"/>
+                </a:solidFill>
+                <a:latin typeface="Calibri" pitchFamily="34" charset="0"/>
+                <a:cs typeface="Calibri" pitchFamily="34" charset="-120"/>
+              </a:rPr>
+              <a:t> para </a:t>
+            </a:r>
+            <a:r>
+              <a:rPr lang="en-US" sz="1050" dirty="0" err="1">
+                <a:solidFill>
+                  <a:srgbClr val="2C3E50"/>
+                </a:solidFill>
+                <a:latin typeface="Calibri" pitchFamily="34" charset="0"/>
+                <a:cs typeface="Calibri" pitchFamily="34" charset="-120"/>
+              </a:rPr>
+              <a:t>identificar</a:t>
+            </a:r>
+            <a:r>
+              <a:rPr lang="en-US" sz="1050" dirty="0">
+                <a:solidFill>
+                  <a:srgbClr val="2C3E50"/>
+                </a:solidFill>
+                <a:latin typeface="Calibri" pitchFamily="34" charset="0"/>
+                <a:cs typeface="Calibri" pitchFamily="34" charset="-120"/>
+              </a:rPr>
+              <a:t> un </a:t>
+            </a:r>
+            <a:r>
+              <a:rPr lang="en-US" sz="1050" dirty="0" err="1">
+                <a:solidFill>
+                  <a:srgbClr val="2C3E50"/>
+                </a:solidFill>
+                <a:latin typeface="Calibri" pitchFamily="34" charset="0"/>
+                <a:cs typeface="Calibri" pitchFamily="34" charset="-120"/>
+              </a:rPr>
+              <a:t>dato</a:t>
+            </a:r>
+            <a:r>
+              <a:rPr lang="en-US" sz="1050" dirty="0">
+                <a:solidFill>
+                  <a:srgbClr val="2C3E50"/>
+                </a:solidFill>
+                <a:latin typeface="Calibri" pitchFamily="34" charset="0"/>
+                <a:cs typeface="Calibri" pitchFamily="34" charset="-120"/>
+              </a:rPr>
+              <a:t> clave. Damos </a:t>
+            </a:r>
+            <a:r>
+              <a:rPr lang="en-US" sz="1050" dirty="0" err="1">
+                <a:solidFill>
+                  <a:srgbClr val="2C3E50"/>
+                </a:solidFill>
+                <a:latin typeface="Calibri" pitchFamily="34" charset="0"/>
+                <a:cs typeface="Calibri" pitchFamily="34" charset="-120"/>
+              </a:rPr>
+              <a:t>los</a:t>
+            </a:r>
+            <a:r>
+              <a:rPr lang="en-US" sz="1050" dirty="0">
+                <a:solidFill>
+                  <a:srgbClr val="2C3E50"/>
+                </a:solidFill>
+                <a:latin typeface="Calibri" pitchFamily="34" charset="0"/>
+                <a:cs typeface="Calibri" pitchFamily="34" charset="-120"/>
+              </a:rPr>
+              <a:t> </a:t>
+            </a:r>
+            <a:r>
+              <a:rPr lang="en-US" sz="1050" dirty="0" err="1">
+                <a:solidFill>
+                  <a:srgbClr val="2C3E50"/>
+                </a:solidFill>
+                <a:latin typeface="Calibri" pitchFamily="34" charset="0"/>
+                <a:cs typeface="Calibri" pitchFamily="34" charset="-120"/>
+              </a:rPr>
+              <a:t>datos</a:t>
+            </a:r>
+            <a:r>
+              <a:rPr lang="en-US" sz="1050" dirty="0">
+                <a:solidFill>
+                  <a:srgbClr val="2C3E50"/>
+                </a:solidFill>
+                <a:latin typeface="Calibri" pitchFamily="34" charset="0"/>
+                <a:cs typeface="Calibri" pitchFamily="34" charset="-120"/>
+              </a:rPr>
+              <a:t> y </a:t>
+            </a:r>
+            <a:r>
+              <a:rPr lang="en-US" sz="1050" dirty="0" err="1">
+                <a:solidFill>
+                  <a:srgbClr val="2C3E50"/>
+                </a:solidFill>
+                <a:latin typeface="Calibri" pitchFamily="34" charset="0"/>
+                <a:cs typeface="Calibri" pitchFamily="34" charset="-120"/>
+              </a:rPr>
+              <a:t>velocidad</a:t>
             </a:r>
             <a:endParaRPr lang="en-US" sz="1050" dirty="0"/>
           </a:p>
@@ -6467,7 +6670,7 @@
                 <a:ea typeface="Trebuchet MS" pitchFamily="34" charset="-122"/>
                 <a:cs typeface="Trebuchet MS" pitchFamily="34" charset="-120"/>
               </a:rPr>
-              <a:t>50</a:t>
+              <a:t>1 día</a:t>
             </a:r>
             <a:endParaRPr lang="en-US" sz="3000" dirty="0"/>
           </a:p>
@@ -6498,6 +6701,17 @@
               <a:buNone/>
             </a:pPr>
             <a:r>
+              <a:rPr lang="en-US" sz="1050" dirty="0" err="1">
+                <a:solidFill>
+                  <a:srgbClr val="2C3E50"/>
+                </a:solidFill>
+                <a:latin typeface="Calibri" pitchFamily="34" charset="0"/>
+                <a:ea typeface="Calibri" pitchFamily="34" charset="-122"/>
+                <a:cs typeface="Calibri" pitchFamily="34" charset="-120"/>
+              </a:rPr>
+              <a:t>periodo</a:t>
+            </a:r>
+            <a:r>
               <a:rPr lang="en-US" sz="1050" dirty="0">
                 <a:solidFill>
                   <a:srgbClr val="2C3E50"/>
@@ -6506,7 +6720,62 @@
                 <a:ea typeface="Calibri" pitchFamily="34" charset="-122"/>
                 <a:cs typeface="Calibri" pitchFamily="34" charset="-120"/>
               </a:rPr>
-              <a:t>preguntas ciudadanas evaluadas por ciclos, convertidas en mejoras estructurales</a:t>
+              <a:t> de </a:t>
+            </a:r>
+            <a:r>
+              <a:rPr lang="en-US" sz="1050" dirty="0" err="1">
+                <a:solidFill>
+                  <a:srgbClr val="2C3E50"/>
+                </a:solidFill>
+                <a:latin typeface="Calibri" pitchFamily="34" charset="0"/>
+                <a:ea typeface="Calibri" pitchFamily="34" charset="-122"/>
+                <a:cs typeface="Calibri" pitchFamily="34" charset="-120"/>
+              </a:rPr>
+              <a:t>actualización</a:t>
+            </a:r>
+            <a:r>
+              <a:rPr lang="en-US" sz="1050" dirty="0">
+                <a:solidFill>
+                  <a:srgbClr val="2C3E50"/>
+                </a:solidFill>
+                <a:latin typeface="Calibri" pitchFamily="34" charset="0"/>
+                <a:ea typeface="Calibri" pitchFamily="34" charset="-122"/>
+                <a:cs typeface="Calibri" pitchFamily="34" charset="-120"/>
+              </a:rPr>
+              <a:t> y </a:t>
+            </a:r>
+            <a:r>
+              <a:rPr lang="en-US" sz="1050" dirty="0" err="1">
+                <a:solidFill>
+                  <a:srgbClr val="2C3E50"/>
+                </a:solidFill>
+                <a:latin typeface="Calibri" pitchFamily="34" charset="0"/>
+                <a:ea typeface="Calibri" pitchFamily="34" charset="-122"/>
+                <a:cs typeface="Calibri" pitchFamily="34" charset="-120"/>
+              </a:rPr>
+              <a:t>autocatalogcación</a:t>
+            </a:r>
+            <a:r>
+              <a:rPr lang="en-US" sz="1050" dirty="0">
+                <a:solidFill>
+                  <a:srgbClr val="2C3E50"/>
+                </a:solidFill>
+                <a:latin typeface="Calibri" pitchFamily="34" charset="0"/>
+                <a:ea typeface="Calibri" pitchFamily="34" charset="-122"/>
+                <a:cs typeface="Calibri" pitchFamily="34" charset="-120"/>
+              </a:rPr>
+              <a:t> de </a:t>
+            </a:r>
+            <a:r>
+              <a:rPr lang="en-US" sz="1050" dirty="0" err="1">
+                <a:solidFill>
+                  <a:srgbClr val="2C3E50"/>
+                </a:solidFill>
+                <a:latin typeface="Calibri" pitchFamily="34" charset="0"/>
+                <a:ea typeface="Calibri" pitchFamily="34" charset="-122"/>
+                <a:cs typeface="Calibri" pitchFamily="34" charset="-120"/>
+              </a:rPr>
+              <a:t>datos</a:t>
             </a:r>
             <a:endParaRPr lang="en-US" sz="1050" dirty="0"/>
           </a:p>
@@ -6578,7 +6847,51 @@
                 <a:ea typeface="Calibri" pitchFamily="34" charset="-122"/>
                 <a:cs typeface="Calibri" pitchFamily="34" charset="-120"/>
               </a:rPr>
-              <a:t>filtros de año y municipio dentro del dataset · respuestas compuestas (KPI + tendencia + per cápita).</a:t>
+              <a:t>filtros de año y municipio dentro del dataset · respuestas </a:t>
+            </a:r>
+            <a:r>
+              <a:rPr lang="en-US" sz="1100" dirty="0" err="1">
+                <a:solidFill>
+                  <a:srgbClr val="2C3E50"/>
+                </a:solidFill>
+                <a:latin typeface="Calibri" pitchFamily="34" charset="0"/>
+                <a:ea typeface="Calibri" pitchFamily="34" charset="-122"/>
+                <a:cs typeface="Calibri" pitchFamily="34" charset="-120"/>
+              </a:rPr>
+              <a:t>compuestas</a:t>
+            </a:r>
+            <a:r>
+              <a:rPr lang="en-US" sz="1100" dirty="0">
+                <a:solidFill>
+                  <a:srgbClr val="2C3E50"/>
+                </a:solidFill>
+                <a:latin typeface="Calibri" pitchFamily="34" charset="0"/>
+                <a:ea typeface="Calibri" pitchFamily="34" charset="-122"/>
+                <a:cs typeface="Calibri" pitchFamily="34" charset="-120"/>
+              </a:rPr>
+              <a:t> y cruces </a:t>
+            </a:r>
+            <a:r>
+              <a:rPr lang="en-US" sz="1100" dirty="0" err="1">
+                <a:solidFill>
+                  <a:srgbClr val="2C3E50"/>
+                </a:solidFill>
+                <a:latin typeface="Calibri" pitchFamily="34" charset="0"/>
+                <a:ea typeface="Calibri" pitchFamily="34" charset="-122"/>
+                <a:cs typeface="Calibri" pitchFamily="34" charset="-120"/>
+              </a:rPr>
+              <a:t>avanzados</a:t>
+            </a:r>
+            <a:r>
+              <a:rPr lang="en-US" sz="1100" dirty="0">
+                <a:solidFill>
+                  <a:srgbClr val="2C3E50"/>
+                </a:solidFill>
+                <a:latin typeface="Calibri" pitchFamily="34" charset="0"/>
+                <a:ea typeface="Calibri" pitchFamily="34" charset="-122"/>
+                <a:cs typeface="Calibri" pitchFamily="34" charset="-120"/>
+              </a:rPr>
+              <a:t> de datasets.</a:t>
             </a:r>
             <a:endParaRPr lang="en-US" sz="1100" dirty="0"/>
           </a:p>
@@ -7628,14 +7941,15 @@
         </p:nvPicPr>
         <p:blipFill>
           <a:blip r:embed="rId3"/>
+          <a:srcRect t="7082" r="30655" b="11432"/>
           <a:stretch>
             <a:fillRect/>
           </a:stretch>
         </p:blipFill>
         <p:spPr>
           <a:xfrm>
-            <a:off x="502920" y="1234440"/>
-            <a:ext cx="8138160" cy="4069080"/>
+            <a:off x="1487887" y="1130079"/>
+            <a:ext cx="6168225" cy="3624006"/>
           </a:xfrm>
           <a:prstGeom prst="rect">
             <a:avLst/>
@@ -7812,7 +8126,7 @@
         <p:spPr>
           <a:xfrm>
             <a:off x="502920" y="548640"/>
-            <a:ext cx="8138160" cy="502920"/>
+            <a:ext cx="8434346" cy="502920"/>
           </a:xfrm>
           <a:prstGeom prst="rect">
             <a:avLst/>
@@ -7828,7 +8142,7 @@
               <a:buNone/>
             </a:pPr>
             <a:r>
-              <a:rPr lang="en-US" sz="2700" b="1" dirty="0">
+              <a:rPr lang="en-US" sz="2400" b="1" dirty="0">
                 <a:solidFill>
                   <a:srgbClr val="0B3C5D"/>
                 </a:solidFill>
@@ -7838,7 +8152,7 @@
               </a:rPr>
               <a:t>Motor NL2SQL: generar no basta — hay que verificar</a:t>
             </a:r>
-            <a:endParaRPr lang="en-US" sz="2700" dirty="0"/>
+            <a:endParaRPr lang="en-US" sz="2400" dirty="0"/>
           </a:p>
         </p:txBody>
       </p:sp>
@@ -7852,14 +8166,15 @@
         </p:nvPicPr>
         <p:blipFill>
           <a:blip r:embed="rId3"/>
+          <a:srcRect l="1051" t="10551" r="15998" b="28115"/>
           <a:stretch>
             <a:fillRect/>
           </a:stretch>
         </p:blipFill>
         <p:spPr>
           <a:xfrm>
-            <a:off x="502920" y="1280160"/>
-            <a:ext cx="8138160" cy="3616960"/>
+            <a:off x="445787" y="1457076"/>
+            <a:ext cx="8252425" cy="2711929"/>
           </a:xfrm>
           <a:prstGeom prst="rect">
             <a:avLst/>
@@ -8052,7 +8367,7 @@
               <a:buNone/>
             </a:pPr>
             <a:r>
-              <a:rPr lang="en-US" sz="2700" b="1" dirty="0">
+              <a:rPr lang="en-US" sz="2400" b="1" dirty="0">
                 <a:solidFill>
                   <a:srgbClr val="0B3C5D"/>
                 </a:solidFill>
@@ -8062,7 +8377,7 @@
               </a:rPr>
               <a:t>Modelo de datos: una vista curada como fuente única</a:t>
             </a:r>
-            <a:endParaRPr lang="en-US" sz="2700" dirty="0"/>
+            <a:endParaRPr lang="en-US" sz="2400" dirty="0"/>
           </a:p>
         </p:txBody>
       </p:sp>
@@ -8074,7 +8389,7 @@
         </p:nvSpPr>
         <p:spPr>
           <a:xfrm>
-            <a:off x="502920" y="1298448"/>
+            <a:off x="502920" y="1172718"/>
             <a:ext cx="8138160" cy="658368"/>
           </a:xfrm>
           <a:prstGeom prst="rect">
@@ -9778,130 +10093,13 @@
       </p:grpSpPr>
       <p:sp>
         <p:nvSpPr>
-          <p:cNvPr id="2" name="Text 0"/>
-          <p:cNvSpPr/>
-          <p:nvPr/>
-        </p:nvSpPr>
-        <p:spPr>
-          <a:xfrm>
-            <a:off x="502920" y="292608"/>
-            <a:ext cx="8138160" cy="256032"/>
-          </a:xfrm>
-          <a:prstGeom prst="rect">
-            <a:avLst/>
-          </a:prstGeom>
-          <a:noFill/>
-          <a:ln/>
-        </p:spPr>
-        <p:txBody>
-          <a:bodyPr wrap="square" lIns="0" tIns="0" rIns="0" bIns="0" rtlCol="0" anchor="ctr"/>
-          <a:lstStyle/>
-          <a:p>
-            <a:pPr marL="0" indent="0">
-              <a:buNone/>
-            </a:pPr>
-            <a:r>
-              <a:rPr lang="en-US" sz="1100" b="1" kern="0" spc="200" dirty="0">
-                <a:solidFill>
-                  <a:srgbClr val="1ABC9C"/>
-                </a:solidFill>
-                <a:latin typeface="Trebuchet MS" pitchFamily="34" charset="0"/>
-                <a:ea typeface="Trebuchet MS" pitchFamily="34" charset="-122"/>
-                <a:cs typeface="Trebuchet MS" pitchFamily="34" charset="-120"/>
-              </a:rPr>
-              <a:t>RESPALDO TÉCNICO · B5</a:t>
-            </a:r>
-            <a:endParaRPr lang="en-US" sz="1100" dirty="0"/>
-          </a:p>
-        </p:txBody>
-      </p:sp>
-      <p:sp>
-        <p:nvSpPr>
-          <p:cNvPr id="3" name="Text 1"/>
-          <p:cNvSpPr/>
-          <p:nvPr/>
-        </p:nvSpPr>
-        <p:spPr>
-          <a:xfrm>
-            <a:off x="502920" y="548640"/>
-            <a:ext cx="8138160" cy="502920"/>
-          </a:xfrm>
-          <a:prstGeom prst="rect">
-            <a:avLst/>
-          </a:prstGeom>
-          <a:noFill/>
-          <a:ln/>
-        </p:spPr>
-        <p:txBody>
-          <a:bodyPr wrap="square" lIns="0" tIns="0" rIns="0" bIns="0" rtlCol="0" anchor="ctr"/>
-          <a:lstStyle/>
-          <a:p>
-            <a:pPr marL="0" indent="0">
-              <a:buNone/>
-            </a:pPr>
-            <a:r>
-              <a:rPr lang="en-US" sz="2700" b="1" dirty="0">
-                <a:solidFill>
-                  <a:srgbClr val="0B3C5D"/>
-                </a:solidFill>
-                <a:latin typeface="Trebuchet MS" pitchFamily="34" charset="0"/>
-                <a:ea typeface="Trebuchet MS" pitchFamily="34" charset="-122"/>
-                <a:cs typeface="Trebuchet MS" pitchFamily="34" charset="-120"/>
-              </a:rPr>
-              <a:t>Evaluación y trazabilidad</a:t>
-            </a:r>
-            <a:endParaRPr lang="en-US" sz="2700" dirty="0"/>
-          </a:p>
-        </p:txBody>
-      </p:sp>
-      <p:sp>
-        <p:nvSpPr>
-          <p:cNvPr id="4" name="Text 2"/>
-          <p:cNvSpPr/>
-          <p:nvPr/>
-        </p:nvSpPr>
-        <p:spPr>
-          <a:xfrm>
-            <a:off x="502920" y="1298448"/>
-            <a:ext cx="8138160" cy="621792"/>
-          </a:xfrm>
-          <a:prstGeom prst="rect">
-            <a:avLst/>
-          </a:prstGeom>
-          <a:noFill/>
-          <a:ln/>
-        </p:spPr>
-        <p:txBody>
-          <a:bodyPr wrap="square" lIns="0" tIns="0" rIns="0" bIns="0" rtlCol="0" anchor="ctr"/>
-          <a:lstStyle/>
-          <a:p>
-            <a:pPr marL="0" indent="0">
-              <a:buNone/>
-            </a:pPr>
-            <a:r>
-              <a:rPr lang="en-US" sz="1200" dirty="0">
-                <a:solidFill>
-                  <a:srgbClr val="2C3E50"/>
-                </a:solidFill>
-                <a:latin typeface="Calibri" pitchFamily="34" charset="0"/>
-                <a:ea typeface="Calibri" pitchFamily="34" charset="-122"/>
-                <a:cs typeface="Calibri" pitchFamily="34" charset="-120"/>
-              </a:rPr>
-              <a:t>El motor se prueba en dos frentes: uno técnico, con casos de referencia versionados, y uno ciudadano, con preguntas reales cuya respuesta esperada se escribió antes de correrlas. Los patrones que fallan se convierten en mejoras estructurales y el ciclo se repite.</a:t>
-            </a:r>
-            <a:endParaRPr lang="en-US" sz="1200" dirty="0"/>
-          </a:p>
-        </p:txBody>
-      </p:sp>
-      <p:sp>
-        <p:nvSpPr>
-          <p:cNvPr id="5" name="Shape 3"/>
-          <p:cNvSpPr/>
-          <p:nvPr/>
-        </p:nvSpPr>
-        <p:spPr>
-          <a:xfrm>
-            <a:off x="502920" y="2057400"/>
+          <p:cNvPr id="9" name="Shape 6"/>
+          <p:cNvSpPr/>
+          <p:nvPr/>
+        </p:nvSpPr>
+        <p:spPr>
+          <a:xfrm>
+            <a:off x="4709160" y="2057400"/>
             <a:ext cx="3931920" cy="1097280"/>
           </a:xfrm>
           <a:prstGeom prst="roundRect">
@@ -9922,6 +10120,152 @@
           </a:effectLst>
         </p:spPr>
       </p:sp>
+      <p:sp>
+        <p:nvSpPr>
+          <p:cNvPr id="2" name="Text 0"/>
+          <p:cNvSpPr/>
+          <p:nvPr/>
+        </p:nvSpPr>
+        <p:spPr>
+          <a:xfrm>
+            <a:off x="502920" y="292608"/>
+            <a:ext cx="8138160" cy="256032"/>
+          </a:xfrm>
+          <a:prstGeom prst="rect">
+            <a:avLst/>
+          </a:prstGeom>
+          <a:noFill/>
+          <a:ln/>
+        </p:spPr>
+        <p:txBody>
+          <a:bodyPr wrap="square" lIns="0" tIns="0" rIns="0" bIns="0" rtlCol="0" anchor="ctr"/>
+          <a:lstStyle/>
+          <a:p>
+            <a:pPr marL="0" indent="0">
+              <a:buNone/>
+            </a:pPr>
+            <a:r>
+              <a:rPr lang="en-US" sz="1100" b="1" kern="0" spc="200" dirty="0">
+                <a:solidFill>
+                  <a:srgbClr val="1ABC9C"/>
+                </a:solidFill>
+                <a:latin typeface="Trebuchet MS" pitchFamily="34" charset="0"/>
+                <a:ea typeface="Trebuchet MS" pitchFamily="34" charset="-122"/>
+                <a:cs typeface="Trebuchet MS" pitchFamily="34" charset="-120"/>
+              </a:rPr>
+              <a:t>RESPALDO TÉCNICO · B5</a:t>
+            </a:r>
+            <a:endParaRPr lang="en-US" sz="1100" dirty="0"/>
+          </a:p>
+        </p:txBody>
+      </p:sp>
+      <p:sp>
+        <p:nvSpPr>
+          <p:cNvPr id="3" name="Text 1"/>
+          <p:cNvSpPr/>
+          <p:nvPr/>
+        </p:nvSpPr>
+        <p:spPr>
+          <a:xfrm>
+            <a:off x="502920" y="548640"/>
+            <a:ext cx="8138160" cy="502920"/>
+          </a:xfrm>
+          <a:prstGeom prst="rect">
+            <a:avLst/>
+          </a:prstGeom>
+          <a:noFill/>
+          <a:ln/>
+        </p:spPr>
+        <p:txBody>
+          <a:bodyPr wrap="square" lIns="0" tIns="0" rIns="0" bIns="0" rtlCol="0" anchor="ctr"/>
+          <a:lstStyle/>
+          <a:p>
+            <a:pPr marL="0" indent="0">
+              <a:buNone/>
+            </a:pPr>
+            <a:r>
+              <a:rPr lang="en-US" sz="2700" b="1" dirty="0">
+                <a:solidFill>
+                  <a:srgbClr val="0B3C5D"/>
+                </a:solidFill>
+                <a:latin typeface="Trebuchet MS" pitchFamily="34" charset="0"/>
+                <a:ea typeface="Trebuchet MS" pitchFamily="34" charset="-122"/>
+                <a:cs typeface="Trebuchet MS" pitchFamily="34" charset="-120"/>
+              </a:rPr>
+              <a:t>Evaluación y trazabilidad</a:t>
+            </a:r>
+            <a:endParaRPr lang="en-US" sz="2700" dirty="0"/>
+          </a:p>
+        </p:txBody>
+      </p:sp>
+      <p:sp>
+        <p:nvSpPr>
+          <p:cNvPr id="4" name="Text 2"/>
+          <p:cNvSpPr/>
+          <p:nvPr/>
+        </p:nvSpPr>
+        <p:spPr>
+          <a:xfrm>
+            <a:off x="502920" y="1298448"/>
+            <a:ext cx="8138160" cy="621792"/>
+          </a:xfrm>
+          <a:prstGeom prst="rect">
+            <a:avLst/>
+          </a:prstGeom>
+          <a:noFill/>
+          <a:ln/>
+        </p:spPr>
+        <p:txBody>
+          <a:bodyPr wrap="square" lIns="0" tIns="0" rIns="0" bIns="0" rtlCol="0" anchor="ctr"/>
+          <a:lstStyle/>
+          <a:p>
+            <a:pPr marL="0" indent="0">
+              <a:buNone/>
+            </a:pPr>
+            <a:r>
+              <a:rPr lang="en-US" sz="1200" dirty="0">
+                <a:solidFill>
+                  <a:srgbClr val="2C3E50"/>
+                </a:solidFill>
+                <a:latin typeface="Calibri" pitchFamily="34" charset="0"/>
+                <a:ea typeface="Calibri" pitchFamily="34" charset="-122"/>
+                <a:cs typeface="Calibri" pitchFamily="34" charset="-120"/>
+              </a:rPr>
+              <a:t>El motor se prueba en dos frentes: uno técnico, con casos de referencia versionados, y uno ciudadano, con preguntas reales cuya respuesta esperada se escribió antes de correrlas. Los patrones que fallan se convierten en mejoras estructurales y el ciclo se repite.</a:t>
+            </a:r>
+            <a:endParaRPr lang="en-US" sz="1200" dirty="0"/>
+          </a:p>
+        </p:txBody>
+      </p:sp>
+      <p:sp>
+        <p:nvSpPr>
+          <p:cNvPr id="5" name="Shape 3"/>
+          <p:cNvSpPr/>
+          <p:nvPr/>
+        </p:nvSpPr>
+        <p:spPr>
+          <a:xfrm>
+            <a:off x="502920" y="2057400"/>
+            <a:ext cx="3931920" cy="1097280"/>
+          </a:xfrm>
+          <a:prstGeom prst="roundRect">
+            <a:avLst>
+              <a:gd name="adj" fmla="val 5000"/>
+            </a:avLst>
+          </a:prstGeom>
+          <a:solidFill>
+            <a:srgbClr val="FFFFFF"/>
+          </a:solidFill>
+          <a:ln/>
+          <a:effectLst>
+            <a:outerShdw algn="bl" rotWithShape="0">
+              <a:srgbClr val="1A2530">
+                <a:alpha val="0"/>
+              </a:srgbClr>
+            </a:outerShdw>
+          </a:effectLst>
+        </p:spPr>
+      </p:sp>
       <p:pic>
         <p:nvPicPr>
           <p:cNvPr id="6" name="Image 0" descr="preencoded.png"/>
@@ -10026,13 +10370,91 @@
       </p:sp>
       <p:sp>
         <p:nvSpPr>
-          <p:cNvPr id="9" name="Shape 6"/>
-          <p:cNvSpPr/>
-          <p:nvPr/>
-        </p:nvSpPr>
-        <p:spPr>
-          <a:xfrm>
-            <a:off x="4709160" y="2057400"/>
+          <p:cNvPr id="11" name="Text 7"/>
+          <p:cNvSpPr/>
+          <p:nvPr/>
+        </p:nvSpPr>
+        <p:spPr>
+          <a:xfrm>
+            <a:off x="5330952" y="2157984"/>
+            <a:ext cx="3154680" cy="274320"/>
+          </a:xfrm>
+          <a:prstGeom prst="rect">
+            <a:avLst/>
+          </a:prstGeom>
+          <a:noFill/>
+          <a:ln/>
+        </p:spPr>
+        <p:txBody>
+          <a:bodyPr wrap="square" lIns="0" tIns="0" rIns="0" bIns="0" rtlCol="0" anchor="ctr"/>
+          <a:lstStyle/>
+          <a:p>
+            <a:pPr marL="0" indent="0">
+              <a:buNone/>
+            </a:pPr>
+            <a:r>
+              <a:rPr lang="en-US" sz="1150" b="1" dirty="0">
+                <a:solidFill>
+                  <a:srgbClr val="0B3C5D"/>
+                </a:solidFill>
+                <a:latin typeface="Trebuchet MS" pitchFamily="34" charset="0"/>
+                <a:ea typeface="Trebuchet MS" pitchFamily="34" charset="-122"/>
+                <a:cs typeface="Trebuchet MS" pitchFamily="34" charset="-120"/>
+              </a:rPr>
+              <a:t>Ciclo ciudadano de 50 preguntas</a:t>
+            </a:r>
+            <a:endParaRPr lang="en-US" sz="1150" dirty="0"/>
+          </a:p>
+        </p:txBody>
+      </p:sp>
+      <p:sp>
+        <p:nvSpPr>
+          <p:cNvPr id="12" name="Text 8"/>
+          <p:cNvSpPr/>
+          <p:nvPr/>
+        </p:nvSpPr>
+        <p:spPr>
+          <a:xfrm>
+            <a:off x="5330952" y="2441448"/>
+            <a:ext cx="3154680" cy="685800"/>
+          </a:xfrm>
+          <a:prstGeom prst="rect">
+            <a:avLst/>
+          </a:prstGeom>
+          <a:noFill/>
+          <a:ln/>
+        </p:spPr>
+        <p:txBody>
+          <a:bodyPr wrap="square" lIns="0" tIns="0" rIns="0" bIns="0" rtlCol="0" anchor="ctr"/>
+          <a:lstStyle/>
+          <a:p>
+            <a:pPr marL="0" indent="0">
+              <a:buNone/>
+            </a:pPr>
+            <a:r>
+              <a:rPr lang="en-US" sz="900" dirty="0">
+                <a:solidFill>
+                  <a:srgbClr val="2C3E50"/>
+                </a:solidFill>
+                <a:latin typeface="Calibri" pitchFamily="34" charset="0"/>
+                <a:ea typeface="Calibri" pitchFamily="34" charset="-122"/>
+                <a:cs typeface="Calibri" pitchFamily="34" charset="-120"/>
+              </a:rPr>
+              <a:t>Cada pregunta tiene respuesta esperada pre-registrada. Las fallas detectadas produjeron mejoras concretas: re-ranking semántico, respuesta de totales y honestidad de lejanía.</a:t>
+            </a:r>
+            <a:endParaRPr lang="en-US" sz="900" dirty="0"/>
+          </a:p>
+        </p:txBody>
+      </p:sp>
+      <p:sp>
+        <p:nvSpPr>
+          <p:cNvPr id="13" name="Shape 9"/>
+          <p:cNvSpPr/>
+          <p:nvPr/>
+        </p:nvSpPr>
+        <p:spPr>
+          <a:xfrm>
+            <a:off x="502920" y="3291840"/>
             <a:ext cx="3931920" cy="1097280"/>
           </a:xfrm>
           <a:prstGeom prst="roundRect">
@@ -10055,7 +10477,7 @@
       </p:sp>
       <p:pic>
         <p:nvPicPr>
-          <p:cNvPr id="10" name="Image 1" descr="preencoded.png"/>
+          <p:cNvPr id="14" name="Image 2" descr="preencoded.png"/>
           <p:cNvPicPr>
             <a:picLocks noChangeAspect="1"/>
           </p:cNvPicPr>
@@ -10069,7 +10491,7 @@
         </p:blipFill>
         <p:spPr>
           <a:xfrm>
-            <a:off x="4892040" y="2240280"/>
+            <a:off x="685800" y="3474720"/>
             <a:ext cx="310896" cy="310896"/>
           </a:xfrm>
           <a:prstGeom prst="rect">
@@ -10079,13 +10501,13 @@
       </p:pic>
       <p:sp>
         <p:nvSpPr>
-          <p:cNvPr id="11" name="Text 7"/>
-          <p:cNvSpPr/>
-          <p:nvPr/>
-        </p:nvSpPr>
-        <p:spPr>
-          <a:xfrm>
-            <a:off x="5330952" y="2157984"/>
+          <p:cNvPr id="15" name="Text 10"/>
+          <p:cNvSpPr/>
+          <p:nvPr/>
+        </p:nvSpPr>
+        <p:spPr>
+          <a:xfrm>
+            <a:off x="1124712" y="3392424"/>
             <a:ext cx="3154680" cy="274320"/>
           </a:xfrm>
           <a:prstGeom prst="rect">
@@ -10110,7 +10532,7 @@
                 <a:ea typeface="Trebuchet MS" pitchFamily="34" charset="-122"/>
                 <a:cs typeface="Trebuchet MS" pitchFamily="34" charset="-120"/>
               </a:rPr>
-              <a:t>Ciclo ciudadano de 50 preguntas</a:t>
+              <a:t>36 archivos de pruebas</a:t>
             </a:r>
             <a:endParaRPr lang="en-US" sz="1150" dirty="0"/>
           </a:p>
@@ -10118,13 +10540,13 @@
       </p:sp>
       <p:sp>
         <p:nvSpPr>
-          <p:cNvPr id="12" name="Text 8"/>
-          <p:cNvSpPr/>
-          <p:nvPr/>
-        </p:nvSpPr>
-        <p:spPr>
-          <a:xfrm>
-            <a:off x="5330952" y="2441448"/>
+          <p:cNvPr id="16" name="Text 11"/>
+          <p:cNvSpPr/>
+          <p:nvPr/>
+        </p:nvSpPr>
+        <p:spPr>
+          <a:xfrm>
+            <a:off x="1124712" y="3675888"/>
             <a:ext cx="3154680" cy="685800"/>
           </a:xfrm>
           <a:prstGeom prst="rect">
@@ -10149,7 +10571,7 @@
                 <a:ea typeface="Calibri" pitchFamily="34" charset="-122"/>
                 <a:cs typeface="Calibri" pitchFamily="34" charset="-120"/>
               </a:rPr>
-              <a:t>Cada pregunta tiene respuesta esperada pre-registrada. Las fallas detectadas produjeron mejoras concretas: re-ranking semántico, respuesta de totales y honestidad de lejanía.</a:t>
+              <a:t>Cubren el verificador SoQL, el validador anti-alucinación, la reparación, la inferencia territorial, la cosecha, el MCP y las rutas de la API.</a:t>
             </a:r>
             <a:endParaRPr lang="en-US" sz="900" dirty="0"/>
           </a:p>
@@ -10157,13 +10579,13 @@
       </p:sp>
       <p:sp>
         <p:nvSpPr>
-          <p:cNvPr id="13" name="Shape 9"/>
-          <p:cNvSpPr/>
-          <p:nvPr/>
-        </p:nvSpPr>
-        <p:spPr>
-          <a:xfrm>
-            <a:off x="502920" y="3291840"/>
+          <p:cNvPr id="17" name="Shape 12"/>
+          <p:cNvSpPr/>
+          <p:nvPr/>
+        </p:nvSpPr>
+        <p:spPr>
+          <a:xfrm>
+            <a:off x="4709160" y="3291840"/>
             <a:ext cx="3931920" cy="1097280"/>
           </a:xfrm>
           <a:prstGeom prst="roundRect">
@@ -10186,7 +10608,7 @@
       </p:sp>
       <p:pic>
         <p:nvPicPr>
-          <p:cNvPr id="14" name="Image 2" descr="preencoded.png"/>
+          <p:cNvPr id="18" name="Image 3" descr="preencoded.png"/>
           <p:cNvPicPr>
             <a:picLocks noChangeAspect="1"/>
           </p:cNvPicPr>
@@ -10200,7 +10622,7 @@
         </p:blipFill>
         <p:spPr>
           <a:xfrm>
-            <a:off x="685800" y="3474720"/>
+            <a:off x="4892040" y="3474720"/>
             <a:ext cx="310896" cy="310896"/>
           </a:xfrm>
           <a:prstGeom prst="rect">
@@ -10210,13 +10632,13 @@
       </p:pic>
       <p:sp>
         <p:nvSpPr>
-          <p:cNvPr id="15" name="Text 10"/>
-          <p:cNvSpPr/>
-          <p:nvPr/>
-        </p:nvSpPr>
-        <p:spPr>
-          <a:xfrm>
-            <a:off x="1124712" y="3392424"/>
+          <p:cNvPr id="19" name="Text 13"/>
+          <p:cNvSpPr/>
+          <p:nvPr/>
+        </p:nvSpPr>
+        <p:spPr>
+          <a:xfrm>
+            <a:off x="5330952" y="3392424"/>
             <a:ext cx="3154680" cy="274320"/>
           </a:xfrm>
           <a:prstGeom prst="rect">
@@ -10241,7 +10663,7 @@
                 <a:ea typeface="Trebuchet MS" pitchFamily="34" charset="-122"/>
                 <a:cs typeface="Trebuchet MS" pitchFamily="34" charset="-120"/>
               </a:rPr>
-              <a:t>36 archivos de pruebas</a:t>
+              <a:t>Decisiones documentadas (ADRs)</a:t>
             </a:r>
             <a:endParaRPr lang="en-US" sz="1150" dirty="0"/>
           </a:p>
@@ -10249,13 +10671,13 @@
       </p:sp>
       <p:sp>
         <p:nvSpPr>
-          <p:cNvPr id="16" name="Text 11"/>
-          <p:cNvSpPr/>
-          <p:nvPr/>
-        </p:nvSpPr>
-        <p:spPr>
-          <a:xfrm>
-            <a:off x="1124712" y="3675888"/>
+          <p:cNvPr id="20" name="Text 14"/>
+          <p:cNvSpPr/>
+          <p:nvPr/>
+        </p:nvSpPr>
+        <p:spPr>
+          <a:xfrm>
+            <a:off x="5330952" y="3675888"/>
             <a:ext cx="3154680" cy="685800"/>
           </a:xfrm>
           <a:prstGeom prst="rect">
@@ -10280,7 +10702,7 @@
                 <a:ea typeface="Calibri" pitchFamily="34" charset="-122"/>
                 <a:cs typeface="Calibri" pitchFamily="34" charset="-120"/>
               </a:rPr>
-              <a:t>Cubren el verificador SoQL, el validador anti-alucinación, la reparación, la inferencia territorial, la cosecha, el MCP y las rutas de la API.</a:t>
+              <a:t>Los registros públicos de decisión (017-024) trazan cada giro técnico, del principio “la IA razona, el motor verifica” al pivote panorama-decisor.</a:t>
             </a:r>
             <a:endParaRPr lang="en-US" sz="900" dirty="0"/>
           </a:p>
@@ -10288,36 +10710,102 @@
       </p:sp>
       <p:sp>
         <p:nvSpPr>
-          <p:cNvPr id="17" name="Shape 12"/>
-          <p:cNvSpPr/>
-          <p:nvPr/>
-        </p:nvSpPr>
-        <p:spPr>
-          <a:xfrm>
-            <a:off x="4709160" y="3291840"/>
-            <a:ext cx="3931920" cy="1097280"/>
-          </a:xfrm>
-          <a:prstGeom prst="roundRect">
-            <a:avLst>
-              <a:gd name="adj" fmla="val 5000"/>
-            </a:avLst>
-          </a:prstGeom>
-          <a:solidFill>
-            <a:srgbClr val="FFFFFF"/>
-          </a:solidFill>
-          <a:ln/>
-          <a:effectLst>
-            <a:outerShdw algn="bl" rotWithShape="0">
-              <a:srgbClr val="1A2530">
-                <a:alpha val="0"/>
-              </a:srgbClr>
-            </a:outerShdw>
-          </a:effectLst>
-        </p:spPr>
+          <p:cNvPr id="21" name="Text 15"/>
+          <p:cNvSpPr/>
+          <p:nvPr/>
+        </p:nvSpPr>
+        <p:spPr>
+          <a:xfrm>
+            <a:off x="502920" y="4832604"/>
+            <a:ext cx="7680960" cy="228600"/>
+          </a:xfrm>
+          <a:prstGeom prst="rect">
+            <a:avLst/>
+          </a:prstGeom>
+          <a:noFill/>
+          <a:ln/>
+        </p:spPr>
+        <p:txBody>
+          <a:bodyPr wrap="square" lIns="0" tIns="0" rIns="0" bIns="0" rtlCol="0" anchor="ctr"/>
+          <a:lstStyle/>
+          <a:p>
+            <a:pPr marL="0" indent="0">
+              <a:buNone/>
+            </a:pPr>
+            <a:r>
+              <a:rPr lang="en-US" sz="850" b="1" dirty="0">
+                <a:solidFill>
+                  <a:srgbClr val="0B3C5D"/>
+                </a:solidFill>
+                <a:latin typeface="Calibri" pitchFamily="34" charset="0"/>
+                <a:ea typeface="Calibri" pitchFamily="34" charset="-122"/>
+                <a:cs typeface="Calibri" pitchFamily="34" charset="-120"/>
+              </a:rPr>
+              <a:t>DatosVivos · datosvivos.co</a:t>
+            </a:r>
+            <a:r>
+              <a:rPr lang="en-US" sz="850" dirty="0">
+                <a:solidFill>
+                  <a:srgbClr val="7F8C8D"/>
+                </a:solidFill>
+                <a:latin typeface="Calibri" pitchFamily="34" charset="0"/>
+                <a:ea typeface="Calibri" pitchFamily="34" charset="-122"/>
+                <a:cs typeface="Calibri" pitchFamily="34" charset="-120"/>
+              </a:rPr>
+              <a:t>   |   Datos al Ecosistema 2026 · Equipo 93 · Reto 7 · Nivel Avanzado</a:t>
+            </a:r>
+            <a:endParaRPr lang="en-US" sz="850" dirty="0"/>
+          </a:p>
+        </p:txBody>
+      </p:sp>
+      <p:sp>
+        <p:nvSpPr>
+          <p:cNvPr id="22" name="Text 16"/>
+          <p:cNvSpPr/>
+          <p:nvPr/>
+        </p:nvSpPr>
+        <p:spPr>
+          <a:xfrm>
+            <a:off x="8275320" y="4832604"/>
+            <a:ext cx="365760" cy="228600"/>
+          </a:xfrm>
+          <a:prstGeom prst="rect">
+            <a:avLst/>
+          </a:prstGeom>
+          <a:noFill/>
+          <a:ln/>
+        </p:spPr>
+        <p:txBody>
+          <a:bodyPr wrap="square" lIns="0" tIns="0" rIns="0" bIns="0" rtlCol="0" anchor="ctr"/>
+          <a:lstStyle/>
+          <a:p>
+            <a:pPr marL="0" indent="0" algn="r">
+              <a:buNone/>
+            </a:pPr>
+            <a:r>
+              <a:rPr lang="en-US" sz="850" dirty="0">
+                <a:solidFill>
+                  <a:srgbClr val="7F8C8D"/>
+                </a:solidFill>
+                <a:latin typeface="Calibri" pitchFamily="34" charset="0"/>
+                <a:ea typeface="Calibri" pitchFamily="34" charset="-122"/>
+                <a:cs typeface="Calibri" pitchFamily="34" charset="-120"/>
+              </a:rPr>
+              <a:t>18</a:t>
+            </a:r>
+            <a:endParaRPr lang="en-US" sz="850" dirty="0"/>
+          </a:p>
+        </p:txBody>
       </p:sp>
       <p:pic>
         <p:nvPicPr>
-          <p:cNvPr id="18" name="Image 3" descr="preencoded.png"/>
+          <p:cNvPr id="23" name="Image 1" descr="preencoded.png">
+            <a:extLst>
+              <a:ext uri="{FF2B5EF4-FFF2-40B4-BE49-F238E27FC236}">
+                <a16:creationId xmlns:a16="http://schemas.microsoft.com/office/drawing/2014/main" id="{5D094D1C-ECA2-FE52-7421-7D627AB2024B}"/>
+              </a:ext>
+            </a:extLst>
+          </p:cNvPr>
           <p:cNvPicPr>
             <a:picLocks noChangeAspect="1"/>
           </p:cNvPicPr>
@@ -10331,7 +10819,7 @@
         </p:blipFill>
         <p:spPr>
           <a:xfrm>
-            <a:off x="4892040" y="3474720"/>
+            <a:off x="4892040" y="2240280"/>
             <a:ext cx="310896" cy="310896"/>
           </a:xfrm>
           <a:prstGeom prst="rect">
@@ -10339,173 +10827,36 @@
           </a:prstGeom>
         </p:spPr>
       </p:pic>
-      <p:sp>
-        <p:nvSpPr>
-          <p:cNvPr id="19" name="Text 13"/>
-          <p:cNvSpPr/>
-          <p:nvPr/>
-        </p:nvSpPr>
-        <p:spPr>
-          <a:xfrm>
-            <a:off x="5330952" y="3392424"/>
-            <a:ext cx="3154680" cy="274320"/>
-          </a:xfrm>
-          <a:prstGeom prst="rect">
-            <a:avLst/>
-          </a:prstGeom>
-          <a:noFill/>
-          <a:ln/>
-        </p:spPr>
-        <p:txBody>
-          <a:bodyPr wrap="square" lIns="0" tIns="0" rIns="0" bIns="0" rtlCol="0" anchor="ctr"/>
-          <a:lstStyle/>
-          <a:p>
-            <a:pPr marL="0" indent="0">
-              <a:buNone/>
-            </a:pPr>
-            <a:r>
-              <a:rPr lang="en-US" sz="1150" b="1" dirty="0">
-                <a:solidFill>
-                  <a:srgbClr val="0B3C5D"/>
-                </a:solidFill>
-                <a:latin typeface="Trebuchet MS" pitchFamily="34" charset="0"/>
-                <a:ea typeface="Trebuchet MS" pitchFamily="34" charset="-122"/>
-                <a:cs typeface="Trebuchet MS" pitchFamily="34" charset="-120"/>
-              </a:rPr>
-              <a:t>Decisiones documentadas (ADRs)</a:t>
-            </a:r>
-            <a:endParaRPr lang="en-US" sz="1150" dirty="0"/>
-          </a:p>
-        </p:txBody>
-      </p:sp>
-      <p:sp>
-        <p:nvSpPr>
-          <p:cNvPr id="20" name="Text 14"/>
-          <p:cNvSpPr/>
-          <p:nvPr/>
-        </p:nvSpPr>
-        <p:spPr>
-          <a:xfrm>
-            <a:off x="5330952" y="3675888"/>
-            <a:ext cx="3154680" cy="685800"/>
-          </a:xfrm>
-          <a:prstGeom prst="rect">
-            <a:avLst/>
-          </a:prstGeom>
-          <a:noFill/>
-          <a:ln/>
-        </p:spPr>
-        <p:txBody>
-          <a:bodyPr wrap="square" lIns="0" tIns="0" rIns="0" bIns="0" rtlCol="0" anchor="ctr"/>
-          <a:lstStyle/>
-          <a:p>
-            <a:pPr marL="0" indent="0">
-              <a:buNone/>
-            </a:pPr>
-            <a:r>
-              <a:rPr lang="en-US" sz="900" dirty="0">
-                <a:solidFill>
-                  <a:srgbClr val="2C3E50"/>
-                </a:solidFill>
-                <a:latin typeface="Calibri" pitchFamily="34" charset="0"/>
-                <a:ea typeface="Calibri" pitchFamily="34" charset="-122"/>
-                <a:cs typeface="Calibri" pitchFamily="34" charset="-120"/>
-              </a:rPr>
-              <a:t>Los registros públicos de decisión (017-024) trazan cada giro técnico, del principio “la IA razona, el motor verifica” al pivote panorama-decisor.</a:t>
-            </a:r>
-            <a:endParaRPr lang="en-US" sz="900" dirty="0"/>
-          </a:p>
-        </p:txBody>
-      </p:sp>
-      <p:sp>
-        <p:nvSpPr>
-          <p:cNvPr id="21" name="Text 15"/>
-          <p:cNvSpPr/>
-          <p:nvPr/>
-        </p:nvSpPr>
-        <p:spPr>
-          <a:xfrm>
-            <a:off x="502920" y="4832604"/>
-            <a:ext cx="7680960" cy="228600"/>
-          </a:xfrm>
-          <a:prstGeom prst="rect">
-            <a:avLst/>
-          </a:prstGeom>
-          <a:noFill/>
-          <a:ln/>
-        </p:spPr>
-        <p:txBody>
-          <a:bodyPr wrap="square" lIns="0" tIns="0" rIns="0" bIns="0" rtlCol="0" anchor="ctr"/>
-          <a:lstStyle/>
-          <a:p>
-            <a:pPr marL="0" indent="0">
-              <a:buNone/>
-            </a:pPr>
-            <a:r>
-              <a:rPr lang="en-US" sz="850" b="1" dirty="0">
-                <a:solidFill>
-                  <a:srgbClr val="0B3C5D"/>
-                </a:solidFill>
-                <a:latin typeface="Calibri" pitchFamily="34" charset="0"/>
-                <a:ea typeface="Calibri" pitchFamily="34" charset="-122"/>
-                <a:cs typeface="Calibri" pitchFamily="34" charset="-120"/>
-              </a:rPr>
-              <a:t>DatosVivos · datosvivos.co</a:t>
-            </a:r>
-            <a:r>
-              <a:rPr lang="en-US" sz="850" dirty="0">
-                <a:solidFill>
-                  <a:srgbClr val="7F8C8D"/>
-                </a:solidFill>
-                <a:latin typeface="Calibri" pitchFamily="34" charset="0"/>
-                <a:ea typeface="Calibri" pitchFamily="34" charset="-122"/>
-                <a:cs typeface="Calibri" pitchFamily="34" charset="-120"/>
-              </a:rPr>
-              <a:t>   |   Datos al Ecosistema 2026 · Equipo 93 · Reto 7 · Nivel Avanzado</a:t>
-            </a:r>
-            <a:endParaRPr lang="en-US" sz="850" dirty="0"/>
-          </a:p>
-        </p:txBody>
-      </p:sp>
-      <p:sp>
-        <p:nvSpPr>
-          <p:cNvPr id="22" name="Text 16"/>
-          <p:cNvSpPr/>
-          <p:nvPr/>
-        </p:nvSpPr>
-        <p:spPr>
-          <a:xfrm>
-            <a:off x="8275320" y="4832604"/>
-            <a:ext cx="365760" cy="228600"/>
-          </a:xfrm>
-          <a:prstGeom prst="rect">
-            <a:avLst/>
-          </a:prstGeom>
-          <a:noFill/>
-          <a:ln/>
-        </p:spPr>
-        <p:txBody>
-          <a:bodyPr wrap="square" lIns="0" tIns="0" rIns="0" bIns="0" rtlCol="0" anchor="ctr"/>
-          <a:lstStyle/>
-          <a:p>
-            <a:pPr marL="0" indent="0" algn="r">
-              <a:buNone/>
-            </a:pPr>
-            <a:r>
-              <a:rPr lang="en-US" sz="850" dirty="0">
-                <a:solidFill>
-                  <a:srgbClr val="7F8C8D"/>
-                </a:solidFill>
-                <a:latin typeface="Calibri" pitchFamily="34" charset="0"/>
-                <a:ea typeface="Calibri" pitchFamily="34" charset="-122"/>
-                <a:cs typeface="Calibri" pitchFamily="34" charset="-120"/>
-              </a:rPr>
-              <a:t>18</a:t>
-            </a:r>
-            <a:endParaRPr lang="en-US" sz="850" dirty="0"/>
-          </a:p>
-        </p:txBody>
-      </p:sp>
+      <p:pic>
+        <p:nvPicPr>
+          <p:cNvPr id="24" name="Image 3" descr="preencoded.png">
+            <a:extLst>
+              <a:ext uri="{FF2B5EF4-FFF2-40B4-BE49-F238E27FC236}">
+                <a16:creationId xmlns:a16="http://schemas.microsoft.com/office/drawing/2014/main" id="{5FC96C83-32CC-8A3D-5993-698800C1E89C}"/>
+              </a:ext>
+            </a:extLst>
+          </p:cNvPr>
+          <p:cNvPicPr>
+            <a:picLocks noChangeAspect="1"/>
+          </p:cNvPicPr>
+          <p:nvPr/>
+        </p:nvPicPr>
+        <p:blipFill>
+          <a:blip r:embed="rId5"/>
+          <a:stretch>
+            <a:fillRect/>
+          </a:stretch>
+        </p:blipFill>
+        <p:spPr>
+          <a:xfrm>
+            <a:off x="4864608" y="2291467"/>
+            <a:ext cx="310896" cy="310896"/>
+          </a:xfrm>
+          <a:prstGeom prst="rect">
+            <a:avLst/>
+          </a:prstGeom>
+        </p:spPr>
+      </p:pic>
     </p:spTree>
   </p:cSld>
   <p:clrMapOvr>
@@ -11288,7 +11639,7 @@
               <a:buNone/>
             </a:pPr>
             <a:r>
-              <a:rPr lang="en-US" sz="1450" b="1" dirty="0">
+              <a:rPr lang="en-US" sz="1400" b="1" dirty="0">
                 <a:solidFill>
                   <a:srgbClr val="0B3C5D"/>
                 </a:solidFill>
@@ -11296,9 +11647,42 @@
                 <a:ea typeface="Trebuchet MS" pitchFamily="34" charset="-122"/>
                 <a:cs typeface="Trebuchet MS" pitchFamily="34" charset="-120"/>
               </a:rPr>
-              <a:t>El dato público existe — pero nadie puede verlo completo ni usarlo sin conocimientos técnicos.</a:t>
-            </a:r>
-            <a:endParaRPr lang="en-US" sz="1450" dirty="0"/>
+              <a:t>El dato público existe — pero nadie puede verlo completo ni usarlo sin </a:t>
+            </a:r>
+            <a:r>
+              <a:rPr lang="en-US" sz="1400" b="1" dirty="0" err="1">
+                <a:solidFill>
+                  <a:srgbClr val="0B3C5D"/>
+                </a:solidFill>
+                <a:latin typeface="Trebuchet MS" pitchFamily="34" charset="0"/>
+                <a:ea typeface="Trebuchet MS" pitchFamily="34" charset="-122"/>
+                <a:cs typeface="Trebuchet MS" pitchFamily="34" charset="-120"/>
+              </a:rPr>
+              <a:t>conocimientos</a:t>
+            </a:r>
+            <a:r>
+              <a:rPr lang="en-US" sz="1400" b="1" dirty="0">
+                <a:solidFill>
+                  <a:srgbClr val="0B3C5D"/>
+                </a:solidFill>
+                <a:latin typeface="Trebuchet MS" pitchFamily="34" charset="0"/>
+                <a:ea typeface="Trebuchet MS" pitchFamily="34" charset="-122"/>
+                <a:cs typeface="Trebuchet MS" pitchFamily="34" charset="-120"/>
+              </a:rPr>
+              <a:t> </a:t>
+            </a:r>
+            <a:r>
+              <a:rPr lang="en-US" sz="1400" b="1" dirty="0" err="1">
+                <a:solidFill>
+                  <a:srgbClr val="0B3C5D"/>
+                </a:solidFill>
+                <a:latin typeface="Trebuchet MS" pitchFamily="34" charset="0"/>
+                <a:ea typeface="Trebuchet MS" pitchFamily="34" charset="-122"/>
+                <a:cs typeface="Trebuchet MS" pitchFamily="34" charset="-120"/>
+              </a:rPr>
+              <a:t>técnicos</a:t>
+            </a:r>
+            <a:endParaRPr lang="en-US" sz="1400" dirty="0"/>
           </a:p>
         </p:txBody>
       </p:sp>
@@ -12634,7 +13018,7 @@
         <p:spPr>
           <a:xfrm>
             <a:off x="1143000" y="1600200"/>
-            <a:ext cx="7040880" cy="1371600"/>
+            <a:ext cx="7155180" cy="1371600"/>
           </a:xfrm>
           <a:prstGeom prst="rect">
             <a:avLst/>
@@ -12675,7 +13059,51 @@
                 <a:ea typeface="Trebuchet MS" pitchFamily="34" charset="-122"/>
                 <a:cs typeface="Trebuchet MS" pitchFamily="34" charset="-120"/>
               </a:rPr>
-              <a:t>Y si no medimos, no podemos mejorar.”</a:t>
+              <a:t>Y si no medimos, no </a:t>
+            </a:r>
+            <a:r>
+              <a:rPr lang="en-US" sz="3000" b="1" dirty="0" err="1">
+                <a:solidFill>
+                  <a:srgbClr val="0B3C5D"/>
+                </a:solidFill>
+                <a:latin typeface="Trebuchet MS" pitchFamily="34" charset="0"/>
+                <a:ea typeface="Trebuchet MS" pitchFamily="34" charset="-122"/>
+                <a:cs typeface="Trebuchet MS" pitchFamily="34" charset="-120"/>
+              </a:rPr>
+              <a:t>podemos</a:t>
+            </a:r>
+            <a:r>
+              <a:rPr lang="en-US" sz="3000" b="1" dirty="0">
+                <a:solidFill>
+                  <a:srgbClr val="0B3C5D"/>
+                </a:solidFill>
+                <a:latin typeface="Trebuchet MS" pitchFamily="34" charset="0"/>
+                <a:ea typeface="Trebuchet MS" pitchFamily="34" charset="-122"/>
+                <a:cs typeface="Trebuchet MS" pitchFamily="34" charset="-120"/>
+              </a:rPr>
+              <a:t> </a:t>
+            </a:r>
+            <a:r>
+              <a:rPr lang="en-US" sz="3000" b="1" dirty="0" err="1">
+                <a:solidFill>
+                  <a:srgbClr val="0B3C5D"/>
+                </a:solidFill>
+                <a:latin typeface="Trebuchet MS" pitchFamily="34" charset="0"/>
+                <a:ea typeface="Trebuchet MS" pitchFamily="34" charset="-122"/>
+                <a:cs typeface="Trebuchet MS" pitchFamily="34" charset="-120"/>
+              </a:rPr>
+              <a:t>mejorar</a:t>
+            </a:r>
+            <a:r>
+              <a:rPr lang="en-US" sz="3000" b="1" dirty="0">
+                <a:solidFill>
+                  <a:srgbClr val="0B3C5D"/>
+                </a:solidFill>
+                <a:latin typeface="Trebuchet MS" pitchFamily="34" charset="0"/>
+                <a:ea typeface="Trebuchet MS" pitchFamily="34" charset="-122"/>
+                <a:cs typeface="Trebuchet MS" pitchFamily="34" charset="-120"/>
+              </a:rPr>
+              <a:t>.”</a:t>
             </a:r>
             <a:endParaRPr lang="en-US" sz="3000" dirty="0"/>
           </a:p>
@@ -12986,7 +13414,29 @@
                 <a:ea typeface="Trebuchet MS" pitchFamily="34" charset="-122"/>
                 <a:cs typeface="Trebuchet MS" pitchFamily="34" charset="-120"/>
               </a:rPr>
-              <a:t>Cuatro puertas, una por audiencia</a:t>
+              <a:t>Cuatro </a:t>
+            </a:r>
+            <a:r>
+              <a:rPr lang="en-US" sz="2700" b="1" dirty="0" err="1">
+                <a:solidFill>
+                  <a:srgbClr val="0B3C5D"/>
+                </a:solidFill>
+                <a:latin typeface="Trebuchet MS" pitchFamily="34" charset="0"/>
+                <a:ea typeface="Trebuchet MS" pitchFamily="34" charset="-122"/>
+                <a:cs typeface="Trebuchet MS" pitchFamily="34" charset="-120"/>
+              </a:rPr>
+              <a:t>ejes</a:t>
+            </a:r>
+            <a:r>
+              <a:rPr lang="en-US" sz="2700" b="1" dirty="0">
+                <a:solidFill>
+                  <a:srgbClr val="0B3C5D"/>
+                </a:solidFill>
+                <a:latin typeface="Trebuchet MS" pitchFamily="34" charset="0"/>
+                <a:ea typeface="Trebuchet MS" pitchFamily="34" charset="-122"/>
+                <a:cs typeface="Trebuchet MS" pitchFamily="34" charset="-120"/>
+              </a:rPr>
+              <a:t>, uno por audiencia</a:t>
             </a:r>
             <a:endParaRPr lang="en-US" sz="2700" dirty="0"/>
           </a:p>
@@ -13212,20 +13662,20 @@
         </p:nvSpPr>
         <p:spPr>
           <a:xfrm>
-            <a:off x="630936" y="2423160"/>
-            <a:ext cx="1607058" cy="1188720"/>
-          </a:xfrm>
-          <a:prstGeom prst="rect">
-            <a:avLst/>
-          </a:prstGeom>
-          <a:noFill/>
-          <a:ln/>
-        </p:spPr>
-        <p:txBody>
-          <a:bodyPr wrap="square" lIns="0" tIns="0" rIns="0" bIns="0" rtlCol="0" anchor="ctr"/>
-          <a:lstStyle/>
-          <a:p>
-            <a:pPr marL="0" indent="0">
+            <a:off x="567328" y="2423160"/>
+            <a:ext cx="1735074" cy="1188720"/>
+          </a:xfrm>
+          <a:prstGeom prst="rect">
+            <a:avLst/>
+          </a:prstGeom>
+          <a:noFill/>
+          <a:ln/>
+        </p:spPr>
+        <p:txBody>
+          <a:bodyPr wrap="square" lIns="0" tIns="0" rIns="0" bIns="0" rtlCol="0" anchor="ctr"/>
+          <a:lstStyle/>
+          <a:p>
+            <a:pPr marL="0" indent="0" algn="ctr">
               <a:buNone/>
             </a:pPr>
             <a:r>
@@ -13507,20 +13957,20 @@
         </p:nvSpPr>
         <p:spPr>
           <a:xfrm>
-            <a:off x="2722626" y="2423160"/>
-            <a:ext cx="1607058" cy="1188720"/>
-          </a:xfrm>
-          <a:prstGeom prst="rect">
-            <a:avLst/>
-          </a:prstGeom>
-          <a:noFill/>
-          <a:ln/>
-        </p:spPr>
-        <p:txBody>
-          <a:bodyPr wrap="square" lIns="0" tIns="0" rIns="0" bIns="0" rtlCol="0" anchor="ctr"/>
-          <a:lstStyle/>
-          <a:p>
-            <a:pPr marL="0" indent="0">
+            <a:off x="2659018" y="2423160"/>
+            <a:ext cx="1735074" cy="1188720"/>
+          </a:xfrm>
+          <a:prstGeom prst="rect">
+            <a:avLst/>
+          </a:prstGeom>
+          <a:noFill/>
+          <a:ln/>
+        </p:spPr>
+        <p:txBody>
+          <a:bodyPr wrap="square" lIns="0" tIns="0" rIns="0" bIns="0" rtlCol="0" anchor="ctr"/>
+          <a:lstStyle/>
+          <a:p>
+            <a:pPr marL="0" indent="0" algn="ctr">
               <a:buNone/>
             </a:pPr>
             <a:r>
@@ -13890,20 +14340,20 @@
         </p:nvSpPr>
         <p:spPr>
           <a:xfrm>
-            <a:off x="4814316" y="2423160"/>
-            <a:ext cx="1607058" cy="1188720"/>
-          </a:xfrm>
-          <a:prstGeom prst="rect">
-            <a:avLst/>
-          </a:prstGeom>
-          <a:noFill/>
-          <a:ln/>
-        </p:spPr>
-        <p:txBody>
-          <a:bodyPr wrap="square" lIns="0" tIns="0" rIns="0" bIns="0" rtlCol="0" anchor="ctr"/>
-          <a:lstStyle/>
-          <a:p>
-            <a:pPr marL="0" indent="0">
+            <a:off x="4750708" y="2423160"/>
+            <a:ext cx="1735074" cy="1188720"/>
+          </a:xfrm>
+          <a:prstGeom prst="rect">
+            <a:avLst/>
+          </a:prstGeom>
+          <a:noFill/>
+          <a:ln/>
+        </p:spPr>
+        <p:txBody>
+          <a:bodyPr wrap="square" lIns="0" tIns="0" rIns="0" bIns="0" rtlCol="0" anchor="ctr"/>
+          <a:lstStyle/>
+          <a:p>
+            <a:pPr marL="0" indent="0" algn="ctr">
               <a:buNone/>
             </a:pPr>
             <a:r>
@@ -14295,20 +14745,20 @@
         </p:nvSpPr>
         <p:spPr>
           <a:xfrm>
-            <a:off x="6906006" y="2423160"/>
-            <a:ext cx="1607058" cy="1188720"/>
-          </a:xfrm>
-          <a:prstGeom prst="rect">
-            <a:avLst/>
-          </a:prstGeom>
-          <a:noFill/>
-          <a:ln/>
-        </p:spPr>
-        <p:txBody>
-          <a:bodyPr wrap="square" lIns="0" tIns="0" rIns="0" bIns="0" rtlCol="0" anchor="ctr"/>
-          <a:lstStyle/>
-          <a:p>
-            <a:pPr marL="0" indent="0">
+            <a:off x="6842398" y="2423160"/>
+            <a:ext cx="1735074" cy="1188720"/>
+          </a:xfrm>
+          <a:prstGeom prst="rect">
+            <a:avLst/>
+          </a:prstGeom>
+          <a:noFill/>
+          <a:ln/>
+        </p:spPr>
+        <p:txBody>
+          <a:bodyPr wrap="square" lIns="0" tIns="0" rIns="0" bIns="0" rtlCol="0" anchor="ctr"/>
+          <a:lstStyle/>
+          <a:p>
+            <a:pPr marL="0" indent="0" algn="ctr">
               <a:buNone/>
             </a:pPr>
             <a:r>
@@ -14572,107 +15022,24 @@
       </p:grpSpPr>
       <p:sp>
         <p:nvSpPr>
-          <p:cNvPr id="2" name="Text 0"/>
-          <p:cNvSpPr/>
-          <p:nvPr/>
-        </p:nvSpPr>
-        <p:spPr>
-          <a:xfrm>
-            <a:off x="502920" y="292608"/>
-            <a:ext cx="8138160" cy="256032"/>
-          </a:xfrm>
-          <a:prstGeom prst="rect">
-            <a:avLst/>
-          </a:prstGeom>
-          <a:noFill/>
-          <a:ln/>
-        </p:spPr>
-        <p:txBody>
-          <a:bodyPr wrap="square" lIns="0" tIns="0" rIns="0" bIns="0" rtlCol="0" anchor="ctr"/>
-          <a:lstStyle/>
-          <a:p>
-            <a:pPr marL="0" indent="0">
-              <a:buNone/>
-            </a:pPr>
-            <a:r>
-              <a:rPr lang="en-US" sz="1100" b="1" kern="0" spc="200" dirty="0">
-                <a:solidFill>
-                  <a:srgbClr val="1ABC9C"/>
-                </a:solidFill>
-                <a:latin typeface="Trebuchet MS" pitchFamily="34" charset="0"/>
-                <a:ea typeface="Trebuchet MS" pitchFamily="34" charset="-122"/>
-                <a:cs typeface="Trebuchet MS" pitchFamily="34" charset="-120"/>
-              </a:rPr>
-              <a:t>DEMO 1/3 · INICIO</a:t>
-            </a:r>
-            <a:endParaRPr lang="en-US" sz="1100" dirty="0"/>
-          </a:p>
-        </p:txBody>
-      </p:sp>
-      <p:sp>
-        <p:nvSpPr>
-          <p:cNvPr id="3" name="Text 1"/>
-          <p:cNvSpPr/>
-          <p:nvPr/>
-        </p:nvSpPr>
-        <p:spPr>
-          <a:xfrm>
-            <a:off x="502920" y="548640"/>
-            <a:ext cx="8138160" cy="502920"/>
-          </a:xfrm>
-          <a:prstGeom prst="rect">
-            <a:avLst/>
-          </a:prstGeom>
-          <a:noFill/>
-          <a:ln/>
-        </p:spPr>
-        <p:txBody>
-          <a:bodyPr wrap="square" lIns="0" tIns="0" rIns="0" bIns="0" rtlCol="0" anchor="ctr"/>
-          <a:lstStyle/>
-          <a:p>
-            <a:pPr marL="0" indent="0">
-              <a:buNone/>
-            </a:pPr>
-            <a:r>
-              <a:rPr lang="en-US" sz="2700" b="1" dirty="0">
-                <a:solidFill>
-                  <a:srgbClr val="0B3C5D"/>
-                </a:solidFill>
-                <a:latin typeface="Trebuchet MS" pitchFamily="34" charset="0"/>
-                <a:ea typeface="Trebuchet MS" pitchFamily="34" charset="-122"/>
-                <a:cs typeface="Trebuchet MS" pitchFamily="34" charset="-120"/>
-              </a:rPr>
-              <a:t>El panorama en vivo y </a:t>
-            </a:r>
-            <a:r>
-              <a:rPr lang="en-US" sz="2700" b="1" dirty="0" err="1">
-                <a:solidFill>
-                  <a:srgbClr val="0B3C5D"/>
-                </a:solidFill>
-                <a:latin typeface="Trebuchet MS" pitchFamily="34" charset="0"/>
-                <a:ea typeface="Trebuchet MS" pitchFamily="34" charset="-122"/>
-                <a:cs typeface="Trebuchet MS" pitchFamily="34" charset="-120"/>
-              </a:rPr>
-              <a:t>actualizado</a:t>
-            </a:r>
-            <a:endParaRPr lang="en-US" sz="2700" dirty="0"/>
-          </a:p>
-        </p:txBody>
-      </p:sp>
-      <p:sp>
-        <p:nvSpPr>
-          <p:cNvPr id="4" name="Shape 2"/>
-          <p:cNvSpPr/>
-          <p:nvPr/>
-        </p:nvSpPr>
-        <p:spPr>
-          <a:xfrm>
-            <a:off x="502920" y="1298448"/>
-            <a:ext cx="1863090" cy="960120"/>
+          <p:cNvPr id="33" name="Shape 18">
+            <a:extLst>
+              <a:ext uri="{FF2B5EF4-FFF2-40B4-BE49-F238E27FC236}">
+                <a16:creationId xmlns:a16="http://schemas.microsoft.com/office/drawing/2014/main" id="{CA3467CC-6346-9801-245E-EBC9A6CF3A00}"/>
+              </a:ext>
+            </a:extLst>
+          </p:cNvPr>
+          <p:cNvSpPr/>
+          <p:nvPr/>
+        </p:nvSpPr>
+        <p:spPr>
+          <a:xfrm>
+            <a:off x="502920" y="3954780"/>
+            <a:ext cx="8138160" cy="774954"/>
           </a:xfrm>
           <a:prstGeom prst="roundRect">
             <a:avLst>
-              <a:gd name="adj" fmla="val 5714"/>
+              <a:gd name="adj" fmla="val 3871"/>
             </a:avLst>
           </a:prstGeom>
           <a:solidFill>
@@ -14690,111 +15057,102 @@
       </p:sp>
       <p:sp>
         <p:nvSpPr>
-          <p:cNvPr id="5" name="Shape 3"/>
-          <p:cNvSpPr/>
-          <p:nvPr/>
-        </p:nvSpPr>
-        <p:spPr>
-          <a:xfrm>
-            <a:off x="502920" y="1298448"/>
-            <a:ext cx="1863090" cy="64008"/>
-          </a:xfrm>
-          <a:prstGeom prst="rect">
-            <a:avLst/>
-          </a:prstGeom>
-          <a:solidFill>
-            <a:srgbClr val="0B3C5D"/>
-          </a:solidFill>
-          <a:ln/>
-        </p:spPr>
-      </p:sp>
-      <p:sp>
-        <p:nvSpPr>
-          <p:cNvPr id="6" name="Text 4"/>
-          <p:cNvSpPr/>
-          <p:nvPr/>
-        </p:nvSpPr>
-        <p:spPr>
-          <a:xfrm>
-            <a:off x="502920" y="1399032"/>
-            <a:ext cx="1863090" cy="457200"/>
-          </a:xfrm>
-          <a:prstGeom prst="rect">
-            <a:avLst/>
-          </a:prstGeom>
-          <a:noFill/>
-          <a:ln/>
-        </p:spPr>
-        <p:txBody>
-          <a:bodyPr wrap="square" lIns="0" tIns="0" rIns="0" bIns="0" rtlCol="0" anchor="ctr"/>
-          <a:lstStyle/>
-          <a:p>
-            <a:pPr marL="0" indent="0" algn="ctr">
-              <a:buNone/>
-            </a:pPr>
-            <a:r>
-              <a:rPr lang="en-US" sz="2600" b="1" dirty="0">
-                <a:solidFill>
-                  <a:srgbClr val="0B3C5D"/>
+          <p:cNvPr id="2" name="Text 0"/>
+          <p:cNvSpPr/>
+          <p:nvPr/>
+        </p:nvSpPr>
+        <p:spPr>
+          <a:xfrm>
+            <a:off x="502920" y="292608"/>
+            <a:ext cx="8138160" cy="256032"/>
+          </a:xfrm>
+          <a:prstGeom prst="rect">
+            <a:avLst/>
+          </a:prstGeom>
+          <a:noFill/>
+          <a:ln/>
+        </p:spPr>
+        <p:txBody>
+          <a:bodyPr wrap="square" lIns="0" tIns="0" rIns="0" bIns="0" rtlCol="0" anchor="ctr"/>
+          <a:lstStyle/>
+          <a:p>
+            <a:pPr marL="0" indent="0">
+              <a:buNone/>
+            </a:pPr>
+            <a:r>
+              <a:rPr lang="en-US" sz="1100" b="1" kern="0" spc="200" dirty="0">
+                <a:solidFill>
+                  <a:srgbClr val="1ABC9C"/>
                 </a:solidFill>
                 <a:latin typeface="Trebuchet MS" pitchFamily="34" charset="0"/>
                 <a:ea typeface="Trebuchet MS" pitchFamily="34" charset="-122"/>
                 <a:cs typeface="Trebuchet MS" pitchFamily="34" charset="-120"/>
               </a:rPr>
-              <a:t>25.234</a:t>
-            </a:r>
-            <a:endParaRPr lang="en-US" sz="2600" dirty="0"/>
-          </a:p>
-        </p:txBody>
-      </p:sp>
-      <p:sp>
-        <p:nvSpPr>
-          <p:cNvPr id="7" name="Text 5"/>
-          <p:cNvSpPr/>
-          <p:nvPr/>
-        </p:nvSpPr>
-        <p:spPr>
-          <a:xfrm>
-            <a:off x="548640" y="1874520"/>
-            <a:ext cx="1771650" cy="320040"/>
-          </a:xfrm>
-          <a:prstGeom prst="rect">
-            <a:avLst/>
-          </a:prstGeom>
-          <a:noFill/>
-          <a:ln/>
-        </p:spPr>
-        <p:txBody>
-          <a:bodyPr wrap="square" lIns="0" tIns="0" rIns="0" bIns="0" rtlCol="0" anchor="ctr"/>
-          <a:lstStyle/>
-          <a:p>
-            <a:pPr marL="0" indent="0" algn="ctr">
-              <a:buNone/>
-            </a:pPr>
-            <a:r>
-              <a:rPr lang="en-US" sz="950" dirty="0">
-                <a:solidFill>
-                  <a:srgbClr val="7F8C8D"/>
-                </a:solidFill>
-                <a:latin typeface="Calibri" pitchFamily="34" charset="0"/>
-                <a:ea typeface="Calibri" pitchFamily="34" charset="-122"/>
-                <a:cs typeface="Calibri" pitchFamily="34" charset="-120"/>
-              </a:rPr>
-              <a:t>datasets en el catálogo</a:t>
-            </a:r>
-            <a:endParaRPr lang="en-US" sz="950" dirty="0"/>
-          </a:p>
-        </p:txBody>
-      </p:sp>
-      <p:sp>
-        <p:nvSpPr>
-          <p:cNvPr id="8" name="Shape 6"/>
-          <p:cNvSpPr/>
-          <p:nvPr/>
-        </p:nvSpPr>
-        <p:spPr>
-          <a:xfrm>
-            <a:off x="2594610" y="1298448"/>
+              <a:t>DEMO 1/3 · INICIO</a:t>
+            </a:r>
+            <a:endParaRPr lang="en-US" sz="1100" dirty="0"/>
+          </a:p>
+        </p:txBody>
+      </p:sp>
+      <p:sp>
+        <p:nvSpPr>
+          <p:cNvPr id="3" name="Text 1"/>
+          <p:cNvSpPr/>
+          <p:nvPr/>
+        </p:nvSpPr>
+        <p:spPr>
+          <a:xfrm>
+            <a:off x="502920" y="548640"/>
+            <a:ext cx="8138160" cy="502920"/>
+          </a:xfrm>
+          <a:prstGeom prst="rect">
+            <a:avLst/>
+          </a:prstGeom>
+          <a:noFill/>
+          <a:ln/>
+        </p:spPr>
+        <p:txBody>
+          <a:bodyPr wrap="square" lIns="0" tIns="0" rIns="0" bIns="0" rtlCol="0" anchor="ctr"/>
+          <a:lstStyle/>
+          <a:p>
+            <a:pPr marL="0" indent="0">
+              <a:buNone/>
+            </a:pPr>
+            <a:r>
+              <a:rPr lang="en-US" sz="2700" b="1" dirty="0">
+                <a:solidFill>
+                  <a:srgbClr val="0B3C5D"/>
+                </a:solidFill>
+                <a:latin typeface="Trebuchet MS" pitchFamily="34" charset="0"/>
+                <a:ea typeface="Trebuchet MS" pitchFamily="34" charset="-122"/>
+                <a:cs typeface="Trebuchet MS" pitchFamily="34" charset="-120"/>
+              </a:rPr>
+              <a:t>El panorama en vivo y </a:t>
+            </a:r>
+            <a:r>
+              <a:rPr lang="en-US" sz="2700" b="1" dirty="0" err="1">
+                <a:solidFill>
+                  <a:srgbClr val="0B3C5D"/>
+                </a:solidFill>
+                <a:latin typeface="Trebuchet MS" pitchFamily="34" charset="0"/>
+                <a:ea typeface="Trebuchet MS" pitchFamily="34" charset="-122"/>
+                <a:cs typeface="Trebuchet MS" pitchFamily="34" charset="-120"/>
+              </a:rPr>
+              <a:t>actualizado</a:t>
+            </a:r>
+            <a:endParaRPr lang="en-US" sz="2700" dirty="0"/>
+          </a:p>
+        </p:txBody>
+      </p:sp>
+      <p:sp>
+        <p:nvSpPr>
+          <p:cNvPr id="4" name="Shape 2"/>
+          <p:cNvSpPr/>
+          <p:nvPr/>
+        </p:nvSpPr>
+        <p:spPr>
+          <a:xfrm>
+            <a:off x="502920" y="1298448"/>
             <a:ext cx="1863090" cy="960120"/>
           </a:xfrm>
           <a:prstGeom prst="roundRect">
@@ -14817,13 +15175,13 @@
       </p:sp>
       <p:sp>
         <p:nvSpPr>
-          <p:cNvPr id="9" name="Shape 7"/>
-          <p:cNvSpPr/>
-          <p:nvPr/>
-        </p:nvSpPr>
-        <p:spPr>
-          <a:xfrm>
-            <a:off x="2594610" y="1298448"/>
+          <p:cNvPr id="5" name="Shape 3"/>
+          <p:cNvSpPr/>
+          <p:nvPr/>
+        </p:nvSpPr>
+        <p:spPr>
+          <a:xfrm>
+            <a:off x="502920" y="1298448"/>
             <a:ext cx="1863090" cy="64008"/>
           </a:xfrm>
           <a:prstGeom prst="rect">
@@ -14837,13 +15195,13 @@
       </p:sp>
       <p:sp>
         <p:nvSpPr>
-          <p:cNvPr id="10" name="Text 8"/>
-          <p:cNvSpPr/>
-          <p:nvPr/>
-        </p:nvSpPr>
-        <p:spPr>
-          <a:xfrm>
-            <a:off x="2594610" y="1399032"/>
+          <p:cNvPr id="6" name="Text 4"/>
+          <p:cNvSpPr/>
+          <p:nvPr/>
+        </p:nvSpPr>
+        <p:spPr>
+          <a:xfrm>
+            <a:off x="502920" y="1399032"/>
             <a:ext cx="1863090" cy="457200"/>
           </a:xfrm>
           <a:prstGeom prst="rect">
@@ -14868,7 +15226,7 @@
                 <a:ea typeface="Trebuchet MS" pitchFamily="34" charset="-122"/>
                 <a:cs typeface="Trebuchet MS" pitchFamily="34" charset="-120"/>
               </a:rPr>
-              <a:t>1.423</a:t>
+              <a:t>25.234</a:t>
             </a:r>
             <a:endParaRPr lang="en-US" sz="2600" dirty="0"/>
           </a:p>
@@ -14876,13 +15234,13 @@
       </p:sp>
       <p:sp>
         <p:nvSpPr>
-          <p:cNvPr id="11" name="Text 9"/>
-          <p:cNvSpPr/>
-          <p:nvPr/>
-        </p:nvSpPr>
-        <p:spPr>
-          <a:xfrm>
-            <a:off x="2640330" y="1874520"/>
+          <p:cNvPr id="7" name="Text 5"/>
+          <p:cNvSpPr/>
+          <p:nvPr/>
+        </p:nvSpPr>
+        <p:spPr>
+          <a:xfrm>
+            <a:off x="548640" y="1874520"/>
             <a:ext cx="1771650" cy="320040"/>
           </a:xfrm>
           <a:prstGeom prst="rect">
@@ -14907,7 +15265,7 @@
                 <a:ea typeface="Calibri" pitchFamily="34" charset="-122"/>
                 <a:cs typeface="Calibri" pitchFamily="34" charset="-120"/>
               </a:rPr>
-              <a:t>entidades publicadoras</a:t>
+              <a:t>datasets en el catálogo</a:t>
             </a:r>
             <a:endParaRPr lang="en-US" sz="950" dirty="0"/>
           </a:p>
@@ -14915,13 +15273,13 @@
       </p:sp>
       <p:sp>
         <p:nvSpPr>
-          <p:cNvPr id="12" name="Shape 10"/>
-          <p:cNvSpPr/>
-          <p:nvPr/>
-        </p:nvSpPr>
-        <p:spPr>
-          <a:xfrm>
-            <a:off x="4686300" y="1298448"/>
+          <p:cNvPr id="8" name="Shape 6"/>
+          <p:cNvSpPr/>
+          <p:nvPr/>
+        </p:nvSpPr>
+        <p:spPr>
+          <a:xfrm>
+            <a:off x="2594610" y="1298448"/>
             <a:ext cx="1863090" cy="960120"/>
           </a:xfrm>
           <a:prstGeom prst="roundRect">
@@ -14944,13 +15302,13 @@
       </p:sp>
       <p:sp>
         <p:nvSpPr>
-          <p:cNvPr id="13" name="Shape 11"/>
-          <p:cNvSpPr/>
-          <p:nvPr/>
-        </p:nvSpPr>
-        <p:spPr>
-          <a:xfrm>
-            <a:off x="4686300" y="1298448"/>
+          <p:cNvPr id="9" name="Shape 7"/>
+          <p:cNvSpPr/>
+          <p:nvPr/>
+        </p:nvSpPr>
+        <p:spPr>
+          <a:xfrm>
+            <a:off x="2594610" y="1298448"/>
             <a:ext cx="1863090" cy="64008"/>
           </a:xfrm>
           <a:prstGeom prst="rect">
@@ -14964,13 +15322,13 @@
       </p:sp>
       <p:sp>
         <p:nvSpPr>
-          <p:cNvPr id="14" name="Text 12"/>
-          <p:cNvSpPr/>
-          <p:nvPr/>
-        </p:nvSpPr>
-        <p:spPr>
-          <a:xfrm>
-            <a:off x="4686300" y="1399032"/>
+          <p:cNvPr id="10" name="Text 8"/>
+          <p:cNvSpPr/>
+          <p:nvPr/>
+        </p:nvSpPr>
+        <p:spPr>
+          <a:xfrm>
+            <a:off x="2594610" y="1399032"/>
             <a:ext cx="1863090" cy="457200"/>
           </a:xfrm>
           <a:prstGeom prst="rect">
@@ -14995,7 +15353,7 @@
                 <a:ea typeface="Trebuchet MS" pitchFamily="34" charset="-122"/>
                 <a:cs typeface="Trebuchet MS" pitchFamily="34" charset="-120"/>
               </a:rPr>
-              <a:t>9 %</a:t>
+              <a:t>1.423</a:t>
             </a:r>
             <a:endParaRPr lang="en-US" sz="2600" dirty="0"/>
           </a:p>
@@ -15003,13 +15361,13 @@
       </p:sp>
       <p:sp>
         <p:nvSpPr>
-          <p:cNvPr id="15" name="Text 13"/>
-          <p:cNvSpPr/>
-          <p:nvPr/>
-        </p:nvSpPr>
-        <p:spPr>
-          <a:xfrm>
-            <a:off x="4732020" y="1874520"/>
+          <p:cNvPr id="11" name="Text 9"/>
+          <p:cNvSpPr/>
+          <p:nvPr/>
+        </p:nvSpPr>
+        <p:spPr>
+          <a:xfrm>
+            <a:off x="2640330" y="1874520"/>
             <a:ext cx="1771650" cy="320040"/>
           </a:xfrm>
           <a:prstGeom prst="rect">
@@ -15034,7 +15392,7 @@
                 <a:ea typeface="Calibri" pitchFamily="34" charset="-122"/>
                 <a:cs typeface="Calibri" pitchFamily="34" charset="-120"/>
               </a:rPr>
-              <a:t>actualizados al día</a:t>
+              <a:t>entidades publicadoras</a:t>
             </a:r>
             <a:endParaRPr lang="en-US" sz="950" dirty="0"/>
           </a:p>
@@ -15042,13 +15400,13 @@
       </p:sp>
       <p:sp>
         <p:nvSpPr>
-          <p:cNvPr id="16" name="Shape 14"/>
-          <p:cNvSpPr/>
-          <p:nvPr/>
-        </p:nvSpPr>
-        <p:spPr>
-          <a:xfrm>
-            <a:off x="6777990" y="1298448"/>
+          <p:cNvPr id="12" name="Shape 10"/>
+          <p:cNvSpPr/>
+          <p:nvPr/>
+        </p:nvSpPr>
+        <p:spPr>
+          <a:xfrm>
+            <a:off x="4686300" y="1298448"/>
             <a:ext cx="1863090" cy="960120"/>
           </a:xfrm>
           <a:prstGeom prst="roundRect">
@@ -15071,13 +15429,13 @@
       </p:sp>
       <p:sp>
         <p:nvSpPr>
-          <p:cNvPr id="17" name="Shape 15"/>
-          <p:cNvSpPr/>
-          <p:nvPr/>
-        </p:nvSpPr>
-        <p:spPr>
-          <a:xfrm>
-            <a:off x="6777990" y="1298448"/>
+          <p:cNvPr id="13" name="Shape 11"/>
+          <p:cNvSpPr/>
+          <p:nvPr/>
+        </p:nvSpPr>
+        <p:spPr>
+          <a:xfrm>
+            <a:off x="4686300" y="1298448"/>
             <a:ext cx="1863090" cy="64008"/>
           </a:xfrm>
           <a:prstGeom prst="rect">
@@ -15091,13 +15449,13 @@
       </p:sp>
       <p:sp>
         <p:nvSpPr>
-          <p:cNvPr id="18" name="Text 16"/>
-          <p:cNvSpPr/>
-          <p:nvPr/>
-        </p:nvSpPr>
-        <p:spPr>
-          <a:xfrm>
-            <a:off x="6777990" y="1399032"/>
+          <p:cNvPr id="14" name="Text 12"/>
+          <p:cNvSpPr/>
+          <p:nvPr/>
+        </p:nvSpPr>
+        <p:spPr>
+          <a:xfrm>
+            <a:off x="4686300" y="1399032"/>
             <a:ext cx="1863090" cy="457200"/>
           </a:xfrm>
           <a:prstGeom prst="rect">
@@ -15122,7 +15480,7 @@
                 <a:ea typeface="Trebuchet MS" pitchFamily="34" charset="-122"/>
                 <a:cs typeface="Trebuchet MS" pitchFamily="34" charset="-120"/>
               </a:rPr>
-              <a:t>59 %</a:t>
+              <a:t>9 %</a:t>
             </a:r>
             <a:endParaRPr lang="en-US" sz="2600" dirty="0"/>
           </a:p>
@@ -15130,13 +15488,13 @@
       </p:sp>
       <p:sp>
         <p:nvSpPr>
-          <p:cNvPr id="19" name="Text 17"/>
-          <p:cNvSpPr/>
-          <p:nvPr/>
-        </p:nvSpPr>
-        <p:spPr>
-          <a:xfrm>
-            <a:off x="6823710" y="1874520"/>
+          <p:cNvPr id="15" name="Text 13"/>
+          <p:cNvSpPr/>
+          <p:nvPr/>
+        </p:nvSpPr>
+        <p:spPr>
+          <a:xfrm>
+            <a:off x="4732020" y="1874520"/>
             <a:ext cx="1771650" cy="320040"/>
           </a:xfrm>
           <a:prstGeom prst="rect">
@@ -15161,7 +15519,7 @@
                 <a:ea typeface="Calibri" pitchFamily="34" charset="-122"/>
                 <a:cs typeface="Calibri" pitchFamily="34" charset="-120"/>
               </a:rPr>
-              <a:t>consultables como tabla</a:t>
+              <a:t>actualizados al día</a:t>
             </a:r>
             <a:endParaRPr lang="en-US" sz="950" dirty="0"/>
           </a:p>
@@ -15169,18 +15527,18 @@
       </p:sp>
       <p:sp>
         <p:nvSpPr>
-          <p:cNvPr id="20" name="Shape 18"/>
-          <p:cNvSpPr/>
-          <p:nvPr/>
-        </p:nvSpPr>
-        <p:spPr>
-          <a:xfrm>
-            <a:off x="502920" y="2450592"/>
-            <a:ext cx="3931920" cy="1417320"/>
+          <p:cNvPr id="16" name="Shape 14"/>
+          <p:cNvSpPr/>
+          <p:nvPr/>
+        </p:nvSpPr>
+        <p:spPr>
+          <a:xfrm>
+            <a:off x="6777990" y="1298448"/>
+            <a:ext cx="1863090" cy="960120"/>
           </a:xfrm>
           <a:prstGeom prst="roundRect">
             <a:avLst>
-              <a:gd name="adj" fmla="val 3871"/>
+              <a:gd name="adj" fmla="val 5714"/>
             </a:avLst>
           </a:prstGeom>
           <a:solidFill>
@@ -15198,152 +15556,140 @@
       </p:sp>
       <p:sp>
         <p:nvSpPr>
-          <p:cNvPr id="21" name="Text 19"/>
-          <p:cNvSpPr/>
-          <p:nvPr/>
-        </p:nvSpPr>
-        <p:spPr>
-          <a:xfrm>
-            <a:off x="704088" y="2578608"/>
-            <a:ext cx="3529584" cy="237744"/>
-          </a:xfrm>
-          <a:prstGeom prst="rect">
-            <a:avLst/>
-          </a:prstGeom>
-          <a:noFill/>
-          <a:ln/>
-        </p:spPr>
-        <p:txBody>
-          <a:bodyPr wrap="square" lIns="0" tIns="0" rIns="0" bIns="0" rtlCol="0" anchor="ctr"/>
-          <a:lstStyle/>
-          <a:p>
-            <a:pPr marL="0" indent="0">
-              <a:buNone/>
-            </a:pPr>
-            <a:r>
-              <a:rPr lang="en-US" sz="1050" b="1" kern="0" spc="100" dirty="0">
-                <a:solidFill>
-                  <a:srgbClr val="1ABC9C"/>
+          <p:cNvPr id="17" name="Shape 15"/>
+          <p:cNvSpPr/>
+          <p:nvPr/>
+        </p:nvSpPr>
+        <p:spPr>
+          <a:xfrm>
+            <a:off x="6777990" y="1298448"/>
+            <a:ext cx="1863090" cy="64008"/>
+          </a:xfrm>
+          <a:prstGeom prst="rect">
+            <a:avLst/>
+          </a:prstGeom>
+          <a:solidFill>
+            <a:srgbClr val="0B3C5D"/>
+          </a:solidFill>
+          <a:ln/>
+        </p:spPr>
+      </p:sp>
+      <p:sp>
+        <p:nvSpPr>
+          <p:cNvPr id="18" name="Text 16"/>
+          <p:cNvSpPr/>
+          <p:nvPr/>
+        </p:nvSpPr>
+        <p:spPr>
+          <a:xfrm>
+            <a:off x="6777990" y="1399032"/>
+            <a:ext cx="1863090" cy="457200"/>
+          </a:xfrm>
+          <a:prstGeom prst="rect">
+            <a:avLst/>
+          </a:prstGeom>
+          <a:noFill/>
+          <a:ln/>
+        </p:spPr>
+        <p:txBody>
+          <a:bodyPr wrap="square" lIns="0" tIns="0" rIns="0" bIns="0" rtlCol="0" anchor="ctr"/>
+          <a:lstStyle/>
+          <a:p>
+            <a:pPr marL="0" indent="0" algn="ctr">
+              <a:buNone/>
+            </a:pPr>
+            <a:r>
+              <a:rPr lang="en-US" sz="2600" b="1" dirty="0">
+                <a:solidFill>
+                  <a:srgbClr val="0B3C5D"/>
                 </a:solidFill>
                 <a:latin typeface="Trebuchet MS" pitchFamily="34" charset="0"/>
                 <a:ea typeface="Trebuchet MS" pitchFamily="34" charset="-122"/>
                 <a:cs typeface="Trebuchet MS" pitchFamily="34" charset="-120"/>
               </a:rPr>
-              <a:t>CÓMO HA CRECIDO EL CATÁLOGO</a:t>
-            </a:r>
-            <a:endParaRPr lang="en-US" sz="1050" dirty="0"/>
-          </a:p>
-        </p:txBody>
-      </p:sp>
-      <p:sp>
-        <p:nvSpPr>
-          <p:cNvPr id="22" name="Text 20"/>
-          <p:cNvSpPr/>
-          <p:nvPr/>
-        </p:nvSpPr>
-        <p:spPr>
-          <a:xfrm>
-            <a:off x="704088" y="2852928"/>
-            <a:ext cx="3529584" cy="274320"/>
-          </a:xfrm>
-          <a:prstGeom prst="rect">
-            <a:avLst/>
-          </a:prstGeom>
-          <a:noFill/>
-          <a:ln/>
-        </p:spPr>
-        <p:txBody>
-          <a:bodyPr wrap="square" lIns="0" tIns="0" rIns="0" bIns="0" rtlCol="0" anchor="ctr"/>
-          <a:lstStyle/>
-          <a:p>
-            <a:pPr marL="0" indent="0">
-              <a:buNone/>
-            </a:pPr>
-            <a:r>
-              <a:rPr lang="en-US" sz="1250" b="1" dirty="0">
-                <a:solidFill>
-                  <a:srgbClr val="0B3C5D"/>
-                </a:solidFill>
-                <a:latin typeface="Calibri" pitchFamily="34" charset="0"/>
-                <a:ea typeface="Calibri" pitchFamily="34" charset="-122"/>
-                <a:cs typeface="Calibri" pitchFamily="34" charset="-120"/>
-              </a:rPr>
-              <a:t>9 datasets</a:t>
-            </a:r>
-            <a:r>
-              <a:rPr lang="en-US" sz="1250" dirty="0">
-                <a:solidFill>
-                  <a:srgbClr val="2C3E50"/>
-                </a:solidFill>
-                <a:latin typeface="Calibri" pitchFamily="34" charset="0"/>
-                <a:ea typeface="Calibri" pitchFamily="34" charset="-122"/>
-                <a:cs typeface="Calibri" pitchFamily="34" charset="-120"/>
-              </a:rPr>
-              <a:t> hasta 2015  →  </a:t>
-            </a:r>
-            <a:r>
-              <a:rPr lang="en-US" sz="1250" b="1" dirty="0">
-                <a:solidFill>
-                  <a:srgbClr val="0B3C5D"/>
-                </a:solidFill>
-                <a:latin typeface="Calibri" pitchFamily="34" charset="0"/>
-                <a:ea typeface="Calibri" pitchFamily="34" charset="-122"/>
-                <a:cs typeface="Calibri" pitchFamily="34" charset="-120"/>
-              </a:rPr>
-              <a:t>25.234 hoy</a:t>
-            </a:r>
-            <a:endParaRPr lang="en-US" sz="1250" dirty="0"/>
-          </a:p>
-        </p:txBody>
-      </p:sp>
-      <p:sp>
-        <p:nvSpPr>
-          <p:cNvPr id="23" name="Text 21"/>
-          <p:cNvSpPr/>
-          <p:nvPr/>
-        </p:nvSpPr>
-        <p:spPr>
-          <a:xfrm>
-            <a:off x="704088" y="3154680"/>
-            <a:ext cx="3529584" cy="594360"/>
-          </a:xfrm>
-          <a:prstGeom prst="rect">
-            <a:avLst/>
-          </a:prstGeom>
-          <a:noFill/>
-          <a:ln/>
-        </p:spPr>
-        <p:txBody>
-          <a:bodyPr wrap="square" lIns="0" tIns="0" rIns="0" bIns="0" rtlCol="0" anchor="ctr"/>
-          <a:lstStyle/>
-          <a:p>
-            <a:pPr marL="0" indent="0">
-              <a:buNone/>
-            </a:pPr>
-            <a:r>
-              <a:rPr lang="en-US" sz="1000" dirty="0">
+              <a:t>0.3 %</a:t>
+            </a:r>
+            <a:endParaRPr lang="en-US" sz="2600" dirty="0"/>
+          </a:p>
+        </p:txBody>
+      </p:sp>
+      <p:sp>
+        <p:nvSpPr>
+          <p:cNvPr id="19" name="Text 17"/>
+          <p:cNvSpPr/>
+          <p:nvPr/>
+        </p:nvSpPr>
+        <p:spPr>
+          <a:xfrm>
+            <a:off x="6823710" y="1874520"/>
+            <a:ext cx="1771650" cy="320040"/>
+          </a:xfrm>
+          <a:prstGeom prst="rect">
+            <a:avLst/>
+          </a:prstGeom>
+          <a:noFill/>
+          <a:ln/>
+        </p:spPr>
+        <p:txBody>
+          <a:bodyPr wrap="square" lIns="0" tIns="0" rIns="0" bIns="0" rtlCol="0" anchor="ctr"/>
+          <a:lstStyle/>
+          <a:p>
+            <a:pPr marL="0" indent="0" algn="ctr">
+              <a:buNone/>
+            </a:pPr>
+            <a:r>
+              <a:rPr lang="en-US" sz="950" dirty="0">
                 <a:solidFill>
                   <a:srgbClr val="7F8C8D"/>
                 </a:solidFill>
                 <a:latin typeface="Calibri" pitchFamily="34" charset="0"/>
-                <a:ea typeface="Calibri" pitchFamily="34" charset="-122"/>
-                <a:cs typeface="Calibri" pitchFamily="34" charset="-120"/>
-              </a:rPr>
-              <a:t>La curva se acelera desde 2023 — la federación de portales territoriales duplicó el catálogo visible en dos años.</a:t>
-            </a:r>
-            <a:endParaRPr lang="en-US" sz="1000" dirty="0"/>
-          </a:p>
-        </p:txBody>
-      </p:sp>
-      <p:sp>
-        <p:nvSpPr>
-          <p:cNvPr id="24" name="Shape 22"/>
-          <p:cNvSpPr/>
-          <p:nvPr/>
-        </p:nvSpPr>
-        <p:spPr>
-          <a:xfrm>
-            <a:off x="4709160" y="2450592"/>
+                <a:cs typeface="Calibri" pitchFamily="34" charset="-120"/>
+              </a:rPr>
+              <a:t>con </a:t>
+            </a:r>
+            <a:r>
+              <a:rPr lang="en-US" sz="950" dirty="0" err="1">
+                <a:solidFill>
+                  <a:srgbClr val="7F8C8D"/>
+                </a:solidFill>
+                <a:latin typeface="Calibri" pitchFamily="34" charset="0"/>
+                <a:cs typeface="Calibri" pitchFamily="34" charset="-120"/>
+              </a:rPr>
+              <a:t>interacción</a:t>
+            </a:r>
+            <a:r>
+              <a:rPr lang="en-US" sz="950" dirty="0">
+                <a:solidFill>
+                  <a:srgbClr val="7F8C8D"/>
+                </a:solidFill>
+                <a:latin typeface="Calibri" pitchFamily="34" charset="0"/>
+                <a:cs typeface="Calibri" pitchFamily="34" charset="-120"/>
+              </a:rPr>
+              <a:t> </a:t>
+            </a:r>
+            <a:r>
+              <a:rPr lang="en-US" sz="950" dirty="0" err="1">
+                <a:solidFill>
+                  <a:srgbClr val="7F8C8D"/>
+                </a:solidFill>
+                <a:latin typeface="Calibri" pitchFamily="34" charset="0"/>
+                <a:cs typeface="Calibri" pitchFamily="34" charset="-120"/>
+              </a:rPr>
+              <a:t>ciudadana</a:t>
+            </a:r>
+            <a:endParaRPr lang="en-US" sz="950" dirty="0"/>
+          </a:p>
+        </p:txBody>
+      </p:sp>
+      <p:sp>
+        <p:nvSpPr>
+          <p:cNvPr id="20" name="Shape 18"/>
+          <p:cNvSpPr/>
+          <p:nvPr/>
+        </p:nvSpPr>
+        <p:spPr>
+          <a:xfrm>
+            <a:off x="502920" y="2450592"/>
             <a:ext cx="3931920" cy="1417320"/>
           </a:xfrm>
           <a:prstGeom prst="roundRect">
@@ -15366,13 +15712,13 @@
       </p:sp>
       <p:sp>
         <p:nvSpPr>
-          <p:cNvPr id="25" name="Text 23"/>
-          <p:cNvSpPr/>
-          <p:nvPr/>
-        </p:nvSpPr>
-        <p:spPr>
-          <a:xfrm>
-            <a:off x="4910328" y="2578608"/>
+          <p:cNvPr id="21" name="Text 19"/>
+          <p:cNvSpPr/>
+          <p:nvPr/>
+        </p:nvSpPr>
+        <p:spPr>
+          <a:xfrm>
+            <a:off x="704088" y="2578608"/>
             <a:ext cx="3529584" cy="237744"/>
           </a:xfrm>
           <a:prstGeom prst="rect">
@@ -15397,6 +15743,174 @@
                 <a:ea typeface="Trebuchet MS" pitchFamily="34" charset="-122"/>
                 <a:cs typeface="Trebuchet MS" pitchFamily="34" charset="-120"/>
               </a:rPr>
+              <a:t>CÓMO HA CRECIDO EL CATÁLOGO</a:t>
+            </a:r>
+            <a:endParaRPr lang="en-US" sz="1050" dirty="0"/>
+          </a:p>
+        </p:txBody>
+      </p:sp>
+      <p:sp>
+        <p:nvSpPr>
+          <p:cNvPr id="22" name="Text 20"/>
+          <p:cNvSpPr/>
+          <p:nvPr/>
+        </p:nvSpPr>
+        <p:spPr>
+          <a:xfrm>
+            <a:off x="704088" y="2852928"/>
+            <a:ext cx="3529584" cy="274320"/>
+          </a:xfrm>
+          <a:prstGeom prst="rect">
+            <a:avLst/>
+          </a:prstGeom>
+          <a:noFill/>
+          <a:ln/>
+        </p:spPr>
+        <p:txBody>
+          <a:bodyPr wrap="square" lIns="0" tIns="0" rIns="0" bIns="0" rtlCol="0" anchor="ctr"/>
+          <a:lstStyle/>
+          <a:p>
+            <a:pPr marL="0" indent="0">
+              <a:buNone/>
+            </a:pPr>
+            <a:r>
+              <a:rPr lang="en-US" sz="1250" b="1" dirty="0">
+                <a:solidFill>
+                  <a:srgbClr val="0B3C5D"/>
+                </a:solidFill>
+                <a:latin typeface="Calibri" pitchFamily="34" charset="0"/>
+                <a:ea typeface="Calibri" pitchFamily="34" charset="-122"/>
+                <a:cs typeface="Calibri" pitchFamily="34" charset="-120"/>
+              </a:rPr>
+              <a:t>9 datasets</a:t>
+            </a:r>
+            <a:r>
+              <a:rPr lang="en-US" sz="1250" dirty="0">
+                <a:solidFill>
+                  <a:srgbClr val="2C3E50"/>
+                </a:solidFill>
+                <a:latin typeface="Calibri" pitchFamily="34" charset="0"/>
+                <a:ea typeface="Calibri" pitchFamily="34" charset="-122"/>
+                <a:cs typeface="Calibri" pitchFamily="34" charset="-120"/>
+              </a:rPr>
+              <a:t> hasta 2015  →  </a:t>
+            </a:r>
+            <a:r>
+              <a:rPr lang="en-US" sz="1250" b="1" dirty="0">
+                <a:solidFill>
+                  <a:srgbClr val="0B3C5D"/>
+                </a:solidFill>
+                <a:latin typeface="Calibri" pitchFamily="34" charset="0"/>
+                <a:ea typeface="Calibri" pitchFamily="34" charset="-122"/>
+                <a:cs typeface="Calibri" pitchFamily="34" charset="-120"/>
+              </a:rPr>
+              <a:t>25.234 hoy</a:t>
+            </a:r>
+            <a:endParaRPr lang="en-US" sz="1250" dirty="0"/>
+          </a:p>
+        </p:txBody>
+      </p:sp>
+      <p:sp>
+        <p:nvSpPr>
+          <p:cNvPr id="23" name="Text 21"/>
+          <p:cNvSpPr/>
+          <p:nvPr/>
+        </p:nvSpPr>
+        <p:spPr>
+          <a:xfrm>
+            <a:off x="704088" y="3154680"/>
+            <a:ext cx="3529584" cy="594360"/>
+          </a:xfrm>
+          <a:prstGeom prst="rect">
+            <a:avLst/>
+          </a:prstGeom>
+          <a:noFill/>
+          <a:ln/>
+        </p:spPr>
+        <p:txBody>
+          <a:bodyPr wrap="square" lIns="0" tIns="0" rIns="0" bIns="0" rtlCol="0" anchor="ctr"/>
+          <a:lstStyle/>
+          <a:p>
+            <a:pPr marL="0" indent="0">
+              <a:buNone/>
+            </a:pPr>
+            <a:r>
+              <a:rPr lang="en-US" sz="1000" dirty="0">
+                <a:solidFill>
+                  <a:srgbClr val="7F8C8D"/>
+                </a:solidFill>
+                <a:latin typeface="Calibri" pitchFamily="34" charset="0"/>
+                <a:ea typeface="Calibri" pitchFamily="34" charset="-122"/>
+                <a:cs typeface="Calibri" pitchFamily="34" charset="-120"/>
+              </a:rPr>
+              <a:t>La curva se acelera desde 2023 — la federación de portales territoriales duplicó el catálogo visible en dos años.</a:t>
+            </a:r>
+            <a:endParaRPr lang="en-US" sz="1000" dirty="0"/>
+          </a:p>
+        </p:txBody>
+      </p:sp>
+      <p:sp>
+        <p:nvSpPr>
+          <p:cNvPr id="24" name="Shape 22"/>
+          <p:cNvSpPr/>
+          <p:nvPr/>
+        </p:nvSpPr>
+        <p:spPr>
+          <a:xfrm>
+            <a:off x="4709160" y="2450592"/>
+            <a:ext cx="3931920" cy="1417320"/>
+          </a:xfrm>
+          <a:prstGeom prst="roundRect">
+            <a:avLst>
+              <a:gd name="adj" fmla="val 3871"/>
+            </a:avLst>
+          </a:prstGeom>
+          <a:solidFill>
+            <a:srgbClr val="FFFFFF"/>
+          </a:solidFill>
+          <a:ln/>
+          <a:effectLst>
+            <a:outerShdw algn="bl" rotWithShape="0">
+              <a:srgbClr val="1A2530">
+                <a:alpha val="0"/>
+              </a:srgbClr>
+            </a:outerShdw>
+          </a:effectLst>
+        </p:spPr>
+      </p:sp>
+      <p:sp>
+        <p:nvSpPr>
+          <p:cNvPr id="25" name="Text 23"/>
+          <p:cNvSpPr/>
+          <p:nvPr/>
+        </p:nvSpPr>
+        <p:spPr>
+          <a:xfrm>
+            <a:off x="4910328" y="2578608"/>
+            <a:ext cx="3529584" cy="237744"/>
+          </a:xfrm>
+          <a:prstGeom prst="rect">
+            <a:avLst/>
+          </a:prstGeom>
+          <a:noFill/>
+          <a:ln/>
+        </p:spPr>
+        <p:txBody>
+          <a:bodyPr wrap="square" lIns="0" tIns="0" rIns="0" bIns="0" rtlCol="0" anchor="ctr"/>
+          <a:lstStyle/>
+          <a:p>
+            <a:pPr marL="0" indent="0">
+              <a:buNone/>
+            </a:pPr>
+            <a:r>
+              <a:rPr lang="en-US" sz="1050" b="1" kern="0" spc="100" dirty="0">
+                <a:solidFill>
+                  <a:srgbClr val="1ABC9C"/>
+                </a:solidFill>
+                <a:latin typeface="Trebuchet MS" pitchFamily="34" charset="0"/>
+                <a:ea typeface="Trebuchet MS" pitchFamily="34" charset="-122"/>
+                <a:cs typeface="Trebuchet MS" pitchFamily="34" charset="-120"/>
+              </a:rPr>
               <a:t>SECTORES Y TERRITORIO</a:t>
             </a:r>
             <a:endParaRPr lang="en-US" sz="1050" dirty="0"/>
@@ -15447,8 +15961,26 @@
                 <a:ea typeface="Calibri" pitchFamily="34" charset="-122"/>
                 <a:cs typeface="Calibri" pitchFamily="34" charset="-120"/>
               </a:rPr>
-              <a:t> lideran por sector. </a:t>
-            </a:r>
+              <a:t> lideran por sector.</a:t>
+            </a:r>
+          </a:p>
+          <a:p>
+            <a:pPr marL="0" indent="0">
+              <a:buNone/>
+            </a:pPr>
+            <a:endParaRPr lang="en-US" sz="1050" dirty="0">
+              <a:solidFill>
+                <a:srgbClr val="2C3E50"/>
+              </a:solidFill>
+              <a:latin typeface="Calibri" pitchFamily="34" charset="0"/>
+              <a:ea typeface="Calibri" pitchFamily="34" charset="-122"/>
+              <a:cs typeface="Calibri" pitchFamily="34" charset="-120"/>
+            </a:endParaRPr>
+          </a:p>
+          <a:p>
+            <a:pPr marL="0" indent="0">
+              <a:buNone/>
+            </a:pPr>
             <a:r>
               <a:rPr lang="en-US" sz="1050" b="1" dirty="0">
                 <a:solidFill>
@@ -15483,7 +16015,7 @@
         </p:nvSpPr>
         <p:spPr>
           <a:xfrm>
-            <a:off x="502920" y="4041648"/>
+            <a:off x="813018" y="4041648"/>
             <a:ext cx="8138160" cy="274320"/>
           </a:xfrm>
           <a:prstGeom prst="rect">
@@ -15588,7 +16120,7 @@
         </p:nvSpPr>
         <p:spPr>
           <a:xfrm>
-            <a:off x="502920" y="4370832"/>
+            <a:off x="820973" y="4370832"/>
             <a:ext cx="8138160" cy="256032"/>
           </a:xfrm>
           <a:prstGeom prst="rect">
@@ -16264,7 +16796,7 @@
               <a:buNone/>
             </a:pPr>
             <a:r>
-              <a:rPr lang="en-US" sz="1400" b="1" dirty="0">
+              <a:rPr lang="en-US" sz="1400" b="1" dirty="0" err="1">
                 <a:solidFill>
                   <a:srgbClr val="0B3C5D"/>
                 </a:solidFill>
@@ -16272,7 +16804,7 @@
                 <a:ea typeface="Trebuchet MS" pitchFamily="34" charset="-122"/>
                 <a:cs typeface="Trebuchet MS" pitchFamily="34" charset="-120"/>
               </a:rPr>
-              <a:t>Territorio DIVIPOLA</a:t>
+              <a:t>Territorio</a:t>
             </a:r>
             <a:endParaRPr lang="en-US" sz="1400" dirty="0"/>
           </a:p>
@@ -16311,7 +16843,95 @@
                 <a:ea typeface="Calibri" pitchFamily="34" charset="-122"/>
                 <a:cs typeface="Calibri" pitchFamily="34" charset="-120"/>
               </a:rPr>
-              <a:t>Mapa con drill de departamento a municipio, con cerca del 89 % de cobertura territorial inferida con IA.</a:t>
+              <a:t>Mapa de árbol del </a:t>
+            </a:r>
+            <a:r>
+              <a:rPr lang="en-US" sz="1000" dirty="0" err="1">
+                <a:solidFill>
+                  <a:srgbClr val="2C3E50"/>
+                </a:solidFill>
+                <a:latin typeface="Calibri" pitchFamily="34" charset="0"/>
+                <a:ea typeface="Calibri" pitchFamily="34" charset="-122"/>
+                <a:cs typeface="Calibri" pitchFamily="34" charset="-120"/>
+              </a:rPr>
+              <a:t>alcance</a:t>
+            </a:r>
+            <a:r>
+              <a:rPr lang="en-US" sz="1000" dirty="0">
+                <a:solidFill>
+                  <a:srgbClr val="2C3E50"/>
+                </a:solidFill>
+                <a:latin typeface="Calibri" pitchFamily="34" charset="0"/>
+                <a:ea typeface="Calibri" pitchFamily="34" charset="-122"/>
+                <a:cs typeface="Calibri" pitchFamily="34" charset="-120"/>
+              </a:rPr>
+              <a:t> de </a:t>
+            </a:r>
+            <a:r>
+              <a:rPr lang="en-US" sz="1000" dirty="0" err="1">
+                <a:solidFill>
+                  <a:srgbClr val="2C3E50"/>
+                </a:solidFill>
+                <a:latin typeface="Calibri" pitchFamily="34" charset="0"/>
+                <a:ea typeface="Calibri" pitchFamily="34" charset="-122"/>
+                <a:cs typeface="Calibri" pitchFamily="34" charset="-120"/>
+              </a:rPr>
+              <a:t>los</a:t>
+            </a:r>
+            <a:r>
+              <a:rPr lang="en-US" sz="1000" dirty="0">
+                <a:solidFill>
+                  <a:srgbClr val="2C3E50"/>
+                </a:solidFill>
+                <a:latin typeface="Calibri" pitchFamily="34" charset="0"/>
+                <a:ea typeface="Calibri" pitchFamily="34" charset="-122"/>
+                <a:cs typeface="Calibri" pitchFamily="34" charset="-120"/>
+              </a:rPr>
+              <a:t> </a:t>
+            </a:r>
+            <a:r>
+              <a:rPr lang="en-US" sz="1000" dirty="0" err="1">
+                <a:solidFill>
+                  <a:srgbClr val="2C3E50"/>
+                </a:solidFill>
+                <a:latin typeface="Calibri" pitchFamily="34" charset="0"/>
+                <a:ea typeface="Calibri" pitchFamily="34" charset="-122"/>
+                <a:cs typeface="Calibri" pitchFamily="34" charset="-120"/>
+              </a:rPr>
+              <a:t>datos</a:t>
+            </a:r>
+            <a:r>
+              <a:rPr lang="en-US" sz="1000" dirty="0">
+                <a:solidFill>
+                  <a:srgbClr val="2C3E50"/>
+                </a:solidFill>
+                <a:latin typeface="Calibri" pitchFamily="34" charset="0"/>
+                <a:ea typeface="Calibri" pitchFamily="34" charset="-122"/>
+                <a:cs typeface="Calibri" pitchFamily="34" charset="-120"/>
+              </a:rPr>
+              <a:t> </a:t>
+            </a:r>
+            <a:r>
+              <a:rPr lang="en-US" sz="1000" dirty="0" err="1">
+                <a:solidFill>
+                  <a:srgbClr val="2C3E50"/>
+                </a:solidFill>
+                <a:latin typeface="Calibri" pitchFamily="34" charset="0"/>
+                <a:ea typeface="Calibri" pitchFamily="34" charset="-122"/>
+                <a:cs typeface="Calibri" pitchFamily="34" charset="-120"/>
+              </a:rPr>
+              <a:t>publicados</a:t>
+            </a:r>
+            <a:r>
+              <a:rPr lang="en-US" sz="1000" dirty="0">
+                <a:solidFill>
+                  <a:srgbClr val="2C3E50"/>
+                </a:solidFill>
+                <a:latin typeface="Calibri" pitchFamily="34" charset="0"/>
+                <a:ea typeface="Calibri" pitchFamily="34" charset="-122"/>
+                <a:cs typeface="Calibri" pitchFamily="34" charset="-120"/>
+              </a:rPr>
+              <a:t>, con cerca del 89 % de cobertura territorial inferida con IA.</a:t>
             </a:r>
             <a:endParaRPr lang="en-US" sz="1000" dirty="0"/>
           </a:p>
@@ -19526,78 +20146,6 @@
               <a:t>Modo voz + narración (Ley 1618)</a:t>
             </a:r>
             <a:endParaRPr kumimoji="0" lang="en-US" sz="950" b="0" i="0" u="none" strike="noStrike" kern="1200" cap="none" spc="0" normalizeH="0" baseline="0" noProof="0" dirty="0">
-              <a:ln>
-                <a:noFill/>
-              </a:ln>
-              <a:solidFill>
-                <a:prstClr val="black"/>
-              </a:solidFill>
-              <a:effectLst/>
-              <a:uLnTx/>
-              <a:uFillTx/>
-              <a:latin typeface="Calibri" panose="020F0502020204030204"/>
-              <a:ea typeface="+mn-ea"/>
-              <a:cs typeface="+mn-cs"/>
-            </a:endParaRPr>
-          </a:p>
-        </p:txBody>
-      </p:sp>
-      <p:sp>
-        <p:nvSpPr>
-          <p:cNvPr id="28" name="Text 26"/>
-          <p:cNvSpPr/>
-          <p:nvPr/>
-        </p:nvSpPr>
-        <p:spPr>
-          <a:xfrm>
-            <a:off x="502920" y="4069080"/>
-            <a:ext cx="8138160" cy="274320"/>
-          </a:xfrm>
-          <a:prstGeom prst="rect">
-            <a:avLst/>
-          </a:prstGeom>
-          <a:noFill/>
-          <a:ln/>
-        </p:spPr>
-        <p:txBody>
-          <a:bodyPr wrap="square" lIns="0" tIns="0" rIns="0" bIns="0" rtlCol="0" anchor="ctr"/>
-          <a:lstStyle/>
-          <a:p>
-            <a:pPr marL="0" marR="0" lvl="0" indent="0" algn="ctr" defTabSz="914400" rtl="0" eaLnBrk="1" fontAlgn="auto" latinLnBrk="0" hangingPunct="1">
-              <a:lnSpc>
-                <a:spcPct val="100000"/>
-              </a:lnSpc>
-              <a:spcBef>
-                <a:spcPts val="0"/>
-              </a:spcBef>
-              <a:spcAft>
-                <a:spcPts val="0"/>
-              </a:spcAft>
-              <a:buClrTx/>
-              <a:buSzTx/>
-              <a:buFontTx/>
-              <a:buNone/>
-              <a:tabLst/>
-              <a:defRPr/>
-            </a:pPr>
-            <a:r>
-              <a:rPr kumimoji="0" lang="en-US" sz="1050" b="0" i="1" u="none" strike="noStrike" kern="1200" cap="none" spc="0" normalizeH="0" baseline="0" noProof="0" dirty="0">
-                <a:ln>
-                  <a:noFill/>
-                </a:ln>
-                <a:solidFill>
-                  <a:srgbClr val="7F97AB"/>
-                </a:solidFill>
-                <a:effectLst/>
-                <a:uLnTx/>
-                <a:uFillTx/>
-                <a:latin typeface="Calibri" pitchFamily="34" charset="0"/>
-                <a:ea typeface="Calibri" pitchFamily="34" charset="-122"/>
-                <a:cs typeface="Calibri" pitchFamily="34" charset="-120"/>
-              </a:rPr>
-              <a:t>~4 minutos · Si la red falla: capturas de respaldo al final de este archivo.</a:t>
-            </a:r>
-            <a:endParaRPr kumimoji="0" lang="en-US" sz="1050" b="0" i="0" u="none" strike="noStrike" kern="1200" cap="none" spc="0" normalizeH="0" baseline="0" noProof="0" dirty="0">
               <a:ln>
                 <a:noFill/>
               </a:ln>

</xml_diff>